<commit_message>
redesign deck with a cover page and charts on every slide
</commit_message>
<xml_diff>
--- a/deck/qcom_nps.pptx
+++ b/deck/qcom_nps.pptx
@@ -11,6 +11,7 @@
     <p:sldId id="259" r:id="rId10"/>
     <p:sldId id="260" r:id="rId11"/>
     <p:sldId id="261" r:id="rId12"/>
+    <p:sldId id="262" r:id="rId13"/>
   </p:sldIdLst>
   <p:sldSz cx="12191695" cy="6858000" type="screen4x3"/>
   <p:notesSz cx="6858000" cy="9144000"/>
@@ -3095,62 +3096,25 @@
       <p:grpSpPr/>
       <p:sp>
         <p:nvSpPr>
-          <p:cNvPr id="2" name="TextBox 1"/>
-          <p:cNvSpPr txBox="1"/>
-          <p:nvPr/>
-        </p:nvSpPr>
-        <p:spPr>
-          <a:xfrm>
-            <a:off x="548640" y="274320"/>
-            <a:ext cx="11064240" cy="1097280"/>
-          </a:xfrm>
-          <a:prstGeom prst="rect">
-            <a:avLst/>
-          </a:prstGeom>
-          <a:noFill/>
-        </p:spPr>
-        <p:txBody>
-          <a:bodyPr wrap="square">
-            <a:spAutoFit/>
-          </a:bodyPr>
-          <a:lstStyle/>
-          <a:p>
-            <a:pPr>
-              <a:spcAft>
-                <a:spcPts val="1000"/>
-              </a:spcAft>
-            </a:pPr>
-            <a:r>
-              <a:rPr sz="2600" b="1">
-                <a:solidFill>
-                  <a:srgbClr val="1F4E79"/>
-                </a:solidFill>
-              </a:rPr>
-              <a:t>Blinkit leads Zepto by 34.5 NPS points in Jul to Sep 2026, and quality and freshness and missing or wrong items explain 10.3 of them</a:t>
-            </a:r>
-          </a:p>
-        </p:txBody>
-      </p:sp>
-      <p:sp>
-        <p:nvSpPr>
-          <p:cNvPr id="3" name="Rectangle 2"/>
+          <p:cNvPr id="2" name="Rectangle 1"/>
           <p:cNvSpPr/>
           <p:nvPr/>
         </p:nvSpPr>
         <p:spPr>
           <a:xfrm>
-            <a:off x="548640" y="1371600"/>
-            <a:ext cx="11064240" cy="36576"/>
+            <a:off x="0" y="0"/>
+            <a:ext cx="12191695" cy="6858000"/>
           </a:xfrm>
           <a:prstGeom prst="rect">
             <a:avLst/>
           </a:prstGeom>
           <a:solidFill>
-            <a:srgbClr val="1F4E79"/>
+            <a:srgbClr val="0F2A43"/>
           </a:solidFill>
           <a:ln>
             <a:noFill/>
           </a:ln>
+          <a:effectLst/>
         </p:spPr>
         <p:style>
           <a:lnRef idx="1">
@@ -3176,14 +3140,58 @@
       </p:sp>
       <p:sp>
         <p:nvSpPr>
+          <p:cNvPr id="3" name="Rectangle 2"/>
+          <p:cNvSpPr/>
+          <p:nvPr/>
+        </p:nvSpPr>
+        <p:spPr>
+          <a:xfrm>
+            <a:off x="731520" y="1417320"/>
+            <a:ext cx="1005840" cy="73152"/>
+          </a:xfrm>
+          <a:prstGeom prst="rect">
+            <a:avLst/>
+          </a:prstGeom>
+          <a:solidFill>
+            <a:srgbClr val="BBD3EA"/>
+          </a:solidFill>
+          <a:ln>
+            <a:noFill/>
+          </a:ln>
+          <a:effectLst/>
+        </p:spPr>
+        <p:style>
+          <a:lnRef idx="1">
+            <a:schemeClr val="accent1"/>
+          </a:lnRef>
+          <a:fillRef idx="3">
+            <a:schemeClr val="accent1"/>
+          </a:fillRef>
+          <a:effectRef idx="2">
+            <a:schemeClr val="accent1"/>
+          </a:effectRef>
+          <a:fontRef idx="minor">
+            <a:schemeClr val="lt1"/>
+          </a:fontRef>
+        </p:style>
+        <p:txBody>
+          <a:bodyPr rtlCol="0" anchor="ctr"/>
+          <a:lstStyle/>
+          <a:p>
+            <a:pPr algn="ctr"/>
+          </a:p>
+        </p:txBody>
+      </p:sp>
+      <p:sp>
+        <p:nvSpPr>
           <p:cNvPr id="4" name="TextBox 3"/>
           <p:cNvSpPr txBox="1"/>
           <p:nvPr/>
         </p:nvSpPr>
         <p:spPr>
           <a:xfrm>
-            <a:off x="548640" y="6400800"/>
-            <a:ext cx="11064240" cy="320040"/>
+            <a:off x="731520" y="1645920"/>
+            <a:ext cx="10515600" cy="1097280"/>
           </a:xfrm>
           <a:prstGeom prst="rect">
             <a:avLst/>
@@ -3198,16 +3206,16 @@
           <a:p>
             <a:pPr>
               <a:spcAft>
-                <a:spcPts val="1000"/>
+                <a:spcPts val="800"/>
               </a:spcAft>
             </a:pPr>
             <a:r>
-              <a:rPr sz="1000" b="0">
-                <a:solidFill>
-                  <a:srgbClr val="777777"/>
+              <a:rPr sz="5000" b="1">
+                <a:solidFill>
+                  <a:srgbClr val="FFFFFF"/>
                 </a:solidFill>
               </a:rPr>
-              <a:t>Source: Google Play reviews, India, English, 1,112,946 reviews, Jan 2025 to Sep 2026; outputs/ in the repo.</a:t>
+              <a:t>Quick-Commerce NPS Benchmark</a:t>
             </a:r>
           </a:p>
         </p:txBody>
@@ -3220,8 +3228,8 @@
         </p:nvSpPr>
         <p:spPr>
           <a:xfrm>
-            <a:off x="548640" y="1645920"/>
-            <a:ext cx="11064240" cy="4572000"/>
+            <a:off x="731520" y="2788920"/>
+            <a:ext cx="10058400" cy="1005840"/>
           </a:xfrm>
           <a:prstGeom prst="rect">
             <a:avLst/>
@@ -3236,61 +3244,282 @@
           <a:p>
             <a:pPr>
               <a:spcAft>
-                <a:spcPts val="1000"/>
+                <a:spcPts val="800"/>
               </a:spcAft>
             </a:pPr>
             <a:r>
-              <a:rPr sz="2200" b="0">
-                <a:solidFill>
-                  <a:srgbClr val="222222"/>
+              <a:rPr sz="2400" b="0">
+                <a:solidFill>
+                  <a:srgbClr val="BBD3EA"/>
                 </a:solidFill>
               </a:rPr>
-              <a:t>NPS proxy, Jul to Sep 2026: Blinkit 44.4 (±0.5), Instamart 43.8 (±1.1), Zepto 10.0 (±1.3).</a:t>
-            </a:r>
-          </a:p>
+              <a:t>What 1.1 million Google Play reviews say about Blinkit, Zepto and Swiggy Instamart</a:t>
+            </a:r>
+          </a:p>
+        </p:txBody>
+      </p:sp>
+      <p:sp>
+        <p:nvSpPr>
+          <p:cNvPr id="6" name="TextBox 5"/>
+          <p:cNvSpPr txBox="1"/>
+          <p:nvPr/>
+        </p:nvSpPr>
+        <p:spPr>
+          <a:xfrm>
+            <a:off x="731520" y="4526280"/>
+            <a:ext cx="3566160" cy="731520"/>
+          </a:xfrm>
+          <a:prstGeom prst="rect">
+            <a:avLst/>
+          </a:prstGeom>
+          <a:noFill/>
+        </p:spPr>
+        <p:txBody>
+          <a:bodyPr wrap="square">
+            <a:spAutoFit/>
+          </a:bodyPr>
+          <a:lstStyle/>
           <a:p>
             <a:pPr>
               <a:spcAft>
-                <a:spcPts val="1000"/>
+                <a:spcPts val="800"/>
               </a:spcAft>
             </a:pPr>
             <a:r>
-              <a:rPr sz="2200" b="0">
-                <a:solidFill>
-                  <a:srgbClr val="222222"/>
+              <a:rPr sz="3600" b="1">
+                <a:solidFill>
+                  <a:srgbClr val="FFFFFF"/>
                 </a:solidFill>
               </a:rPr>
-              <a:t>Of the 34.5 point gap, 14.2 comes from Blinkit's higher share of 5 star reviews and 20.3 from Zepto's heavier detractor complaints.</a:t>
-            </a:r>
-          </a:p>
+              <a:t>1,112,946</a:t>
+            </a:r>
+          </a:p>
+        </p:txBody>
+      </p:sp>
+      <p:sp>
+        <p:nvSpPr>
+          <p:cNvPr id="7" name="TextBox 6"/>
+          <p:cNvSpPr txBox="1"/>
+          <p:nvPr/>
+        </p:nvSpPr>
+        <p:spPr>
+          <a:xfrm>
+            <a:off x="731520" y="5257800"/>
+            <a:ext cx="3383280" cy="731520"/>
+          </a:xfrm>
+          <a:prstGeom prst="rect">
+            <a:avLst/>
+          </a:prstGeom>
+          <a:noFill/>
+        </p:spPr>
+        <p:txBody>
+          <a:bodyPr wrap="square">
+            <a:spAutoFit/>
+          </a:bodyPr>
+          <a:lstStyle/>
           <a:p>
             <a:pPr>
               <a:spcAft>
-                <a:spcPts val="1000"/>
+                <a:spcPts val="800"/>
               </a:spcAft>
             </a:pPr>
             <a:r>
-              <a:rPr sz="2200" b="0">
-                <a:solidFill>
-                  <a:srgbClr val="222222"/>
+              <a:rPr sz="1400" b="0">
+                <a:solidFill>
+                  <a:srgbClr val="BBD3EA"/>
                 </a:solidFill>
               </a:rPr>
-              <a:t>The biggest complaint gaps are quality and freshness (6.0 points), missing or wrong items (4.4) and support and rider behaviour (3.5).</a:t>
-            </a:r>
-          </a:p>
+              <a:t>public reviews, Jan 2025 to Sep 2026</a:t>
+            </a:r>
+          </a:p>
+        </p:txBody>
+      </p:sp>
+      <p:sp>
+        <p:nvSpPr>
+          <p:cNvPr id="8" name="TextBox 7"/>
+          <p:cNvSpPr txBox="1"/>
+          <p:nvPr/>
+        </p:nvSpPr>
+        <p:spPr>
+          <a:xfrm>
+            <a:off x="4480559" y="4526280"/>
+            <a:ext cx="3566160" cy="731520"/>
+          </a:xfrm>
+          <a:prstGeom prst="rect">
+            <a:avLst/>
+          </a:prstGeom>
+          <a:noFill/>
+        </p:spPr>
+        <p:txBody>
+          <a:bodyPr wrap="square">
+            <a:spAutoFit/>
+          </a:bodyPr>
+          <a:lstStyle/>
           <a:p>
             <a:pPr>
               <a:spcAft>
-                <a:spcPts val="1000"/>
+                <a:spcPts val="800"/>
               </a:spcAft>
             </a:pPr>
             <a:r>
-              <a:rPr sz="2200" b="0">
-                <a:solidFill>
-                  <a:srgbClr val="222222"/>
+              <a:rPr sz="3600" b="1">
+                <a:solidFill>
+                  <a:srgbClr val="FFFFFF"/>
                 </a:solidFill>
               </a:rPr>
-              <a:t>The app ranking is the same in 7 of 7 quarters when 3 star reviews count as passive. The first place lead over second is only 0.7 points against a ±1.2 margin, so treat it as a tie.</a:t>
+              <a:t>21,000</a:t>
+            </a:r>
+          </a:p>
+        </p:txBody>
+      </p:sp>
+      <p:sp>
+        <p:nvSpPr>
+          <p:cNvPr id="9" name="TextBox 8"/>
+          <p:cNvSpPr txBox="1"/>
+          <p:nvPr/>
+        </p:nvSpPr>
+        <p:spPr>
+          <a:xfrm>
+            <a:off x="4480559" y="5257800"/>
+            <a:ext cx="3383280" cy="731520"/>
+          </a:xfrm>
+          <a:prstGeom prst="rect">
+            <a:avLst/>
+          </a:prstGeom>
+          <a:noFill/>
+        </p:spPr>
+        <p:txBody>
+          <a:bodyPr wrap="square">
+            <a:spAutoFit/>
+          </a:bodyPr>
+          <a:lstStyle/>
+          <a:p>
+            <a:pPr>
+              <a:spcAft>
+                <a:spcPts val="800"/>
+              </a:spcAft>
+            </a:pPr>
+            <a:r>
+              <a:rPr sz="1400" b="0">
+                <a:solidFill>
+                  <a:srgbClr val="BBD3EA"/>
+                </a:solidFill>
+              </a:rPr>
+              <a:t>detractor reviews tagged to 8 complaint drivers</a:t>
+            </a:r>
+          </a:p>
+        </p:txBody>
+      </p:sp>
+      <p:sp>
+        <p:nvSpPr>
+          <p:cNvPr id="10" name="TextBox 9"/>
+          <p:cNvSpPr txBox="1"/>
+          <p:nvPr/>
+        </p:nvSpPr>
+        <p:spPr>
+          <a:xfrm>
+            <a:off x="8229600" y="4526280"/>
+            <a:ext cx="3566160" cy="731520"/>
+          </a:xfrm>
+          <a:prstGeom prst="rect">
+            <a:avLst/>
+          </a:prstGeom>
+          <a:noFill/>
+        </p:spPr>
+        <p:txBody>
+          <a:bodyPr wrap="square">
+            <a:spAutoFit/>
+          </a:bodyPr>
+          <a:lstStyle/>
+          <a:p>
+            <a:pPr>
+              <a:spcAft>
+                <a:spcPts val="800"/>
+              </a:spcAft>
+            </a:pPr>
+            <a:r>
+              <a:rPr sz="3600" b="1">
+                <a:solidFill>
+                  <a:srgbClr val="FFFFFF"/>
+                </a:solidFill>
+              </a:rPr>
+              <a:t>34.5 points</a:t>
+            </a:r>
+          </a:p>
+        </p:txBody>
+      </p:sp>
+      <p:sp>
+        <p:nvSpPr>
+          <p:cNvPr id="11" name="TextBox 10"/>
+          <p:cNvSpPr txBox="1"/>
+          <p:nvPr/>
+        </p:nvSpPr>
+        <p:spPr>
+          <a:xfrm>
+            <a:off x="8229600" y="5257800"/>
+            <a:ext cx="3383280" cy="731520"/>
+          </a:xfrm>
+          <a:prstGeom prst="rect">
+            <a:avLst/>
+          </a:prstGeom>
+          <a:noFill/>
+        </p:spPr>
+        <p:txBody>
+          <a:bodyPr wrap="square">
+            <a:spAutoFit/>
+          </a:bodyPr>
+          <a:lstStyle/>
+          <a:p>
+            <a:pPr>
+              <a:spcAft>
+                <a:spcPts val="800"/>
+              </a:spcAft>
+            </a:pPr>
+            <a:r>
+              <a:rPr sz="1400" b="0">
+                <a:solidFill>
+                  <a:srgbClr val="BBD3EA"/>
+                </a:solidFill>
+              </a:rPr>
+              <a:t>NPS gap, Blinkit vs Zepto, Jul to Sep 2026</a:t>
+            </a:r>
+          </a:p>
+        </p:txBody>
+      </p:sp>
+      <p:sp>
+        <p:nvSpPr>
+          <p:cNvPr id="12" name="TextBox 11"/>
+          <p:cNvSpPr txBox="1"/>
+          <p:nvPr/>
+        </p:nvSpPr>
+        <p:spPr>
+          <a:xfrm>
+            <a:off x="731520" y="6263640"/>
+            <a:ext cx="10058400" cy="365760"/>
+          </a:xfrm>
+          <a:prstGeom prst="rect">
+            <a:avLst/>
+          </a:prstGeom>
+          <a:noFill/>
+        </p:spPr>
+        <p:txBody>
+          <a:bodyPr wrap="square">
+            <a:spAutoFit/>
+          </a:bodyPr>
+          <a:lstStyle/>
+          <a:p>
+            <a:pPr>
+              <a:spcAft>
+                <a:spcPts val="800"/>
+              </a:spcAft>
+            </a:pPr>
+            <a:r>
+              <a:rPr sz="1300" b="0">
+                <a:solidFill>
+                  <a:srgbClr val="BBD3EA"/>
+                </a:solidFill>
+              </a:rPr>
+              <a:t>Sri Kaasyap Vepa  |  A review based NPS proxy with a 95% margin of error</a:t>
             </a:r>
           </a:p>
         </p:txBody>
@@ -3315,52 +3544,14 @@
       <p:grpSpPr/>
       <p:sp>
         <p:nvSpPr>
-          <p:cNvPr id="2" name="TextBox 1"/>
-          <p:cNvSpPr txBox="1"/>
-          <p:nvPr/>
-        </p:nvSpPr>
-        <p:spPr>
-          <a:xfrm>
-            <a:off x="548640" y="274320"/>
-            <a:ext cx="11064240" cy="1097280"/>
-          </a:xfrm>
-          <a:prstGeom prst="rect">
-            <a:avLst/>
-          </a:prstGeom>
-          <a:noFill/>
-        </p:spPr>
-        <p:txBody>
-          <a:bodyPr wrap="square">
-            <a:spAutoFit/>
-          </a:bodyPr>
-          <a:lstStyle/>
-          <a:p>
-            <a:pPr>
-              <a:spcAft>
-                <a:spcPts val="1000"/>
-              </a:spcAft>
-            </a:pPr>
-            <a:r>
-              <a:rPr sz="2600" b="1">
-                <a:solidFill>
-                  <a:srgbClr val="1F4E79"/>
-                </a:solidFill>
-              </a:rPr>
-              <a:t>Blinkit and Instamart stayed between 34 and 56 NPS points for 21 months while Zepto swung from -25 to 42 and ended at 7</a:t>
-            </a:r>
-          </a:p>
-        </p:txBody>
-      </p:sp>
-      <p:sp>
-        <p:nvSpPr>
-          <p:cNvPr id="3" name="Rectangle 2"/>
+          <p:cNvPr id="2" name="Rectangle 1"/>
           <p:cNvSpPr/>
           <p:nvPr/>
         </p:nvSpPr>
         <p:spPr>
           <a:xfrm>
-            <a:off x="548640" y="1371600"/>
-            <a:ext cx="11064240" cy="36576"/>
+            <a:off x="0" y="0"/>
+            <a:ext cx="228600" cy="6858000"/>
           </a:xfrm>
           <a:prstGeom prst="rect">
             <a:avLst/>
@@ -3371,6 +3562,7 @@
           <a:ln>
             <a:noFill/>
           </a:ln>
+          <a:effectLst/>
         </p:spPr>
         <p:style>
           <a:lnRef idx="1">
@@ -3396,14 +3588,14 @@
       </p:sp>
       <p:sp>
         <p:nvSpPr>
-          <p:cNvPr id="4" name="TextBox 3"/>
+          <p:cNvPr id="3" name="TextBox 2"/>
           <p:cNvSpPr txBox="1"/>
           <p:nvPr/>
         </p:nvSpPr>
         <p:spPr>
           <a:xfrm>
-            <a:off x="548640" y="6400800"/>
-            <a:ext cx="11064240" cy="320040"/>
+            <a:off x="594360" y="274320"/>
+            <a:ext cx="10972800" cy="320040"/>
           </a:xfrm>
           <a:prstGeom prst="rect">
             <a:avLst/>
@@ -3418,23 +3610,547 @@
           <a:p>
             <a:pPr>
               <a:spcAft>
-                <a:spcPts val="1000"/>
+                <a:spcPts val="800"/>
               </a:spcAft>
             </a:pPr>
             <a:r>
+              <a:rPr sz="1200" b="1">
+                <a:solidFill>
+                  <a:srgbClr val="1F4E79"/>
+                </a:solidFill>
+              </a:rPr>
+              <a:t>EXECUTIVE SUMMARY</a:t>
+            </a:r>
+          </a:p>
+        </p:txBody>
+      </p:sp>
+      <p:sp>
+        <p:nvSpPr>
+          <p:cNvPr id="4" name="TextBox 3"/>
+          <p:cNvSpPr txBox="1"/>
+          <p:nvPr/>
+        </p:nvSpPr>
+        <p:spPr>
+          <a:xfrm>
+            <a:off x="594360" y="566928"/>
+            <a:ext cx="11064240" cy="914400"/>
+          </a:xfrm>
+          <a:prstGeom prst="rect">
+            <a:avLst/>
+          </a:prstGeom>
+          <a:noFill/>
+        </p:spPr>
+        <p:txBody>
+          <a:bodyPr wrap="square">
+            <a:spAutoFit/>
+          </a:bodyPr>
+          <a:lstStyle/>
+          <a:p>
+            <a:pPr>
+              <a:spcAft>
+                <a:spcPts val="800"/>
+              </a:spcAft>
+            </a:pPr>
+            <a:r>
+              <a:rPr sz="2400" b="1">
+                <a:solidFill>
+                  <a:srgbClr val="0F2A43"/>
+                </a:solidFill>
+              </a:rPr>
+              <a:t>Blinkit leads Zepto by 34.5 NPS points in Jul to Sep 2026, and quality and freshness and missing or wrong items explain 10.3 of them</a:t>
+            </a:r>
+          </a:p>
+        </p:txBody>
+      </p:sp>
+      <p:sp>
+        <p:nvSpPr>
+          <p:cNvPr id="5" name="Rectangle 4"/>
+          <p:cNvSpPr/>
+          <p:nvPr/>
+        </p:nvSpPr>
+        <p:spPr>
+          <a:xfrm>
+            <a:off x="594360" y="1481328"/>
+            <a:ext cx="11018520" cy="27432"/>
+          </a:xfrm>
+          <a:prstGeom prst="rect">
+            <a:avLst/>
+          </a:prstGeom>
+          <a:solidFill>
+            <a:srgbClr val="BBD3EA"/>
+          </a:solidFill>
+          <a:ln>
+            <a:noFill/>
+          </a:ln>
+          <a:effectLst/>
+        </p:spPr>
+        <p:style>
+          <a:lnRef idx="1">
+            <a:schemeClr val="accent1"/>
+          </a:lnRef>
+          <a:fillRef idx="3">
+            <a:schemeClr val="accent1"/>
+          </a:fillRef>
+          <a:effectRef idx="2">
+            <a:schemeClr val="accent1"/>
+          </a:effectRef>
+          <a:fontRef idx="minor">
+            <a:schemeClr val="lt1"/>
+          </a:fontRef>
+        </p:style>
+        <p:txBody>
+          <a:bodyPr rtlCol="0" anchor="ctr"/>
+          <a:lstStyle/>
+          <a:p>
+            <a:pPr algn="ctr"/>
+          </a:p>
+        </p:txBody>
+      </p:sp>
+      <p:sp>
+        <p:nvSpPr>
+          <p:cNvPr id="6" name="TextBox 5"/>
+          <p:cNvSpPr txBox="1"/>
+          <p:nvPr/>
+        </p:nvSpPr>
+        <p:spPr>
+          <a:xfrm>
+            <a:off x="594360" y="6446520"/>
+            <a:ext cx="9875520" cy="274320"/>
+          </a:xfrm>
+          <a:prstGeom prst="rect">
+            <a:avLst/>
+          </a:prstGeom>
+          <a:noFill/>
+        </p:spPr>
+        <p:txBody>
+          <a:bodyPr wrap="square">
+            <a:spAutoFit/>
+          </a:bodyPr>
+          <a:lstStyle/>
+          <a:p>
+            <a:pPr>
+              <a:spcAft>
+                <a:spcPts val="800"/>
+              </a:spcAft>
+            </a:pPr>
+            <a:r>
               <a:rPr sz="1000" b="0">
                 <a:solidFill>
-                  <a:srgbClr val="777777"/>
+                  <a:srgbClr val="6B7280"/>
                 </a:solidFill>
               </a:rPr>
-              <a:t>Source: Google Play reviews, India, English, 1,112,946 reviews, Jan 2025 to Sep 2026; outputs/ in the repo.</a:t>
+              <a:t>Source: Google Play reviews, India, English, 1,112,946 reviews, Jan 2025 to Sep 2026. Figures from outputs/ in the repo.</a:t>
+            </a:r>
+          </a:p>
+        </p:txBody>
+      </p:sp>
+      <p:sp>
+        <p:nvSpPr>
+          <p:cNvPr id="7" name="TextBox 6"/>
+          <p:cNvSpPr txBox="1"/>
+          <p:nvPr/>
+        </p:nvSpPr>
+        <p:spPr>
+          <a:xfrm>
+            <a:off x="10972800" y="6446520"/>
+            <a:ext cx="640080" cy="274320"/>
+          </a:xfrm>
+          <a:prstGeom prst="rect">
+            <a:avLst/>
+          </a:prstGeom>
+          <a:noFill/>
+        </p:spPr>
+        <p:txBody>
+          <a:bodyPr wrap="square">
+            <a:spAutoFit/>
+          </a:bodyPr>
+          <a:lstStyle/>
+          <a:p>
+            <a:pPr algn="r">
+              <a:spcAft>
+                <a:spcPts val="800"/>
+              </a:spcAft>
+            </a:pPr>
+            <a:r>
+              <a:rPr sz="1000" b="0">
+                <a:solidFill>
+                  <a:srgbClr val="6B7280"/>
+                </a:solidFill>
+              </a:rPr>
+              <a:t>2</a:t>
+            </a:r>
+          </a:p>
+        </p:txBody>
+      </p:sp>
+      <p:sp>
+        <p:nvSpPr>
+          <p:cNvPr id="8" name="Rounded Rectangle 7"/>
+          <p:cNvSpPr/>
+          <p:nvPr/>
+        </p:nvSpPr>
+        <p:spPr>
+          <a:xfrm>
+            <a:off x="594360" y="1691640"/>
+            <a:ext cx="3566160" cy="1234440"/>
+          </a:xfrm>
+          <a:prstGeom prst="roundRect">
+            <a:avLst>
+              <a:gd name="adj" fmla="val 6000"/>
+            </a:avLst>
+          </a:prstGeom>
+          <a:solidFill>
+            <a:srgbClr val="F1F5F9"/>
+          </a:solidFill>
+          <a:ln>
+            <a:noFill/>
+          </a:ln>
+          <a:effectLst/>
+        </p:spPr>
+        <p:style>
+          <a:lnRef idx="1">
+            <a:schemeClr val="accent1"/>
+          </a:lnRef>
+          <a:fillRef idx="3">
+            <a:schemeClr val="accent1"/>
+          </a:fillRef>
+          <a:effectRef idx="2">
+            <a:schemeClr val="accent1"/>
+          </a:effectRef>
+          <a:fontRef idx="minor">
+            <a:schemeClr val="lt1"/>
+          </a:fontRef>
+        </p:style>
+        <p:txBody>
+          <a:bodyPr rtlCol="0" anchor="ctr"/>
+          <a:lstStyle/>
+          <a:p>
+            <a:pPr algn="ctr"/>
+          </a:p>
+        </p:txBody>
+      </p:sp>
+      <p:sp>
+        <p:nvSpPr>
+          <p:cNvPr id="9" name="TextBox 8"/>
+          <p:cNvSpPr txBox="1"/>
+          <p:nvPr/>
+        </p:nvSpPr>
+        <p:spPr>
+          <a:xfrm>
+            <a:off x="777240" y="1755648"/>
+            <a:ext cx="3200400" cy="365760"/>
+          </a:xfrm>
+          <a:prstGeom prst="rect">
+            <a:avLst/>
+          </a:prstGeom>
+          <a:noFill/>
+        </p:spPr>
+        <p:txBody>
+          <a:bodyPr wrap="square">
+            <a:spAutoFit/>
+          </a:bodyPr>
+          <a:lstStyle/>
+          <a:p>
+            <a:pPr>
+              <a:spcAft>
+                <a:spcPts val="800"/>
+              </a:spcAft>
+            </a:pPr>
+            <a:r>
+              <a:rPr sz="1300" b="0">
+                <a:solidFill>
+                  <a:srgbClr val="6B7280"/>
+                </a:solidFill>
+              </a:rPr>
+              <a:t>Blinkit, Jul to Sep 2026</a:t>
+            </a:r>
+          </a:p>
+        </p:txBody>
+      </p:sp>
+      <p:sp>
+        <p:nvSpPr>
+          <p:cNvPr id="10" name="TextBox 9"/>
+          <p:cNvSpPr txBox="1"/>
+          <p:nvPr/>
+        </p:nvSpPr>
+        <p:spPr>
+          <a:xfrm>
+            <a:off x="777240" y="2057400"/>
+            <a:ext cx="3200400" cy="731520"/>
+          </a:xfrm>
+          <a:prstGeom prst="rect">
+            <a:avLst/>
+          </a:prstGeom>
+          <a:noFill/>
+        </p:spPr>
+        <p:txBody>
+          <a:bodyPr wrap="square">
+            <a:spAutoFit/>
+          </a:bodyPr>
+          <a:lstStyle/>
+          <a:p>
+            <a:pPr>
+              <a:spcAft>
+                <a:spcPts val="800"/>
+              </a:spcAft>
+            </a:pPr>
+            <a:r>
+              <a:rPr sz="3200" b="1">
+                <a:solidFill>
+                  <a:srgbClr val="1F4E79"/>
+                </a:solidFill>
+              </a:rPr>
+              <a:t>44.4  (±0.5)</a:t>
+            </a:r>
+          </a:p>
+        </p:txBody>
+      </p:sp>
+      <p:sp>
+        <p:nvSpPr>
+          <p:cNvPr id="11" name="Rounded Rectangle 10"/>
+          <p:cNvSpPr/>
+          <p:nvPr/>
+        </p:nvSpPr>
+        <p:spPr>
+          <a:xfrm>
+            <a:off x="4343400" y="1691640"/>
+            <a:ext cx="3566160" cy="1234440"/>
+          </a:xfrm>
+          <a:prstGeom prst="roundRect">
+            <a:avLst>
+              <a:gd name="adj" fmla="val 6000"/>
+            </a:avLst>
+          </a:prstGeom>
+          <a:solidFill>
+            <a:srgbClr val="F1F5F9"/>
+          </a:solidFill>
+          <a:ln>
+            <a:noFill/>
+          </a:ln>
+          <a:effectLst/>
+        </p:spPr>
+        <p:style>
+          <a:lnRef idx="1">
+            <a:schemeClr val="accent1"/>
+          </a:lnRef>
+          <a:fillRef idx="3">
+            <a:schemeClr val="accent1"/>
+          </a:fillRef>
+          <a:effectRef idx="2">
+            <a:schemeClr val="accent1"/>
+          </a:effectRef>
+          <a:fontRef idx="minor">
+            <a:schemeClr val="lt1"/>
+          </a:fontRef>
+        </p:style>
+        <p:txBody>
+          <a:bodyPr rtlCol="0" anchor="ctr"/>
+          <a:lstStyle/>
+          <a:p>
+            <a:pPr algn="ctr"/>
+          </a:p>
+        </p:txBody>
+      </p:sp>
+      <p:sp>
+        <p:nvSpPr>
+          <p:cNvPr id="12" name="TextBox 11"/>
+          <p:cNvSpPr txBox="1"/>
+          <p:nvPr/>
+        </p:nvSpPr>
+        <p:spPr>
+          <a:xfrm>
+            <a:off x="4526279" y="1755648"/>
+            <a:ext cx="3200400" cy="365760"/>
+          </a:xfrm>
+          <a:prstGeom prst="rect">
+            <a:avLst/>
+          </a:prstGeom>
+          <a:noFill/>
+        </p:spPr>
+        <p:txBody>
+          <a:bodyPr wrap="square">
+            <a:spAutoFit/>
+          </a:bodyPr>
+          <a:lstStyle/>
+          <a:p>
+            <a:pPr>
+              <a:spcAft>
+                <a:spcPts val="800"/>
+              </a:spcAft>
+            </a:pPr>
+            <a:r>
+              <a:rPr sz="1300" b="0">
+                <a:solidFill>
+                  <a:srgbClr val="6B7280"/>
+                </a:solidFill>
+              </a:rPr>
+              <a:t>Instamart, Jul to Sep 2026</a:t>
+            </a:r>
+          </a:p>
+        </p:txBody>
+      </p:sp>
+      <p:sp>
+        <p:nvSpPr>
+          <p:cNvPr id="13" name="TextBox 12"/>
+          <p:cNvSpPr txBox="1"/>
+          <p:nvPr/>
+        </p:nvSpPr>
+        <p:spPr>
+          <a:xfrm>
+            <a:off x="4526279" y="2057400"/>
+            <a:ext cx="3200400" cy="731520"/>
+          </a:xfrm>
+          <a:prstGeom prst="rect">
+            <a:avLst/>
+          </a:prstGeom>
+          <a:noFill/>
+        </p:spPr>
+        <p:txBody>
+          <a:bodyPr wrap="square">
+            <a:spAutoFit/>
+          </a:bodyPr>
+          <a:lstStyle/>
+          <a:p>
+            <a:pPr>
+              <a:spcAft>
+                <a:spcPts val="800"/>
+              </a:spcAft>
+            </a:pPr>
+            <a:r>
+              <a:rPr sz="3200" b="1">
+                <a:solidFill>
+                  <a:srgbClr val="1F4E79"/>
+                </a:solidFill>
+              </a:rPr>
+              <a:t>43.8  (±1.1)</a:t>
+            </a:r>
+          </a:p>
+        </p:txBody>
+      </p:sp>
+      <p:sp>
+        <p:nvSpPr>
+          <p:cNvPr id="14" name="Rounded Rectangle 13"/>
+          <p:cNvSpPr/>
+          <p:nvPr/>
+        </p:nvSpPr>
+        <p:spPr>
+          <a:xfrm>
+            <a:off x="8092440" y="1691640"/>
+            <a:ext cx="3566160" cy="1234440"/>
+          </a:xfrm>
+          <a:prstGeom prst="roundRect">
+            <a:avLst>
+              <a:gd name="adj" fmla="val 6000"/>
+            </a:avLst>
+          </a:prstGeom>
+          <a:solidFill>
+            <a:srgbClr val="F1F5F9"/>
+          </a:solidFill>
+          <a:ln>
+            <a:noFill/>
+          </a:ln>
+          <a:effectLst/>
+        </p:spPr>
+        <p:style>
+          <a:lnRef idx="1">
+            <a:schemeClr val="accent1"/>
+          </a:lnRef>
+          <a:fillRef idx="3">
+            <a:schemeClr val="accent1"/>
+          </a:fillRef>
+          <a:effectRef idx="2">
+            <a:schemeClr val="accent1"/>
+          </a:effectRef>
+          <a:fontRef idx="minor">
+            <a:schemeClr val="lt1"/>
+          </a:fontRef>
+        </p:style>
+        <p:txBody>
+          <a:bodyPr rtlCol="0" anchor="ctr"/>
+          <a:lstStyle/>
+          <a:p>
+            <a:pPr algn="ctr"/>
+          </a:p>
+        </p:txBody>
+      </p:sp>
+      <p:sp>
+        <p:nvSpPr>
+          <p:cNvPr id="15" name="TextBox 14"/>
+          <p:cNvSpPr txBox="1"/>
+          <p:nvPr/>
+        </p:nvSpPr>
+        <p:spPr>
+          <a:xfrm>
+            <a:off x="8275319" y="1755648"/>
+            <a:ext cx="3200400" cy="365760"/>
+          </a:xfrm>
+          <a:prstGeom prst="rect">
+            <a:avLst/>
+          </a:prstGeom>
+          <a:noFill/>
+        </p:spPr>
+        <p:txBody>
+          <a:bodyPr wrap="square">
+            <a:spAutoFit/>
+          </a:bodyPr>
+          <a:lstStyle/>
+          <a:p>
+            <a:pPr>
+              <a:spcAft>
+                <a:spcPts val="800"/>
+              </a:spcAft>
+            </a:pPr>
+            <a:r>
+              <a:rPr sz="1300" b="0">
+                <a:solidFill>
+                  <a:srgbClr val="6B7280"/>
+                </a:solidFill>
+              </a:rPr>
+              <a:t>Zepto, Jul to Sep 2026</a:t>
+            </a:r>
+          </a:p>
+        </p:txBody>
+      </p:sp>
+      <p:sp>
+        <p:nvSpPr>
+          <p:cNvPr id="16" name="TextBox 15"/>
+          <p:cNvSpPr txBox="1"/>
+          <p:nvPr/>
+        </p:nvSpPr>
+        <p:spPr>
+          <a:xfrm>
+            <a:off x="8275319" y="2057400"/>
+            <a:ext cx="3200400" cy="731520"/>
+          </a:xfrm>
+          <a:prstGeom prst="rect">
+            <a:avLst/>
+          </a:prstGeom>
+          <a:noFill/>
+        </p:spPr>
+        <p:txBody>
+          <a:bodyPr wrap="square">
+            <a:spAutoFit/>
+          </a:bodyPr>
+          <a:lstStyle/>
+          <a:p>
+            <a:pPr>
+              <a:spcAft>
+                <a:spcPts val="800"/>
+              </a:spcAft>
+            </a:pPr>
+            <a:r>
+              <a:rPr sz="3200" b="1">
+                <a:solidFill>
+                  <a:srgbClr val="1F4E79"/>
+                </a:solidFill>
+              </a:rPr>
+              <a:t>10.0  (±1.3)</a:t>
             </a:r>
           </a:p>
         </p:txBody>
       </p:sp>
       <p:pic>
         <p:nvPicPr>
-          <p:cNvPr id="5" name="Picture 4" descr="nps_trend.png"/>
+          <p:cNvPr id="17" name="Picture 16" descr="deck_latest.png"/>
           <p:cNvPicPr>
             <a:picLocks noChangeAspect="1"/>
           </p:cNvPicPr>
@@ -3448,14 +4164,82 @@
         </p:blipFill>
         <p:spPr>
           <a:xfrm>
-            <a:off x="1280160" y="1554480"/>
-            <a:ext cx="9509760" cy="4754880"/>
+            <a:off x="594360" y="3108960"/>
+            <a:ext cx="5669280" cy="3366135"/>
           </a:xfrm>
           <a:prstGeom prst="rect">
             <a:avLst/>
           </a:prstGeom>
         </p:spPr>
       </p:pic>
+      <p:sp>
+        <p:nvSpPr>
+          <p:cNvPr id="18" name="TextBox 17"/>
+          <p:cNvSpPr txBox="1"/>
+          <p:nvPr/>
+        </p:nvSpPr>
+        <p:spPr>
+          <a:xfrm>
+            <a:off x="6675120" y="3200400"/>
+            <a:ext cx="4937760" cy="3108960"/>
+          </a:xfrm>
+          <a:prstGeom prst="rect">
+            <a:avLst/>
+          </a:prstGeom>
+          <a:noFill/>
+        </p:spPr>
+        <p:txBody>
+          <a:bodyPr wrap="square">
+            <a:spAutoFit/>
+          </a:bodyPr>
+          <a:lstStyle/>
+          <a:p>
+            <a:pPr>
+              <a:spcAft>
+                <a:spcPts val="800"/>
+              </a:spcAft>
+            </a:pPr>
+            <a:r>
+              <a:rPr sz="1600" b="0">
+                <a:solidFill>
+                  <a:srgbClr val="222222"/>
+                </a:solidFill>
+              </a:rPr>
+              <a:t>The 34.5 point gap: 14.2 from more 5 star reviews at Blinkit, 20.3 from heavier complaints at Zepto.</a:t>
+            </a:r>
+          </a:p>
+          <a:p>
+            <a:pPr>
+              <a:spcAft>
+                <a:spcPts val="800"/>
+              </a:spcAft>
+            </a:pPr>
+            <a:r>
+              <a:rPr sz="1600" b="0">
+                <a:solidFill>
+                  <a:srgbClr val="222222"/>
+                </a:solidFill>
+              </a:rPr>
+              <a:t>Biggest complaint gaps: quality and freshness 6.0, missing or wrong items 4.4, support and rider behaviour 3.5 points.</a:t>
+            </a:r>
+          </a:p>
+          <a:p>
+            <a:pPr>
+              <a:spcAft>
+                <a:spcPts val="800"/>
+              </a:spcAft>
+            </a:pPr>
+            <a:r>
+              <a:rPr sz="1600" b="0">
+                <a:solidFill>
+                  <a:srgbClr val="222222"/>
+                </a:solidFill>
+              </a:rPr>
+              <a:t>The ranking holds in 7 of 7 quarters when 3 stars count as passive. First place leads by 0.7 points against ±1.2, so treat it as a tie.</a:t>
+            </a:r>
+          </a:p>
+        </p:txBody>
+      </p:sp>
     </p:spTree>
   </p:cSld>
   <p:clrMapOvr>
@@ -3476,52 +4260,14 @@
       <p:grpSpPr/>
       <p:sp>
         <p:nvSpPr>
-          <p:cNvPr id="2" name="TextBox 1"/>
-          <p:cNvSpPr txBox="1"/>
-          <p:nvPr/>
-        </p:nvSpPr>
-        <p:spPr>
-          <a:xfrm>
-            <a:off x="548640" y="274320"/>
-            <a:ext cx="11064240" cy="1097280"/>
-          </a:xfrm>
-          <a:prstGeom prst="rect">
-            <a:avLst/>
-          </a:prstGeom>
-          <a:noFill/>
-        </p:spPr>
-        <p:txBody>
-          <a:bodyPr wrap="square">
-            <a:spAutoFit/>
-          </a:bodyPr>
-          <a:lstStyle/>
-          <a:p>
-            <a:pPr>
-              <a:spcAft>
-                <a:spcPts val="1000"/>
-              </a:spcAft>
-            </a:pPr>
-            <a:r>
-              <a:rPr sz="2600" b="1">
-                <a:solidFill>
-                  <a:srgbClr val="1F4E79"/>
-                </a:solidFill>
-              </a:rPr>
-              <a:t>Fees and prices lead the complaints at Blinkit (21%) and Instamart (26%), but quality and freshness lead at Zepto (21%)</a:t>
-            </a:r>
-          </a:p>
-        </p:txBody>
-      </p:sp>
-      <p:sp>
-        <p:nvSpPr>
-          <p:cNvPr id="3" name="Rectangle 2"/>
+          <p:cNvPr id="2" name="Rectangle 1"/>
           <p:cNvSpPr/>
           <p:nvPr/>
         </p:nvSpPr>
         <p:spPr>
           <a:xfrm>
-            <a:off x="548640" y="1371600"/>
-            <a:ext cx="11064240" cy="36576"/>
+            <a:off x="0" y="0"/>
+            <a:ext cx="228600" cy="6858000"/>
           </a:xfrm>
           <a:prstGeom prst="rect">
             <a:avLst/>
@@ -3532,6 +4278,7 @@
           <a:ln>
             <a:noFill/>
           </a:ln>
+          <a:effectLst/>
         </p:spPr>
         <p:style>
           <a:lnRef idx="1">
@@ -3557,14 +4304,14 @@
       </p:sp>
       <p:sp>
         <p:nvSpPr>
-          <p:cNvPr id="4" name="TextBox 3"/>
+          <p:cNvPr id="3" name="TextBox 2"/>
           <p:cNvSpPr txBox="1"/>
           <p:nvPr/>
         </p:nvSpPr>
         <p:spPr>
           <a:xfrm>
-            <a:off x="548640" y="6400800"/>
-            <a:ext cx="11064240" cy="320040"/>
+            <a:off x="594360" y="274320"/>
+            <a:ext cx="10972800" cy="320040"/>
           </a:xfrm>
           <a:prstGeom prst="rect">
             <a:avLst/>
@@ -3579,23 +4326,181 @@
           <a:p>
             <a:pPr>
               <a:spcAft>
-                <a:spcPts val="1000"/>
+                <a:spcPts val="800"/>
               </a:spcAft>
             </a:pPr>
             <a:r>
+              <a:rPr sz="1200" b="1">
+                <a:solidFill>
+                  <a:srgbClr val="1F4E79"/>
+                </a:solidFill>
+              </a:rPr>
+              <a:t>NPS TREND</a:t>
+            </a:r>
+          </a:p>
+        </p:txBody>
+      </p:sp>
+      <p:sp>
+        <p:nvSpPr>
+          <p:cNvPr id="4" name="TextBox 3"/>
+          <p:cNvSpPr txBox="1"/>
+          <p:nvPr/>
+        </p:nvSpPr>
+        <p:spPr>
+          <a:xfrm>
+            <a:off x="594360" y="566928"/>
+            <a:ext cx="11064240" cy="914400"/>
+          </a:xfrm>
+          <a:prstGeom prst="rect">
+            <a:avLst/>
+          </a:prstGeom>
+          <a:noFill/>
+        </p:spPr>
+        <p:txBody>
+          <a:bodyPr wrap="square">
+            <a:spAutoFit/>
+          </a:bodyPr>
+          <a:lstStyle/>
+          <a:p>
+            <a:pPr>
+              <a:spcAft>
+                <a:spcPts val="800"/>
+              </a:spcAft>
+            </a:pPr>
+            <a:r>
+              <a:rPr sz="2400" b="1">
+                <a:solidFill>
+                  <a:srgbClr val="0F2A43"/>
+                </a:solidFill>
+              </a:rPr>
+              <a:t>Blinkit and Instamart stayed between 34 and 56 NPS points for 21 months while Zepto swung from -25 to 42 and ended at 7</a:t>
+            </a:r>
+          </a:p>
+        </p:txBody>
+      </p:sp>
+      <p:sp>
+        <p:nvSpPr>
+          <p:cNvPr id="5" name="Rectangle 4"/>
+          <p:cNvSpPr/>
+          <p:nvPr/>
+        </p:nvSpPr>
+        <p:spPr>
+          <a:xfrm>
+            <a:off x="594360" y="1481328"/>
+            <a:ext cx="11018520" cy="27432"/>
+          </a:xfrm>
+          <a:prstGeom prst="rect">
+            <a:avLst/>
+          </a:prstGeom>
+          <a:solidFill>
+            <a:srgbClr val="BBD3EA"/>
+          </a:solidFill>
+          <a:ln>
+            <a:noFill/>
+          </a:ln>
+          <a:effectLst/>
+        </p:spPr>
+        <p:style>
+          <a:lnRef idx="1">
+            <a:schemeClr val="accent1"/>
+          </a:lnRef>
+          <a:fillRef idx="3">
+            <a:schemeClr val="accent1"/>
+          </a:fillRef>
+          <a:effectRef idx="2">
+            <a:schemeClr val="accent1"/>
+          </a:effectRef>
+          <a:fontRef idx="minor">
+            <a:schemeClr val="lt1"/>
+          </a:fontRef>
+        </p:style>
+        <p:txBody>
+          <a:bodyPr rtlCol="0" anchor="ctr"/>
+          <a:lstStyle/>
+          <a:p>
+            <a:pPr algn="ctr"/>
+          </a:p>
+        </p:txBody>
+      </p:sp>
+      <p:sp>
+        <p:nvSpPr>
+          <p:cNvPr id="6" name="TextBox 5"/>
+          <p:cNvSpPr txBox="1"/>
+          <p:nvPr/>
+        </p:nvSpPr>
+        <p:spPr>
+          <a:xfrm>
+            <a:off x="594360" y="6446520"/>
+            <a:ext cx="9875520" cy="274320"/>
+          </a:xfrm>
+          <a:prstGeom prst="rect">
+            <a:avLst/>
+          </a:prstGeom>
+          <a:noFill/>
+        </p:spPr>
+        <p:txBody>
+          <a:bodyPr wrap="square">
+            <a:spAutoFit/>
+          </a:bodyPr>
+          <a:lstStyle/>
+          <a:p>
+            <a:pPr>
+              <a:spcAft>
+                <a:spcPts val="800"/>
+              </a:spcAft>
+            </a:pPr>
+            <a:r>
               <a:rPr sz="1000" b="0">
                 <a:solidFill>
-                  <a:srgbClr val="777777"/>
+                  <a:srgbClr val="6B7280"/>
                 </a:solidFill>
               </a:rPr>
-              <a:t>Source: Google Play reviews, India, English, 1,112,946 reviews, Jan 2025 to Sep 2026; outputs/ in the repo.</a:t>
+              <a:t>Source: Google Play reviews, India, English, 1,112,946 reviews, Jan 2025 to Sep 2026. Figures from outputs/ in the repo.</a:t>
+            </a:r>
+          </a:p>
+        </p:txBody>
+      </p:sp>
+      <p:sp>
+        <p:nvSpPr>
+          <p:cNvPr id="7" name="TextBox 6"/>
+          <p:cNvSpPr txBox="1"/>
+          <p:nvPr/>
+        </p:nvSpPr>
+        <p:spPr>
+          <a:xfrm>
+            <a:off x="10972800" y="6446520"/>
+            <a:ext cx="640080" cy="274320"/>
+          </a:xfrm>
+          <a:prstGeom prst="rect">
+            <a:avLst/>
+          </a:prstGeom>
+          <a:noFill/>
+        </p:spPr>
+        <p:txBody>
+          <a:bodyPr wrap="square">
+            <a:spAutoFit/>
+          </a:bodyPr>
+          <a:lstStyle/>
+          <a:p>
+            <a:pPr algn="r">
+              <a:spcAft>
+                <a:spcPts val="800"/>
+              </a:spcAft>
+            </a:pPr>
+            <a:r>
+              <a:rPr sz="1000" b="0">
+                <a:solidFill>
+                  <a:srgbClr val="6B7280"/>
+                </a:solidFill>
+              </a:rPr>
+              <a:t>3</a:t>
             </a:r>
           </a:p>
         </p:txBody>
       </p:sp>
       <p:pic>
         <p:nvPicPr>
-          <p:cNvPr id="5" name="Picture 4" descr="driver_mix_latest.png"/>
+          <p:cNvPr id="8" name="Picture 7" descr="deck_trend.png"/>
           <p:cNvPicPr>
             <a:picLocks noChangeAspect="1"/>
           </p:cNvPicPr>
@@ -3609,24 +4514,48 @@
         </p:blipFill>
         <p:spPr>
           <a:xfrm>
-            <a:off x="548640" y="1554480"/>
-            <a:ext cx="7863840" cy="4646815"/>
+            <a:off x="594360" y="1691640"/>
+            <a:ext cx="7315200" cy="4206240"/>
           </a:xfrm>
           <a:prstGeom prst="rect">
             <a:avLst/>
           </a:prstGeom>
         </p:spPr>
       </p:pic>
-      <p:sp>
-        <p:nvSpPr>
-          <p:cNvPr id="6" name="TextBox 5"/>
+      <p:pic>
+        <p:nvPicPr>
+          <p:cNvPr id="9" name="Picture 8" descr="deck_gap.png"/>
+          <p:cNvPicPr>
+            <a:picLocks noChangeAspect="1"/>
+          </p:cNvPicPr>
+          <p:nvPr/>
+        </p:nvPicPr>
+        <p:blipFill>
+          <a:blip r:embed="rId3"/>
+          <a:stretch>
+            <a:fillRect/>
+          </a:stretch>
+        </p:blipFill>
+        <p:spPr>
+          <a:xfrm>
+            <a:off x="8138160" y="1691640"/>
+            <a:ext cx="3474720" cy="3805646"/>
+          </a:xfrm>
+          <a:prstGeom prst="rect">
+            <a:avLst/>
+          </a:prstGeom>
+        </p:spPr>
+      </p:pic>
+      <p:sp>
+        <p:nvSpPr>
+          <p:cNvPr id="10" name="TextBox 9"/>
           <p:cNvSpPr txBox="1"/>
           <p:nvPr/>
         </p:nvSpPr>
         <p:spPr>
           <a:xfrm>
-            <a:off x="8686800" y="1828800"/>
-            <a:ext cx="3108960" cy="4114800"/>
+            <a:off x="8138160" y="5623560"/>
+            <a:ext cx="3474720" cy="731520"/>
           </a:xfrm>
           <a:prstGeom prst="rect">
             <a:avLst/>
@@ -3641,61 +4570,16 @@
           <a:p>
             <a:pPr>
               <a:spcAft>
-                <a:spcPts val="1000"/>
+                <a:spcPts val="800"/>
               </a:spcAft>
             </a:pPr>
             <a:r>
-              <a:rPr sz="1500" b="0">
-                <a:solidFill>
-                  <a:srgbClr val="222222"/>
+              <a:rPr sz="1300" b="0">
+                <a:solidFill>
+                  <a:srgbClr val="6B7280"/>
                 </a:solidFill>
               </a:rPr>
-              <a:t>Top three complaints by share of tagged detractors</a:t>
-            </a:r>
-          </a:p>
-          <a:p>
-            <a:pPr>
-              <a:spcAft>
-                <a:spcPts val="1000"/>
-              </a:spcAft>
-            </a:pPr>
-            <a:r>
-              <a:rPr sz="1500" b="0">
-                <a:solidFill>
-                  <a:srgbClr val="222222"/>
-                </a:solidFill>
-              </a:rPr>
-              <a:t>Blinkit: fees and prices 21%, quality and freshness 13%, support and rider behaviour 12%</a:t>
-            </a:r>
-          </a:p>
-          <a:p>
-            <a:pPr>
-              <a:spcAft>
-                <a:spcPts val="1000"/>
-              </a:spcAft>
-            </a:pPr>
-            <a:r>
-              <a:rPr sz="1500" b="0">
-                <a:solidFill>
-                  <a:srgbClr val="222222"/>
-                </a:solidFill>
-              </a:rPr>
-              <a:t>Instamart: fees and prices 26%, quality and freshness 13%, missing or wrong items 12%</a:t>
-            </a:r>
-          </a:p>
-          <a:p>
-            <a:pPr>
-              <a:spcAft>
-                <a:spcPts val="1000"/>
-              </a:spcAft>
-            </a:pPr>
-            <a:r>
-              <a:rPr sz="1500" b="0">
-                <a:solidFill>
-                  <a:srgbClr val="222222"/>
-                </a:solidFill>
-              </a:rPr>
-              <a:t>Zepto: quality and freshness 21%, missing or wrong items 15%, support and rider behaviour 14%</a:t>
+              <a:t>Best minus worst NPS in each quarter. The gap has not closed.</a:t>
             </a:r>
           </a:p>
         </p:txBody>
@@ -3720,52 +4604,14 @@
       <p:grpSpPr/>
       <p:sp>
         <p:nvSpPr>
-          <p:cNvPr id="2" name="TextBox 1"/>
-          <p:cNvSpPr txBox="1"/>
-          <p:nvPr/>
-        </p:nvSpPr>
-        <p:spPr>
-          <a:xfrm>
-            <a:off x="548640" y="274320"/>
-            <a:ext cx="11064240" cy="1097280"/>
-          </a:xfrm>
-          <a:prstGeom prst="rect">
-            <a:avLst/>
-          </a:prstGeom>
-          <a:noFill/>
-        </p:spPr>
-        <p:txBody>
-          <a:bodyPr wrap="square">
-            <a:spAutoFit/>
-          </a:bodyPr>
-          <a:lstStyle/>
-          <a:p>
-            <a:pPr>
-              <a:spcAft>
-                <a:spcPts val="1000"/>
-              </a:spcAft>
-            </a:pPr>
-            <a:r>
-              <a:rPr sz="2600" b="1">
-                <a:solidFill>
-                  <a:srgbClr val="1F4E79"/>
-                </a:solidFill>
-              </a:rPr>
-              <a:t>Blinkit's 34.5 point lead over Zepto is 14.2 points of 5 star reviews, then 6.0 from quality and freshness and 4.4 from missing or wrong items</a:t>
-            </a:r>
-          </a:p>
-        </p:txBody>
-      </p:sp>
-      <p:sp>
-        <p:nvSpPr>
-          <p:cNvPr id="3" name="Rectangle 2"/>
+          <p:cNvPr id="2" name="Rectangle 1"/>
           <p:cNvSpPr/>
           <p:nvPr/>
         </p:nvSpPr>
         <p:spPr>
           <a:xfrm>
-            <a:off x="548640" y="1371600"/>
-            <a:ext cx="11064240" cy="36576"/>
+            <a:off x="0" y="0"/>
+            <a:ext cx="228600" cy="6858000"/>
           </a:xfrm>
           <a:prstGeom prst="rect">
             <a:avLst/>
@@ -3776,6 +4622,7 @@
           <a:ln>
             <a:noFill/>
           </a:ln>
+          <a:effectLst/>
         </p:spPr>
         <p:style>
           <a:lnRef idx="1">
@@ -3801,14 +4648,14 @@
       </p:sp>
       <p:sp>
         <p:nvSpPr>
-          <p:cNvPr id="4" name="TextBox 3"/>
+          <p:cNvPr id="3" name="TextBox 2"/>
           <p:cNvSpPr txBox="1"/>
           <p:nvPr/>
         </p:nvSpPr>
         <p:spPr>
           <a:xfrm>
-            <a:off x="548640" y="6400800"/>
-            <a:ext cx="11064240" cy="320040"/>
+            <a:off x="594360" y="274320"/>
+            <a:ext cx="10972800" cy="320040"/>
           </a:xfrm>
           <a:prstGeom prst="rect">
             <a:avLst/>
@@ -3823,23 +4670,181 @@
           <a:p>
             <a:pPr>
               <a:spcAft>
-                <a:spcPts val="1000"/>
+                <a:spcPts val="800"/>
               </a:spcAft>
             </a:pPr>
             <a:r>
+              <a:rPr sz="1200" b="1">
+                <a:solidFill>
+                  <a:srgbClr val="1F4E79"/>
+                </a:solidFill>
+              </a:rPr>
+              <a:t>DRIVER MIX</a:t>
+            </a:r>
+          </a:p>
+        </p:txBody>
+      </p:sp>
+      <p:sp>
+        <p:nvSpPr>
+          <p:cNvPr id="4" name="TextBox 3"/>
+          <p:cNvSpPr txBox="1"/>
+          <p:nvPr/>
+        </p:nvSpPr>
+        <p:spPr>
+          <a:xfrm>
+            <a:off x="594360" y="566928"/>
+            <a:ext cx="11064240" cy="914400"/>
+          </a:xfrm>
+          <a:prstGeom prst="rect">
+            <a:avLst/>
+          </a:prstGeom>
+          <a:noFill/>
+        </p:spPr>
+        <p:txBody>
+          <a:bodyPr wrap="square">
+            <a:spAutoFit/>
+          </a:bodyPr>
+          <a:lstStyle/>
+          <a:p>
+            <a:pPr>
+              <a:spcAft>
+                <a:spcPts val="800"/>
+              </a:spcAft>
+            </a:pPr>
+            <a:r>
+              <a:rPr sz="2400" b="1">
+                <a:solidFill>
+                  <a:srgbClr val="0F2A43"/>
+                </a:solidFill>
+              </a:rPr>
+              <a:t>Fees and prices lead the complaints at Blinkit (21%) and Instamart (26%), but quality and freshness lead at Zepto (21%)</a:t>
+            </a:r>
+          </a:p>
+        </p:txBody>
+      </p:sp>
+      <p:sp>
+        <p:nvSpPr>
+          <p:cNvPr id="5" name="Rectangle 4"/>
+          <p:cNvSpPr/>
+          <p:nvPr/>
+        </p:nvSpPr>
+        <p:spPr>
+          <a:xfrm>
+            <a:off x="594360" y="1481328"/>
+            <a:ext cx="11018520" cy="27432"/>
+          </a:xfrm>
+          <a:prstGeom prst="rect">
+            <a:avLst/>
+          </a:prstGeom>
+          <a:solidFill>
+            <a:srgbClr val="BBD3EA"/>
+          </a:solidFill>
+          <a:ln>
+            <a:noFill/>
+          </a:ln>
+          <a:effectLst/>
+        </p:spPr>
+        <p:style>
+          <a:lnRef idx="1">
+            <a:schemeClr val="accent1"/>
+          </a:lnRef>
+          <a:fillRef idx="3">
+            <a:schemeClr val="accent1"/>
+          </a:fillRef>
+          <a:effectRef idx="2">
+            <a:schemeClr val="accent1"/>
+          </a:effectRef>
+          <a:fontRef idx="minor">
+            <a:schemeClr val="lt1"/>
+          </a:fontRef>
+        </p:style>
+        <p:txBody>
+          <a:bodyPr rtlCol="0" anchor="ctr"/>
+          <a:lstStyle/>
+          <a:p>
+            <a:pPr algn="ctr"/>
+          </a:p>
+        </p:txBody>
+      </p:sp>
+      <p:sp>
+        <p:nvSpPr>
+          <p:cNvPr id="6" name="TextBox 5"/>
+          <p:cNvSpPr txBox="1"/>
+          <p:nvPr/>
+        </p:nvSpPr>
+        <p:spPr>
+          <a:xfrm>
+            <a:off x="594360" y="6446520"/>
+            <a:ext cx="9875520" cy="274320"/>
+          </a:xfrm>
+          <a:prstGeom prst="rect">
+            <a:avLst/>
+          </a:prstGeom>
+          <a:noFill/>
+        </p:spPr>
+        <p:txBody>
+          <a:bodyPr wrap="square">
+            <a:spAutoFit/>
+          </a:bodyPr>
+          <a:lstStyle/>
+          <a:p>
+            <a:pPr>
+              <a:spcAft>
+                <a:spcPts val="800"/>
+              </a:spcAft>
+            </a:pPr>
+            <a:r>
               <a:rPr sz="1000" b="0">
                 <a:solidFill>
-                  <a:srgbClr val="777777"/>
+                  <a:srgbClr val="6B7280"/>
                 </a:solidFill>
               </a:rPr>
-              <a:t>Source: Google Play reviews, India, English, 1,112,946 reviews, Jan 2025 to Sep 2026; outputs/ in the repo.</a:t>
+              <a:t>Source: Google Play reviews, India, English, 1,112,946 reviews, Jan 2025 to Sep 2026. Figures from outputs/ in the repo.</a:t>
+            </a:r>
+          </a:p>
+        </p:txBody>
+      </p:sp>
+      <p:sp>
+        <p:nvSpPr>
+          <p:cNvPr id="7" name="TextBox 6"/>
+          <p:cNvSpPr txBox="1"/>
+          <p:nvPr/>
+        </p:nvSpPr>
+        <p:spPr>
+          <a:xfrm>
+            <a:off x="10972800" y="6446520"/>
+            <a:ext cx="640080" cy="274320"/>
+          </a:xfrm>
+          <a:prstGeom prst="rect">
+            <a:avLst/>
+          </a:prstGeom>
+          <a:noFill/>
+        </p:spPr>
+        <p:txBody>
+          <a:bodyPr wrap="square">
+            <a:spAutoFit/>
+          </a:bodyPr>
+          <a:lstStyle/>
+          <a:p>
+            <a:pPr algn="r">
+              <a:spcAft>
+                <a:spcPts val="800"/>
+              </a:spcAft>
+            </a:pPr>
+            <a:r>
+              <a:rPr sz="1000" b="0">
+                <a:solidFill>
+                  <a:srgbClr val="6B7280"/>
+                </a:solidFill>
+              </a:rPr>
+              <a:t>4</a:t>
             </a:r>
           </a:p>
         </p:txBody>
       </p:sp>
       <p:pic>
         <p:nvPicPr>
-          <p:cNvPr id="5" name="Picture 4" descr="waterfall.png"/>
+          <p:cNvPr id="8" name="Picture 7" descr="deck_mix.png"/>
           <p:cNvPicPr>
             <a:picLocks noChangeAspect="1"/>
           </p:cNvPicPr>
@@ -3853,14 +4858,114 @@
         </p:blipFill>
         <p:spPr>
           <a:xfrm>
-            <a:off x="822960" y="1554480"/>
-            <a:ext cx="10515600" cy="4882243"/>
+            <a:off x="594360" y="1691640"/>
+            <a:ext cx="5852160" cy="4058756"/>
           </a:xfrm>
           <a:prstGeom prst="rect">
             <a:avLst/>
           </a:prstGeom>
         </p:spPr>
       </p:pic>
+      <p:pic>
+        <p:nvPicPr>
+          <p:cNvPr id="9" name="Picture 8" descr="deck_heat.png"/>
+          <p:cNvPicPr>
+            <a:picLocks noChangeAspect="1"/>
+          </p:cNvPicPr>
+          <p:nvPr/>
+        </p:nvPicPr>
+        <p:blipFill>
+          <a:blip r:embed="rId3"/>
+          <a:stretch>
+            <a:fillRect/>
+          </a:stretch>
+        </p:blipFill>
+        <p:spPr>
+          <a:xfrm>
+            <a:off x="6675120" y="1691640"/>
+            <a:ext cx="4937760" cy="3931920"/>
+          </a:xfrm>
+          <a:prstGeom prst="rect">
+            <a:avLst/>
+          </a:prstGeom>
+        </p:spPr>
+      </p:pic>
+      <p:sp>
+        <p:nvSpPr>
+          <p:cNvPr id="10" name="TextBox 9"/>
+          <p:cNvSpPr txBox="1"/>
+          <p:nvPr/>
+        </p:nvSpPr>
+        <p:spPr>
+          <a:xfrm>
+            <a:off x="594360" y="5897880"/>
+            <a:ext cx="5852160" cy="457200"/>
+          </a:xfrm>
+          <a:prstGeom prst="rect">
+            <a:avLst/>
+          </a:prstGeom>
+          <a:noFill/>
+        </p:spPr>
+        <p:txBody>
+          <a:bodyPr wrap="square">
+            <a:spAutoFit/>
+          </a:bodyPr>
+          <a:lstStyle/>
+          <a:p>
+            <a:pPr>
+              <a:spcAft>
+                <a:spcPts val="800"/>
+              </a:spcAft>
+            </a:pPr>
+            <a:r>
+              <a:rPr sz="1200" b="0">
+                <a:solidFill>
+                  <a:srgbClr val="6B7280"/>
+                </a:solidFill>
+              </a:rPr>
+              <a:t>Share of tagged detractor reviews, Jul to Sep 2026.</a:t>
+            </a:r>
+          </a:p>
+        </p:txBody>
+      </p:sp>
+      <p:sp>
+        <p:nvSpPr>
+          <p:cNvPr id="11" name="TextBox 10"/>
+          <p:cNvSpPr txBox="1"/>
+          <p:nvPr/>
+        </p:nvSpPr>
+        <p:spPr>
+          <a:xfrm>
+            <a:off x="6675120" y="5897880"/>
+            <a:ext cx="4937760" cy="457200"/>
+          </a:xfrm>
+          <a:prstGeom prst="rect">
+            <a:avLst/>
+          </a:prstGeom>
+          <a:noFill/>
+        </p:spPr>
+        <p:txBody>
+          <a:bodyPr wrap="square">
+            <a:spAutoFit/>
+          </a:bodyPr>
+          <a:lstStyle/>
+          <a:p>
+            <a:pPr>
+              <a:spcAft>
+                <a:spcPts val="800"/>
+              </a:spcAft>
+            </a:pPr>
+            <a:r>
+              <a:rPr sz="1200" b="0">
+                <a:solidFill>
+                  <a:srgbClr val="6B7280"/>
+                </a:solidFill>
+              </a:rPr>
+              <a:t>NPS points lost to each driver, per app (all reviews).</a:t>
+            </a:r>
+          </a:p>
+        </p:txBody>
+      </p:sp>
     </p:spTree>
   </p:cSld>
   <p:clrMapOvr>
@@ -3881,52 +4986,14 @@
       <p:grpSpPr/>
       <p:sp>
         <p:nvSpPr>
-          <p:cNvPr id="2" name="TextBox 1"/>
-          <p:cNvSpPr txBox="1"/>
-          <p:nvPr/>
-        </p:nvSpPr>
-        <p:spPr>
-          <a:xfrm>
-            <a:off x="548640" y="274320"/>
-            <a:ext cx="11064240" cy="1097280"/>
-          </a:xfrm>
-          <a:prstGeom prst="rect">
-            <a:avLst/>
-          </a:prstGeom>
-          <a:noFill/>
-        </p:spPr>
-        <p:txBody>
-          <a:bodyPr wrap="square">
-            <a:spAutoFit/>
-          </a:bodyPr>
-          <a:lstStyle/>
-          <a:p>
-            <a:pPr>
-              <a:spcAft>
-                <a:spcPts val="1000"/>
-              </a:spcAft>
-            </a:pPr>
-            <a:r>
-              <a:rPr sz="2600" b="1">
-                <a:solidFill>
-                  <a:srgbClr val="1F4E79"/>
-                </a:solidFill>
-              </a:rPr>
-              <a:t>Fixing quality and freshness, missing or wrong items and support and rider behaviour at Zepto is worth up to 13.8 of the 34.5 NPS points to Blinkit</a:t>
-            </a:r>
-          </a:p>
-        </p:txBody>
-      </p:sp>
-      <p:sp>
-        <p:nvSpPr>
-          <p:cNvPr id="3" name="Rectangle 2"/>
+          <p:cNvPr id="2" name="Rectangle 1"/>
           <p:cNvSpPr/>
           <p:nvPr/>
         </p:nvSpPr>
         <p:spPr>
           <a:xfrm>
-            <a:off x="548640" y="1371600"/>
-            <a:ext cx="11064240" cy="36576"/>
+            <a:off x="0" y="0"/>
+            <a:ext cx="228600" cy="6858000"/>
           </a:xfrm>
           <a:prstGeom prst="rect">
             <a:avLst/>
@@ -3937,6 +5004,7 @@
           <a:ln>
             <a:noFill/>
           </a:ln>
+          <a:effectLst/>
         </p:spPr>
         <p:style>
           <a:lnRef idx="1">
@@ -3962,14 +5030,14 @@
       </p:sp>
       <p:sp>
         <p:nvSpPr>
-          <p:cNvPr id="4" name="TextBox 3"/>
+          <p:cNvPr id="3" name="TextBox 2"/>
           <p:cNvSpPr txBox="1"/>
           <p:nvPr/>
         </p:nvSpPr>
         <p:spPr>
           <a:xfrm>
-            <a:off x="548640" y="6400800"/>
-            <a:ext cx="11064240" cy="320040"/>
+            <a:off x="594360" y="274320"/>
+            <a:ext cx="10972800" cy="320040"/>
           </a:xfrm>
           <a:prstGeom prst="rect">
             <a:avLst/>
@@ -3984,30 +5052,30 @@
           <a:p>
             <a:pPr>
               <a:spcAft>
-                <a:spcPts val="1000"/>
+                <a:spcPts val="800"/>
               </a:spcAft>
             </a:pPr>
             <a:r>
-              <a:rPr sz="1000" b="0">
-                <a:solidFill>
-                  <a:srgbClr val="777777"/>
+              <a:rPr sz="1200" b="1">
+                <a:solidFill>
+                  <a:srgbClr val="1F4E79"/>
                 </a:solidFill>
               </a:rPr>
-              <a:t>Source: Google Play reviews, India, English, 1,112,946 reviews, Jan 2025 to Sep 2026; outputs/ in the repo.</a:t>
-            </a:r>
-          </a:p>
-        </p:txBody>
-      </p:sp>
-      <p:sp>
-        <p:nvSpPr>
-          <p:cNvPr id="5" name="TextBox 4"/>
+              <a:t>WHERE THE GAP COMES FROM</a:t>
+            </a:r>
+          </a:p>
+        </p:txBody>
+      </p:sp>
+      <p:sp>
+        <p:nvSpPr>
+          <p:cNvPr id="4" name="TextBox 3"/>
           <p:cNvSpPr txBox="1"/>
           <p:nvPr/>
         </p:nvSpPr>
         <p:spPr>
           <a:xfrm>
-            <a:off x="548640" y="1737360"/>
-            <a:ext cx="3566160" cy="914400"/>
+            <a:off x="594360" y="566928"/>
+            <a:ext cx="11064240" cy="914400"/>
           </a:xfrm>
           <a:prstGeom prst="rect">
             <a:avLst/>
@@ -4022,17 +5090,61 @@
           <a:p>
             <a:pPr>
               <a:spcAft>
-                <a:spcPts val="1000"/>
+                <a:spcPts val="800"/>
               </a:spcAft>
             </a:pPr>
             <a:r>
-              <a:rPr sz="4400" b="1">
-                <a:solidFill>
-                  <a:srgbClr val="1F4E79"/>
+              <a:rPr sz="2400" b="1">
+                <a:solidFill>
+                  <a:srgbClr val="0F2A43"/>
                 </a:solidFill>
               </a:rPr>
-              <a:t>6.0 points</a:t>
-            </a:r>
+              <a:t>Blinkit's 34.5 point lead over Zepto is 14.2 points of 5 star reviews, then 6.0 from quality and freshness and 4.4 from missing or wrong items</a:t>
+            </a:r>
+          </a:p>
+        </p:txBody>
+      </p:sp>
+      <p:sp>
+        <p:nvSpPr>
+          <p:cNvPr id="5" name="Rectangle 4"/>
+          <p:cNvSpPr/>
+          <p:nvPr/>
+        </p:nvSpPr>
+        <p:spPr>
+          <a:xfrm>
+            <a:off x="594360" y="1481328"/>
+            <a:ext cx="11018520" cy="27432"/>
+          </a:xfrm>
+          <a:prstGeom prst="rect">
+            <a:avLst/>
+          </a:prstGeom>
+          <a:solidFill>
+            <a:srgbClr val="BBD3EA"/>
+          </a:solidFill>
+          <a:ln>
+            <a:noFill/>
+          </a:ln>
+          <a:effectLst/>
+        </p:spPr>
+        <p:style>
+          <a:lnRef idx="1">
+            <a:schemeClr val="accent1"/>
+          </a:lnRef>
+          <a:fillRef idx="3">
+            <a:schemeClr val="accent1"/>
+          </a:fillRef>
+          <a:effectRef idx="2">
+            <a:schemeClr val="accent1"/>
+          </a:effectRef>
+          <a:fontRef idx="minor">
+            <a:schemeClr val="lt1"/>
+          </a:fontRef>
+        </p:style>
+        <p:txBody>
+          <a:bodyPr rtlCol="0" anchor="ctr"/>
+          <a:lstStyle/>
+          <a:p>
+            <a:pPr algn="ctr"/>
           </a:p>
         </p:txBody>
       </p:sp>
@@ -4044,8 +5156,8 @@
         </p:nvSpPr>
         <p:spPr>
           <a:xfrm>
-            <a:off x="548640" y="2743200"/>
-            <a:ext cx="3566160" cy="548640"/>
+            <a:off x="594360" y="6446520"/>
+            <a:ext cx="9875520" cy="274320"/>
           </a:xfrm>
           <a:prstGeom prst="rect">
             <a:avLst/>
@@ -4060,16 +5172,16 @@
           <a:p>
             <a:pPr>
               <a:spcAft>
-                <a:spcPts val="1000"/>
+                <a:spcPts val="800"/>
               </a:spcAft>
             </a:pPr>
             <a:r>
-              <a:rPr sz="2000" b="1">
-                <a:solidFill>
-                  <a:srgbClr val="222222"/>
+              <a:rPr sz="1000" b="0">
+                <a:solidFill>
+                  <a:srgbClr val="6B7280"/>
                 </a:solidFill>
               </a:rPr>
-              <a:t>Quality and freshness (±1.0)</a:t>
+              <a:t>Source: Google Play reviews, India, English, 1,112,946 reviews. Bars sum to the gap; driver bars carry up to ±1.0 points of sampling error.</a:t>
             </a:r>
           </a:p>
         </p:txBody>
@@ -4082,8 +5194,8 @@
         </p:nvSpPr>
         <p:spPr>
           <a:xfrm>
-            <a:off x="548640" y="3474720"/>
-            <a:ext cx="3566160" cy="1828800"/>
+            <a:off x="10972800" y="6446520"/>
+            <a:ext cx="640080" cy="274320"/>
           </a:xfrm>
           <a:prstGeom prst="rect">
             <a:avLst/>
@@ -4096,288 +5208,46 @@
           </a:bodyPr>
           <a:lstStyle/>
           <a:p>
-            <a:pPr>
+            <a:pPr algn="r">
               <a:spcAft>
-                <a:spcPts val="1000"/>
+                <a:spcPts val="800"/>
               </a:spcAft>
             </a:pPr>
             <a:r>
-              <a:rPr sz="1700" b="0">
-                <a:solidFill>
-                  <a:srgbClr val="222222"/>
+              <a:rPr sz="1000" b="0">
+                <a:solidFill>
+                  <a:srgbClr val="6B7280"/>
                 </a:solidFill>
               </a:rPr>
-              <a:t>1. Check expiry and condition of perishables at packing, and pull items that get repeat complaints.</a:t>
-            </a:r>
-          </a:p>
-        </p:txBody>
-      </p:sp>
-      <p:sp>
-        <p:nvSpPr>
-          <p:cNvPr id="8" name="TextBox 7"/>
-          <p:cNvSpPr txBox="1"/>
-          <p:nvPr/>
-        </p:nvSpPr>
-        <p:spPr>
-          <a:xfrm>
-            <a:off x="4297679" y="1737360"/>
-            <a:ext cx="3566160" cy="914400"/>
-          </a:xfrm>
-          <a:prstGeom prst="rect">
-            <a:avLst/>
-          </a:prstGeom>
-          <a:noFill/>
-        </p:spPr>
-        <p:txBody>
-          <a:bodyPr wrap="square">
-            <a:spAutoFit/>
-          </a:bodyPr>
-          <a:lstStyle/>
-          <a:p>
-            <a:pPr>
-              <a:spcAft>
-                <a:spcPts val="1000"/>
-              </a:spcAft>
-            </a:pPr>
-            <a:r>
-              <a:rPr sz="4400" b="1">
-                <a:solidFill>
-                  <a:srgbClr val="1F4E79"/>
-                </a:solidFill>
-              </a:rPr>
-              <a:t>4.4 points</a:t>
-            </a:r>
-          </a:p>
-        </p:txBody>
-      </p:sp>
-      <p:sp>
-        <p:nvSpPr>
-          <p:cNvPr id="9" name="TextBox 8"/>
-          <p:cNvSpPr txBox="1"/>
-          <p:nvPr/>
-        </p:nvSpPr>
-        <p:spPr>
-          <a:xfrm>
-            <a:off x="4297679" y="2743200"/>
-            <a:ext cx="3566160" cy="548640"/>
-          </a:xfrm>
-          <a:prstGeom prst="rect">
-            <a:avLst/>
-          </a:prstGeom>
-          <a:noFill/>
-        </p:spPr>
-        <p:txBody>
-          <a:bodyPr wrap="square">
-            <a:spAutoFit/>
-          </a:bodyPr>
-          <a:lstStyle/>
-          <a:p>
-            <a:pPr>
-              <a:spcAft>
-                <a:spcPts val="1000"/>
-              </a:spcAft>
-            </a:pPr>
-            <a:r>
-              <a:rPr sz="2000" b="1">
-                <a:solidFill>
-                  <a:srgbClr val="222222"/>
-                </a:solidFill>
-              </a:rPr>
-              <a:t>Missing or wrong items (±0.9)</a:t>
-            </a:r>
-          </a:p>
-        </p:txBody>
-      </p:sp>
-      <p:sp>
-        <p:nvSpPr>
-          <p:cNvPr id="10" name="TextBox 9"/>
-          <p:cNvSpPr txBox="1"/>
-          <p:nvPr/>
-        </p:nvSpPr>
-        <p:spPr>
-          <a:xfrm>
-            <a:off x="4297679" y="3474720"/>
-            <a:ext cx="3566160" cy="1828800"/>
-          </a:xfrm>
-          <a:prstGeom prst="rect">
-            <a:avLst/>
-          </a:prstGeom>
-          <a:noFill/>
-        </p:spPr>
-        <p:txBody>
-          <a:bodyPr wrap="square">
-            <a:spAutoFit/>
-          </a:bodyPr>
-          <a:lstStyle/>
-          <a:p>
-            <a:pPr>
-              <a:spcAft>
-                <a:spcPts val="1000"/>
-              </a:spcAft>
-            </a:pPr>
-            <a:r>
-              <a:rPr sz="1700" b="0">
-                <a:solidFill>
-                  <a:srgbClr val="222222"/>
-                </a:solidFill>
-              </a:rPr>
-              <a:t>2. Add a pick and pack check, and require proof of drop before an order can be marked delivered.</a:t>
-            </a:r>
-          </a:p>
-        </p:txBody>
-      </p:sp>
-      <p:sp>
-        <p:nvSpPr>
-          <p:cNvPr id="11" name="TextBox 10"/>
-          <p:cNvSpPr txBox="1"/>
-          <p:nvPr/>
-        </p:nvSpPr>
-        <p:spPr>
-          <a:xfrm>
-            <a:off x="8046719" y="1737360"/>
-            <a:ext cx="3566160" cy="914400"/>
-          </a:xfrm>
-          <a:prstGeom prst="rect">
-            <a:avLst/>
-          </a:prstGeom>
-          <a:noFill/>
-        </p:spPr>
-        <p:txBody>
-          <a:bodyPr wrap="square">
-            <a:spAutoFit/>
-          </a:bodyPr>
-          <a:lstStyle/>
-          <a:p>
-            <a:pPr>
-              <a:spcAft>
-                <a:spcPts val="1000"/>
-              </a:spcAft>
-            </a:pPr>
-            <a:r>
-              <a:rPr sz="4400" b="1">
-                <a:solidFill>
-                  <a:srgbClr val="1F4E79"/>
-                </a:solidFill>
-              </a:rPr>
-              <a:t>3.5 points</a:t>
-            </a:r>
-          </a:p>
-        </p:txBody>
-      </p:sp>
-      <p:sp>
-        <p:nvSpPr>
-          <p:cNvPr id="12" name="TextBox 11"/>
-          <p:cNvSpPr txBox="1"/>
-          <p:nvPr/>
-        </p:nvSpPr>
-        <p:spPr>
-          <a:xfrm>
-            <a:off x="8046719" y="2743200"/>
-            <a:ext cx="3566160" cy="548640"/>
-          </a:xfrm>
-          <a:prstGeom prst="rect">
-            <a:avLst/>
-          </a:prstGeom>
-          <a:noFill/>
-        </p:spPr>
-        <p:txBody>
-          <a:bodyPr wrap="square">
-            <a:spAutoFit/>
-          </a:bodyPr>
-          <a:lstStyle/>
-          <a:p>
-            <a:pPr>
-              <a:spcAft>
-                <a:spcPts val="1000"/>
-              </a:spcAft>
-            </a:pPr>
-            <a:r>
-              <a:rPr sz="2000" b="1">
-                <a:solidFill>
-                  <a:srgbClr val="222222"/>
-                </a:solidFill>
-              </a:rPr>
-              <a:t>Support and rider behaviour (±0.9)</a:t>
-            </a:r>
-          </a:p>
-        </p:txBody>
-      </p:sp>
-      <p:sp>
-        <p:nvSpPr>
-          <p:cNvPr id="13" name="TextBox 12"/>
-          <p:cNvSpPr txBox="1"/>
-          <p:nvPr/>
-        </p:nvSpPr>
-        <p:spPr>
-          <a:xfrm>
-            <a:off x="8046719" y="3474720"/>
-            <a:ext cx="3566160" cy="1828800"/>
-          </a:xfrm>
-          <a:prstGeom prst="rect">
-            <a:avLst/>
-          </a:prstGeom>
-          <a:noFill/>
-        </p:spPr>
-        <p:txBody>
-          <a:bodyPr wrap="square">
-            <a:spAutoFit/>
-          </a:bodyPr>
-          <a:lstStyle/>
-          <a:p>
-            <a:pPr>
-              <a:spcAft>
-                <a:spcPts val="1000"/>
-              </a:spcAft>
-            </a:pPr>
-            <a:r>
-              <a:rPr sz="1700" b="0">
-                <a:solidFill>
-                  <a:srgbClr val="222222"/>
-                </a:solidFill>
-              </a:rPr>
-              <a:t>3. Give a human agent path after the bot, shorten the first human reply, and coach riders on conduct.</a:t>
-            </a:r>
-          </a:p>
-        </p:txBody>
-      </p:sp>
-      <p:sp>
-        <p:nvSpPr>
-          <p:cNvPr id="14" name="TextBox 13"/>
-          <p:cNvSpPr txBox="1"/>
-          <p:nvPr/>
-        </p:nvSpPr>
-        <p:spPr>
-          <a:xfrm>
-            <a:off x="548640" y="5577840"/>
-            <a:ext cx="11064240" cy="731520"/>
-          </a:xfrm>
-          <a:prstGeom prst="rect">
-            <a:avLst/>
-          </a:prstGeom>
-          <a:noFill/>
-        </p:spPr>
-        <p:txBody>
-          <a:bodyPr wrap="square">
-            <a:spAutoFit/>
-          </a:bodyPr>
-          <a:lstStyle/>
-          <a:p>
-            <a:pPr>
-              <a:spcAft>
-                <a:spcPts val="1000"/>
-              </a:spcAft>
-            </a:pPr>
-            <a:r>
-              <a:rPr sz="1300" b="0">
-                <a:solidFill>
-                  <a:srgbClr val="777777"/>
-                </a:solidFill>
-              </a:rPr>
-              <a:t>Points at stake are the extra NPS points Zepto loses to each driver compared with Blinkit in Jul to Sep 2026. Matching the leader's rate would recover them. The ± is sampling error from the tagged sample.</a:t>
-            </a:r>
-          </a:p>
-        </p:txBody>
-      </p:sp>
+              <a:t>5</a:t>
+            </a:r>
+          </a:p>
+        </p:txBody>
+      </p:sp>
+      <p:pic>
+        <p:nvPicPr>
+          <p:cNvPr id="8" name="Picture 7" descr="waterfall.png"/>
+          <p:cNvPicPr>
+            <a:picLocks noChangeAspect="1"/>
+          </p:cNvPicPr>
+          <p:nvPr/>
+        </p:nvPicPr>
+        <p:blipFill>
+          <a:blip r:embed="rId2"/>
+          <a:stretch>
+            <a:fillRect/>
+          </a:stretch>
+        </p:blipFill>
+        <p:spPr>
+          <a:xfrm>
+            <a:off x="822960" y="1645920"/>
+            <a:ext cx="10241280" cy="4754880"/>
+          </a:xfrm>
+          <a:prstGeom prst="rect">
+            <a:avLst/>
+          </a:prstGeom>
+        </p:spPr>
+      </p:pic>
     </p:spTree>
   </p:cSld>
   <p:clrMapOvr>
@@ -4398,52 +5268,14 @@
       <p:grpSpPr/>
       <p:sp>
         <p:nvSpPr>
-          <p:cNvPr id="2" name="TextBox 1"/>
-          <p:cNvSpPr txBox="1"/>
-          <p:nvPr/>
-        </p:nvSpPr>
-        <p:spPr>
-          <a:xfrm>
-            <a:off x="548640" y="274320"/>
-            <a:ext cx="11064240" cy="1097280"/>
-          </a:xfrm>
-          <a:prstGeom prst="rect">
-            <a:avLst/>
-          </a:prstGeom>
-          <a:noFill/>
-        </p:spPr>
-        <p:txBody>
-          <a:bodyPr wrap="square">
-            <a:spAutoFit/>
-          </a:bodyPr>
-          <a:lstStyle/>
-          <a:p>
-            <a:pPr>
-              <a:spcAft>
-                <a:spcPts val="1000"/>
-              </a:spcAft>
-            </a:pPr>
-            <a:r>
-              <a:rPr sz="2600" b="1">
-                <a:solidFill>
-                  <a:srgbClr val="1F4E79"/>
-                </a:solidFill>
-              </a:rPr>
-              <a:t>The numbers are a review based proxy for NPS, tagged by a model and checked for consistency, not yet against human labels</a:t>
-            </a:r>
-          </a:p>
-        </p:txBody>
-      </p:sp>
-      <p:sp>
-        <p:nvSpPr>
-          <p:cNvPr id="3" name="Rectangle 2"/>
+          <p:cNvPr id="2" name="Rectangle 1"/>
           <p:cNvSpPr/>
           <p:nvPr/>
         </p:nvSpPr>
         <p:spPr>
           <a:xfrm>
-            <a:off x="548640" y="1371600"/>
-            <a:ext cx="11064240" cy="36576"/>
+            <a:off x="0" y="0"/>
+            <a:ext cx="228600" cy="6858000"/>
           </a:xfrm>
           <a:prstGeom prst="rect">
             <a:avLst/>
@@ -4454,6 +5286,7 @@
           <a:ln>
             <a:noFill/>
           </a:ln>
+          <a:effectLst/>
         </p:spPr>
         <p:style>
           <a:lnRef idx="1">
@@ -4479,14 +5312,14 @@
       </p:sp>
       <p:sp>
         <p:nvSpPr>
-          <p:cNvPr id="4" name="TextBox 3"/>
+          <p:cNvPr id="3" name="TextBox 2"/>
           <p:cNvSpPr txBox="1"/>
           <p:nvPr/>
         </p:nvSpPr>
         <p:spPr>
           <a:xfrm>
-            <a:off x="548640" y="6400800"/>
-            <a:ext cx="11064240" cy="320040"/>
+            <a:off x="594360" y="274320"/>
+            <a:ext cx="10972800" cy="320040"/>
           </a:xfrm>
           <a:prstGeom prst="rect">
             <a:avLst/>
@@ -4501,30 +5334,30 @@
           <a:p>
             <a:pPr>
               <a:spcAft>
-                <a:spcPts val="1000"/>
+                <a:spcPts val="800"/>
               </a:spcAft>
             </a:pPr>
             <a:r>
-              <a:rPr sz="1000" b="0">
-                <a:solidFill>
-                  <a:srgbClr val="777777"/>
+              <a:rPr sz="1200" b="1">
+                <a:solidFill>
+                  <a:srgbClr val="1F4E79"/>
                 </a:solidFill>
               </a:rPr>
-              <a:t>Source: Google Play reviews, India, English, 1,112,946 reviews, Jan 2025 to Sep 2026; outputs/ in the repo.</a:t>
-            </a:r>
-          </a:p>
-        </p:txBody>
-      </p:sp>
-      <p:sp>
-        <p:nvSpPr>
-          <p:cNvPr id="5" name="TextBox 4"/>
+              <a:t>RECOMMENDATIONS</a:t>
+            </a:r>
+          </a:p>
+        </p:txBody>
+      </p:sp>
+      <p:sp>
+        <p:nvSpPr>
+          <p:cNvPr id="4" name="TextBox 3"/>
           <p:cNvSpPr txBox="1"/>
           <p:nvPr/>
         </p:nvSpPr>
         <p:spPr>
           <a:xfrm>
-            <a:off x="548640" y="1600200"/>
-            <a:ext cx="5486400" cy="548640"/>
+            <a:off x="594360" y="566928"/>
+            <a:ext cx="11064240" cy="914400"/>
           </a:xfrm>
           <a:prstGeom prst="rect">
             <a:avLst/>
@@ -4539,17 +5372,61 @@
           <a:p>
             <a:pPr>
               <a:spcAft>
-                <a:spcPts val="1000"/>
+                <a:spcPts val="800"/>
               </a:spcAft>
             </a:pPr>
             <a:r>
-              <a:rPr sz="2200" b="1">
-                <a:solidFill>
-                  <a:srgbClr val="1F4E79"/>
+              <a:rPr sz="2400" b="1">
+                <a:solidFill>
+                  <a:srgbClr val="0F2A43"/>
                 </a:solidFill>
               </a:rPr>
-              <a:t>Method</a:t>
-            </a:r>
+              <a:t>Fixing quality and freshness, missing or wrong items and support and rider behaviour at Zepto is worth up to 13.8 of the 34.5 NPS points to Blinkit</a:t>
+            </a:r>
+          </a:p>
+        </p:txBody>
+      </p:sp>
+      <p:sp>
+        <p:nvSpPr>
+          <p:cNvPr id="5" name="Rectangle 4"/>
+          <p:cNvSpPr/>
+          <p:nvPr/>
+        </p:nvSpPr>
+        <p:spPr>
+          <a:xfrm>
+            <a:off x="594360" y="1481328"/>
+            <a:ext cx="11018520" cy="27432"/>
+          </a:xfrm>
+          <a:prstGeom prst="rect">
+            <a:avLst/>
+          </a:prstGeom>
+          <a:solidFill>
+            <a:srgbClr val="BBD3EA"/>
+          </a:solidFill>
+          <a:ln>
+            <a:noFill/>
+          </a:ln>
+          <a:effectLst/>
+        </p:spPr>
+        <p:style>
+          <a:lnRef idx="1">
+            <a:schemeClr val="accent1"/>
+          </a:lnRef>
+          <a:fillRef idx="3">
+            <a:schemeClr val="accent1"/>
+          </a:fillRef>
+          <a:effectRef idx="2">
+            <a:schemeClr val="accent1"/>
+          </a:effectRef>
+          <a:fontRef idx="minor">
+            <a:schemeClr val="lt1"/>
+          </a:fontRef>
+        </p:style>
+        <p:txBody>
+          <a:bodyPr rtlCol="0" anchor="ctr"/>
+          <a:lstStyle/>
+          <a:p>
+            <a:pPr algn="ctr"/>
           </a:p>
         </p:txBody>
       </p:sp>
@@ -4561,8 +5438,8 @@
         </p:nvSpPr>
         <p:spPr>
           <a:xfrm>
-            <a:off x="6309360" y="1600200"/>
-            <a:ext cx="5303520" cy="548640"/>
+            <a:off x="594360" y="6446520"/>
+            <a:ext cx="9875520" cy="274320"/>
           </a:xfrm>
           <a:prstGeom prst="rect">
             <a:avLst/>
@@ -4577,16 +5454,16 @@
           <a:p>
             <a:pPr>
               <a:spcAft>
-                <a:spcPts val="1000"/>
+                <a:spcPts val="800"/>
               </a:spcAft>
             </a:pPr>
             <a:r>
-              <a:rPr sz="2200" b="1">
-                <a:solidFill>
-                  <a:srgbClr val="1F4E79"/>
+              <a:rPr sz="1000" b="0">
+                <a:solidFill>
+                  <a:srgbClr val="6B7280"/>
                 </a:solidFill>
               </a:rPr>
-              <a:t>Limitations</a:t>
+              <a:t>Source: Google Play reviews, India, English, 1,112,946 reviews, Jan 2025 to Sep 2026. Figures from outputs/ in the repo.</a:t>
             </a:r>
           </a:p>
         </p:txBody>
@@ -4599,8 +5476,8 @@
         </p:nvSpPr>
         <p:spPr>
           <a:xfrm>
-            <a:off x="548640" y="2240280"/>
-            <a:ext cx="5486400" cy="4023360"/>
+            <a:off x="10972800" y="6446520"/>
+            <a:ext cx="640080" cy="274320"/>
           </a:xfrm>
           <a:prstGeom prst="rect">
             <a:avLst/>
@@ -4613,77 +5490,78 @@
           </a:bodyPr>
           <a:lstStyle/>
           <a:p>
-            <a:pPr>
+            <a:pPr algn="r">
               <a:spcAft>
-                <a:spcPts val="1000"/>
+                <a:spcPts val="800"/>
               </a:spcAft>
             </a:pPr>
             <a:r>
-              <a:rPr sz="1600" b="0">
-                <a:solidFill>
-                  <a:srgbClr val="222222"/>
+              <a:rPr sz="1000" b="0">
+                <a:solidFill>
+                  <a:srgbClr val="6B7280"/>
                 </a:solidFill>
               </a:rPr>
-              <a:t>* Promoter 5 stars, passive 4, detractor 1 to 3. 1,112,946 reviews, 21 months.</a:t>
-            </a:r>
-          </a:p>
-          <a:p>
-            <a:pPr>
-              <a:spcAft>
-                <a:spcPts val="1000"/>
-              </a:spcAft>
-            </a:pPr>
-            <a:r>
-              <a:rPr sz="1600" b="0">
-                <a:solidFill>
-                  <a:srgbClr val="222222"/>
-                </a:solidFill>
-              </a:rPr>
-              <a:t>* 21,000 detractor reviews (1,000 per app per quarter, 4 or more words) tagged to 8 complaint drivers by Claude in an interactive session.</a:t>
-            </a:r>
-          </a:p>
-          <a:p>
-            <a:pPr>
-              <a:spcAft>
-                <a:spcPts val="1000"/>
-              </a:spcAft>
-            </a:pPr>
-            <a:r>
-              <a:rPr sz="1600" b="0">
-                <a:solidFill>
-                  <a:srgbClr val="222222"/>
-                </a:solidFill>
-              </a:rPr>
-              <a:t>* Two independent tagging passes agreed on 96% of 100 reviews (kappa 0.954).</a:t>
-            </a:r>
-          </a:p>
-          <a:p>
-            <a:pPr>
-              <a:spcAft>
-                <a:spcPts val="1000"/>
-              </a:spcAft>
-            </a:pPr>
-            <a:r>
-              <a:rPr sz="1600" b="0">
-                <a:solidFill>
-                  <a:srgbClr val="222222"/>
-                </a:solidFill>
-              </a:rPr>
-              <a:t>* A keyword baseline agrees with the model tags on 52% (kappa 0.46).</a:t>
-            </a:r>
-          </a:p>
-        </p:txBody>
-      </p:sp>
-      <p:sp>
-        <p:nvSpPr>
-          <p:cNvPr id="8" name="TextBox 7"/>
+              <a:t>6</a:t>
+            </a:r>
+          </a:p>
+        </p:txBody>
+      </p:sp>
+      <p:sp>
+        <p:nvSpPr>
+          <p:cNvPr id="8" name="Rounded Rectangle 7"/>
+          <p:cNvSpPr/>
+          <p:nvPr/>
+        </p:nvSpPr>
+        <p:spPr>
+          <a:xfrm>
+            <a:off x="594360" y="1691640"/>
+            <a:ext cx="6035040" cy="1234440"/>
+          </a:xfrm>
+          <a:prstGeom prst="roundRect">
+            <a:avLst>
+              <a:gd name="adj" fmla="val 6000"/>
+            </a:avLst>
+          </a:prstGeom>
+          <a:solidFill>
+            <a:srgbClr val="F1F5F9"/>
+          </a:solidFill>
+          <a:ln>
+            <a:noFill/>
+          </a:ln>
+          <a:effectLst/>
+        </p:spPr>
+        <p:style>
+          <a:lnRef idx="1">
+            <a:schemeClr val="accent1"/>
+          </a:lnRef>
+          <a:fillRef idx="3">
+            <a:schemeClr val="accent1"/>
+          </a:fillRef>
+          <a:effectRef idx="2">
+            <a:schemeClr val="accent1"/>
+          </a:effectRef>
+          <a:fontRef idx="minor">
+            <a:schemeClr val="lt1"/>
+          </a:fontRef>
+        </p:style>
+        <p:txBody>
+          <a:bodyPr rtlCol="0" anchor="ctr"/>
+          <a:lstStyle/>
+          <a:p>
+            <a:pPr algn="ctr"/>
+          </a:p>
+        </p:txBody>
+      </p:sp>
+      <p:sp>
+        <p:nvSpPr>
+          <p:cNvPr id="9" name="TextBox 8"/>
           <p:cNvSpPr txBox="1"/>
           <p:nvPr/>
         </p:nvSpPr>
         <p:spPr>
           <a:xfrm>
-            <a:off x="6309360" y="2240280"/>
-            <a:ext cx="5303520" cy="4023360"/>
+            <a:off x="731520" y="1874520"/>
+            <a:ext cx="1554480" cy="822960"/>
           </a:xfrm>
           <a:prstGeom prst="rect">
             <a:avLst/>
@@ -4698,61 +5576,998 @@
           <a:p>
             <a:pPr>
               <a:spcAft>
-                <a:spcPts val="1000"/>
+                <a:spcPts val="800"/>
               </a:spcAft>
             </a:pPr>
             <a:r>
-              <a:rPr sz="1600" b="0">
-                <a:solidFill>
-                  <a:srgbClr val="222222"/>
+              <a:rPr sz="3800" b="1">
+                <a:solidFill>
+                  <a:srgbClr val="1F4E79"/>
                 </a:solidFill>
               </a:rPr>
-              <a:t>* Review based proxy, not survey NPS. Reviewers skew negative, so levels are not comparable with published NPS.</a:t>
-            </a:r>
-          </a:p>
+              <a:t>6.0</a:t>
+            </a:r>
+          </a:p>
+        </p:txBody>
+      </p:sp>
+      <p:sp>
+        <p:nvSpPr>
+          <p:cNvPr id="10" name="TextBox 9"/>
+          <p:cNvSpPr txBox="1"/>
+          <p:nvPr/>
+        </p:nvSpPr>
+        <p:spPr>
+          <a:xfrm>
+            <a:off x="2194560" y="1783080"/>
+            <a:ext cx="4297680" cy="365760"/>
+          </a:xfrm>
+          <a:prstGeom prst="rect">
+            <a:avLst/>
+          </a:prstGeom>
+          <a:noFill/>
+        </p:spPr>
+        <p:txBody>
+          <a:bodyPr wrap="square">
+            <a:spAutoFit/>
+          </a:bodyPr>
+          <a:lstStyle/>
           <a:p>
             <a:pPr>
               <a:spcAft>
-                <a:spcPts val="1000"/>
+                <a:spcPts val="800"/>
               </a:spcAft>
             </a:pPr>
             <a:r>
-              <a:rPr sz="1600" b="0">
+              <a:rPr sz="1600" b="1">
                 <a:solidFill>
                   <a:srgbClr val="222222"/>
                 </a:solidFill>
               </a:rPr>
-              <a:t>* Play Store and English only.</a:t>
-            </a:r>
-          </a:p>
+              <a:t>1. Quality and freshness (±1.0)</a:t>
+            </a:r>
+          </a:p>
+        </p:txBody>
+      </p:sp>
+      <p:sp>
+        <p:nvSpPr>
+          <p:cNvPr id="11" name="TextBox 10"/>
+          <p:cNvSpPr txBox="1"/>
+          <p:nvPr/>
+        </p:nvSpPr>
+        <p:spPr>
+          <a:xfrm>
+            <a:off x="2194560" y="2148840"/>
+            <a:ext cx="4297680" cy="731520"/>
+          </a:xfrm>
+          <a:prstGeom prst="rect">
+            <a:avLst/>
+          </a:prstGeom>
+          <a:noFill/>
+        </p:spPr>
+        <p:txBody>
+          <a:bodyPr wrap="square">
+            <a:spAutoFit/>
+          </a:bodyPr>
+          <a:lstStyle/>
           <a:p>
             <a:pPr>
               <a:spcAft>
-                <a:spcPts val="1000"/>
+                <a:spcPts val="800"/>
               </a:spcAft>
             </a:pPr>
             <a:r>
-              <a:rPr sz="1600" b="0">
+              <a:rPr sz="1250" b="0">
                 <a:solidFill>
                   <a:srgbClr val="222222"/>
                 </a:solidFill>
               </a:rPr>
-              <a:t>* Agreement between tagging passes shows the rules are clear, not that the tags are right.</a:t>
-            </a:r>
-          </a:p>
+              <a:t>Check expiry and condition of perishables at packing, and pull items that get repeat complaints.</a:t>
+            </a:r>
+          </a:p>
+        </p:txBody>
+      </p:sp>
+      <p:sp>
+        <p:nvSpPr>
+          <p:cNvPr id="12" name="Rounded Rectangle 11"/>
+          <p:cNvSpPr/>
+          <p:nvPr/>
+        </p:nvSpPr>
+        <p:spPr>
+          <a:xfrm>
+            <a:off x="594360" y="3063240"/>
+            <a:ext cx="6035040" cy="1234440"/>
+          </a:xfrm>
+          <a:prstGeom prst="roundRect">
+            <a:avLst>
+              <a:gd name="adj" fmla="val 6000"/>
+            </a:avLst>
+          </a:prstGeom>
+          <a:solidFill>
+            <a:srgbClr val="F1F5F9"/>
+          </a:solidFill>
+          <a:ln>
+            <a:noFill/>
+          </a:ln>
+          <a:effectLst/>
+        </p:spPr>
+        <p:style>
+          <a:lnRef idx="1">
+            <a:schemeClr val="accent1"/>
+          </a:lnRef>
+          <a:fillRef idx="3">
+            <a:schemeClr val="accent1"/>
+          </a:fillRef>
+          <a:effectRef idx="2">
+            <a:schemeClr val="accent1"/>
+          </a:effectRef>
+          <a:fontRef idx="minor">
+            <a:schemeClr val="lt1"/>
+          </a:fontRef>
+        </p:style>
+        <p:txBody>
+          <a:bodyPr rtlCol="0" anchor="ctr"/>
+          <a:lstStyle/>
+          <a:p>
+            <a:pPr algn="ctr"/>
+          </a:p>
+        </p:txBody>
+      </p:sp>
+      <p:sp>
+        <p:nvSpPr>
+          <p:cNvPr id="13" name="TextBox 12"/>
+          <p:cNvSpPr txBox="1"/>
+          <p:nvPr/>
+        </p:nvSpPr>
+        <p:spPr>
+          <a:xfrm>
+            <a:off x="731520" y="3246120"/>
+            <a:ext cx="1554480" cy="822960"/>
+          </a:xfrm>
+          <a:prstGeom prst="rect">
+            <a:avLst/>
+          </a:prstGeom>
+          <a:noFill/>
+        </p:spPr>
+        <p:txBody>
+          <a:bodyPr wrap="square">
+            <a:spAutoFit/>
+          </a:bodyPr>
+          <a:lstStyle/>
           <a:p>
             <a:pPr>
               <a:spcAft>
-                <a:spcPts val="1000"/>
+                <a:spcPts val="800"/>
               </a:spcAft>
             </a:pPr>
             <a:r>
-              <a:rPr sz="1600" b="0">
+              <a:rPr sz="3800" b="1">
+                <a:solidFill>
+                  <a:srgbClr val="1F4E79"/>
+                </a:solidFill>
+              </a:rPr>
+              <a:t>4.4</a:t>
+            </a:r>
+          </a:p>
+        </p:txBody>
+      </p:sp>
+      <p:sp>
+        <p:nvSpPr>
+          <p:cNvPr id="14" name="TextBox 13"/>
+          <p:cNvSpPr txBox="1"/>
+          <p:nvPr/>
+        </p:nvSpPr>
+        <p:spPr>
+          <a:xfrm>
+            <a:off x="2194560" y="3154680"/>
+            <a:ext cx="4297680" cy="365760"/>
+          </a:xfrm>
+          <a:prstGeom prst="rect">
+            <a:avLst/>
+          </a:prstGeom>
+          <a:noFill/>
+        </p:spPr>
+        <p:txBody>
+          <a:bodyPr wrap="square">
+            <a:spAutoFit/>
+          </a:bodyPr>
+          <a:lstStyle/>
+          <a:p>
+            <a:pPr>
+              <a:spcAft>
+                <a:spcPts val="800"/>
+              </a:spcAft>
+            </a:pPr>
+            <a:r>
+              <a:rPr sz="1600" b="1">
                 <a:solidFill>
                   <a:srgbClr val="222222"/>
                 </a:solidFill>
               </a:rPr>
-              <a:t>* Driver bars carry up to ±1.0 points of sampling error. Blinkit's lead over second place is inside its margin.</a:t>
+              <a:t>2. Missing or wrong items (±0.9)</a:t>
+            </a:r>
+          </a:p>
+        </p:txBody>
+      </p:sp>
+      <p:sp>
+        <p:nvSpPr>
+          <p:cNvPr id="15" name="TextBox 14"/>
+          <p:cNvSpPr txBox="1"/>
+          <p:nvPr/>
+        </p:nvSpPr>
+        <p:spPr>
+          <a:xfrm>
+            <a:off x="2194560" y="3520440"/>
+            <a:ext cx="4297680" cy="731520"/>
+          </a:xfrm>
+          <a:prstGeom prst="rect">
+            <a:avLst/>
+          </a:prstGeom>
+          <a:noFill/>
+        </p:spPr>
+        <p:txBody>
+          <a:bodyPr wrap="square">
+            <a:spAutoFit/>
+          </a:bodyPr>
+          <a:lstStyle/>
+          <a:p>
+            <a:pPr>
+              <a:spcAft>
+                <a:spcPts val="800"/>
+              </a:spcAft>
+            </a:pPr>
+            <a:r>
+              <a:rPr sz="1250" b="0">
+                <a:solidFill>
+                  <a:srgbClr val="222222"/>
+                </a:solidFill>
+              </a:rPr>
+              <a:t>Add a pick and pack check, and require proof of drop before an order can be marked delivered.</a:t>
+            </a:r>
+          </a:p>
+        </p:txBody>
+      </p:sp>
+      <p:sp>
+        <p:nvSpPr>
+          <p:cNvPr id="16" name="Rounded Rectangle 15"/>
+          <p:cNvSpPr/>
+          <p:nvPr/>
+        </p:nvSpPr>
+        <p:spPr>
+          <a:xfrm>
+            <a:off x="594360" y="4434840"/>
+            <a:ext cx="6035040" cy="1234440"/>
+          </a:xfrm>
+          <a:prstGeom prst="roundRect">
+            <a:avLst>
+              <a:gd name="adj" fmla="val 6000"/>
+            </a:avLst>
+          </a:prstGeom>
+          <a:solidFill>
+            <a:srgbClr val="F1F5F9"/>
+          </a:solidFill>
+          <a:ln>
+            <a:noFill/>
+          </a:ln>
+          <a:effectLst/>
+        </p:spPr>
+        <p:style>
+          <a:lnRef idx="1">
+            <a:schemeClr val="accent1"/>
+          </a:lnRef>
+          <a:fillRef idx="3">
+            <a:schemeClr val="accent1"/>
+          </a:fillRef>
+          <a:effectRef idx="2">
+            <a:schemeClr val="accent1"/>
+          </a:effectRef>
+          <a:fontRef idx="minor">
+            <a:schemeClr val="lt1"/>
+          </a:fontRef>
+        </p:style>
+        <p:txBody>
+          <a:bodyPr rtlCol="0" anchor="ctr"/>
+          <a:lstStyle/>
+          <a:p>
+            <a:pPr algn="ctr"/>
+          </a:p>
+        </p:txBody>
+      </p:sp>
+      <p:sp>
+        <p:nvSpPr>
+          <p:cNvPr id="17" name="TextBox 16"/>
+          <p:cNvSpPr txBox="1"/>
+          <p:nvPr/>
+        </p:nvSpPr>
+        <p:spPr>
+          <a:xfrm>
+            <a:off x="731520" y="4617720"/>
+            <a:ext cx="1554480" cy="822960"/>
+          </a:xfrm>
+          <a:prstGeom prst="rect">
+            <a:avLst/>
+          </a:prstGeom>
+          <a:noFill/>
+        </p:spPr>
+        <p:txBody>
+          <a:bodyPr wrap="square">
+            <a:spAutoFit/>
+          </a:bodyPr>
+          <a:lstStyle/>
+          <a:p>
+            <a:pPr>
+              <a:spcAft>
+                <a:spcPts val="800"/>
+              </a:spcAft>
+            </a:pPr>
+            <a:r>
+              <a:rPr sz="3800" b="1">
+                <a:solidFill>
+                  <a:srgbClr val="1F4E79"/>
+                </a:solidFill>
+              </a:rPr>
+              <a:t>3.5</a:t>
+            </a:r>
+          </a:p>
+        </p:txBody>
+      </p:sp>
+      <p:sp>
+        <p:nvSpPr>
+          <p:cNvPr id="18" name="TextBox 17"/>
+          <p:cNvSpPr txBox="1"/>
+          <p:nvPr/>
+        </p:nvSpPr>
+        <p:spPr>
+          <a:xfrm>
+            <a:off x="2194560" y="4526279"/>
+            <a:ext cx="4297680" cy="365760"/>
+          </a:xfrm>
+          <a:prstGeom prst="rect">
+            <a:avLst/>
+          </a:prstGeom>
+          <a:noFill/>
+        </p:spPr>
+        <p:txBody>
+          <a:bodyPr wrap="square">
+            <a:spAutoFit/>
+          </a:bodyPr>
+          <a:lstStyle/>
+          <a:p>
+            <a:pPr>
+              <a:spcAft>
+                <a:spcPts val="800"/>
+              </a:spcAft>
+            </a:pPr>
+            <a:r>
+              <a:rPr sz="1600" b="1">
+                <a:solidFill>
+                  <a:srgbClr val="222222"/>
+                </a:solidFill>
+              </a:rPr>
+              <a:t>3. Support and rider behaviour (±0.9)</a:t>
+            </a:r>
+          </a:p>
+        </p:txBody>
+      </p:sp>
+      <p:sp>
+        <p:nvSpPr>
+          <p:cNvPr id="19" name="TextBox 18"/>
+          <p:cNvSpPr txBox="1"/>
+          <p:nvPr/>
+        </p:nvSpPr>
+        <p:spPr>
+          <a:xfrm>
+            <a:off x="2194560" y="4892040"/>
+            <a:ext cx="4297680" cy="731520"/>
+          </a:xfrm>
+          <a:prstGeom prst="rect">
+            <a:avLst/>
+          </a:prstGeom>
+          <a:noFill/>
+        </p:spPr>
+        <p:txBody>
+          <a:bodyPr wrap="square">
+            <a:spAutoFit/>
+          </a:bodyPr>
+          <a:lstStyle/>
+          <a:p>
+            <a:pPr>
+              <a:spcAft>
+                <a:spcPts val="800"/>
+              </a:spcAft>
+            </a:pPr>
+            <a:r>
+              <a:rPr sz="1250" b="0">
+                <a:solidFill>
+                  <a:srgbClr val="222222"/>
+                </a:solidFill>
+              </a:rPr>
+              <a:t>Give a human agent path after the bot, shorten the first human reply, and coach riders on conduct.</a:t>
+            </a:r>
+          </a:p>
+        </p:txBody>
+      </p:sp>
+      <p:pic>
+        <p:nvPicPr>
+          <p:cNvPr id="20" name="Picture 19" descr="deck_stakes.png"/>
+          <p:cNvPicPr>
+            <a:picLocks noChangeAspect="1"/>
+          </p:cNvPicPr>
+          <p:nvPr/>
+        </p:nvPicPr>
+        <p:blipFill>
+          <a:blip r:embed="rId2"/>
+          <a:stretch>
+            <a:fillRect/>
+          </a:stretch>
+        </p:blipFill>
+        <p:spPr>
+          <a:xfrm>
+            <a:off x="6858000" y="1691640"/>
+            <a:ext cx="4754880" cy="3905794"/>
+          </a:xfrm>
+          <a:prstGeom prst="rect">
+            <a:avLst/>
+          </a:prstGeom>
+        </p:spPr>
+      </p:pic>
+      <p:sp>
+        <p:nvSpPr>
+          <p:cNvPr id="21" name="TextBox 20"/>
+          <p:cNvSpPr txBox="1"/>
+          <p:nvPr/>
+        </p:nvSpPr>
+        <p:spPr>
+          <a:xfrm>
+            <a:off x="594360" y="5852160"/>
+            <a:ext cx="10972800" cy="548640"/>
+          </a:xfrm>
+          <a:prstGeom prst="rect">
+            <a:avLst/>
+          </a:prstGeom>
+          <a:noFill/>
+        </p:spPr>
+        <p:txBody>
+          <a:bodyPr wrap="square">
+            <a:spAutoFit/>
+          </a:bodyPr>
+          <a:lstStyle/>
+          <a:p>
+            <a:pPr>
+              <a:spcAft>
+                <a:spcPts val="800"/>
+              </a:spcAft>
+            </a:pPr>
+            <a:r>
+              <a:rPr sz="1200" b="0">
+                <a:solidFill>
+                  <a:srgbClr val="6B7280"/>
+                </a:solidFill>
+              </a:rPr>
+              <a:t>Points at stake are the extra NPS points Zepto loses to each driver compared with Blinkit in Jul to Sep 2026. Matching the leader's rate would recover them. The ± is sampling error from the tagged sample.</a:t>
+            </a:r>
+          </a:p>
+        </p:txBody>
+      </p:sp>
+    </p:spTree>
+  </p:cSld>
+  <p:clrMapOvr>
+    <a:masterClrMapping/>
+  </p:clrMapOvr>
+</p:sld>
+</file>
+
+<file path=ppt/slides/slide7.xml><?xml version="1.0" encoding="utf-8"?>
+<p:sld xmlns:a="http://schemas.openxmlformats.org/drawingml/2006/main" xmlns:p="http://schemas.openxmlformats.org/presentationml/2006/main" xmlns:r="http://schemas.openxmlformats.org/officeDocument/2006/relationships">
+  <p:cSld>
+    <p:spTree>
+      <p:nvGrpSpPr>
+        <p:cNvPr id="1" name=""/>
+        <p:cNvGrpSpPr/>
+        <p:nvPr/>
+      </p:nvGrpSpPr>
+      <p:grpSpPr/>
+      <p:sp>
+        <p:nvSpPr>
+          <p:cNvPr id="2" name="Rectangle 1"/>
+          <p:cNvSpPr/>
+          <p:nvPr/>
+        </p:nvSpPr>
+        <p:spPr>
+          <a:xfrm>
+            <a:off x="0" y="0"/>
+            <a:ext cx="228600" cy="6858000"/>
+          </a:xfrm>
+          <a:prstGeom prst="rect">
+            <a:avLst/>
+          </a:prstGeom>
+          <a:solidFill>
+            <a:srgbClr val="1F4E79"/>
+          </a:solidFill>
+          <a:ln>
+            <a:noFill/>
+          </a:ln>
+          <a:effectLst/>
+        </p:spPr>
+        <p:style>
+          <a:lnRef idx="1">
+            <a:schemeClr val="accent1"/>
+          </a:lnRef>
+          <a:fillRef idx="3">
+            <a:schemeClr val="accent1"/>
+          </a:fillRef>
+          <a:effectRef idx="2">
+            <a:schemeClr val="accent1"/>
+          </a:effectRef>
+          <a:fontRef idx="minor">
+            <a:schemeClr val="lt1"/>
+          </a:fontRef>
+        </p:style>
+        <p:txBody>
+          <a:bodyPr rtlCol="0" anchor="ctr"/>
+          <a:lstStyle/>
+          <a:p>
+            <a:pPr algn="ctr"/>
+          </a:p>
+        </p:txBody>
+      </p:sp>
+      <p:sp>
+        <p:nvSpPr>
+          <p:cNvPr id="3" name="TextBox 2"/>
+          <p:cNvSpPr txBox="1"/>
+          <p:nvPr/>
+        </p:nvSpPr>
+        <p:spPr>
+          <a:xfrm>
+            <a:off x="594360" y="274320"/>
+            <a:ext cx="10972800" cy="320040"/>
+          </a:xfrm>
+          <a:prstGeom prst="rect">
+            <a:avLst/>
+          </a:prstGeom>
+          <a:noFill/>
+        </p:spPr>
+        <p:txBody>
+          <a:bodyPr wrap="square">
+            <a:spAutoFit/>
+          </a:bodyPr>
+          <a:lstStyle/>
+          <a:p>
+            <a:pPr>
+              <a:spcAft>
+                <a:spcPts val="800"/>
+              </a:spcAft>
+            </a:pPr>
+            <a:r>
+              <a:rPr sz="1200" b="1">
+                <a:solidFill>
+                  <a:srgbClr val="1F4E79"/>
+                </a:solidFill>
+              </a:rPr>
+              <a:t>METHOD AND LIMITATIONS</a:t>
+            </a:r>
+          </a:p>
+        </p:txBody>
+      </p:sp>
+      <p:sp>
+        <p:nvSpPr>
+          <p:cNvPr id="4" name="TextBox 3"/>
+          <p:cNvSpPr txBox="1"/>
+          <p:nvPr/>
+        </p:nvSpPr>
+        <p:spPr>
+          <a:xfrm>
+            <a:off x="594360" y="566928"/>
+            <a:ext cx="11064240" cy="914400"/>
+          </a:xfrm>
+          <a:prstGeom prst="rect">
+            <a:avLst/>
+          </a:prstGeom>
+          <a:noFill/>
+        </p:spPr>
+        <p:txBody>
+          <a:bodyPr wrap="square">
+            <a:spAutoFit/>
+          </a:bodyPr>
+          <a:lstStyle/>
+          <a:p>
+            <a:pPr>
+              <a:spcAft>
+                <a:spcPts val="800"/>
+              </a:spcAft>
+            </a:pPr>
+            <a:r>
+              <a:rPr sz="2400" b="1">
+                <a:solidFill>
+                  <a:srgbClr val="0F2A43"/>
+                </a:solidFill>
+              </a:rPr>
+              <a:t>The numbers are a review based proxy for NPS, tagged by a model and checked for consistency, not yet against human labels</a:t>
+            </a:r>
+          </a:p>
+        </p:txBody>
+      </p:sp>
+      <p:sp>
+        <p:nvSpPr>
+          <p:cNvPr id="5" name="Rectangle 4"/>
+          <p:cNvSpPr/>
+          <p:nvPr/>
+        </p:nvSpPr>
+        <p:spPr>
+          <a:xfrm>
+            <a:off x="594360" y="1481328"/>
+            <a:ext cx="11018520" cy="27432"/>
+          </a:xfrm>
+          <a:prstGeom prst="rect">
+            <a:avLst/>
+          </a:prstGeom>
+          <a:solidFill>
+            <a:srgbClr val="BBD3EA"/>
+          </a:solidFill>
+          <a:ln>
+            <a:noFill/>
+          </a:ln>
+          <a:effectLst/>
+        </p:spPr>
+        <p:style>
+          <a:lnRef idx="1">
+            <a:schemeClr val="accent1"/>
+          </a:lnRef>
+          <a:fillRef idx="3">
+            <a:schemeClr val="accent1"/>
+          </a:fillRef>
+          <a:effectRef idx="2">
+            <a:schemeClr val="accent1"/>
+          </a:effectRef>
+          <a:fontRef idx="minor">
+            <a:schemeClr val="lt1"/>
+          </a:fontRef>
+        </p:style>
+        <p:txBody>
+          <a:bodyPr rtlCol="0" anchor="ctr"/>
+          <a:lstStyle/>
+          <a:p>
+            <a:pPr algn="ctr"/>
+          </a:p>
+        </p:txBody>
+      </p:sp>
+      <p:sp>
+        <p:nvSpPr>
+          <p:cNvPr id="6" name="TextBox 5"/>
+          <p:cNvSpPr txBox="1"/>
+          <p:nvPr/>
+        </p:nvSpPr>
+        <p:spPr>
+          <a:xfrm>
+            <a:off x="594360" y="6446520"/>
+            <a:ext cx="9875520" cy="274320"/>
+          </a:xfrm>
+          <a:prstGeom prst="rect">
+            <a:avLst/>
+          </a:prstGeom>
+          <a:noFill/>
+        </p:spPr>
+        <p:txBody>
+          <a:bodyPr wrap="square">
+            <a:spAutoFit/>
+          </a:bodyPr>
+          <a:lstStyle/>
+          <a:p>
+            <a:pPr>
+              <a:spcAft>
+                <a:spcPts val="800"/>
+              </a:spcAft>
+            </a:pPr>
+            <a:r>
+              <a:rPr sz="1000" b="0">
+                <a:solidFill>
+                  <a:srgbClr val="6B7280"/>
+                </a:solidFill>
+              </a:rPr>
+              <a:t>Source: Google Play reviews, India, English, 1,112,946 reviews, Jan 2025 to Sep 2026. Figures from outputs/ in the repo.</a:t>
+            </a:r>
+          </a:p>
+        </p:txBody>
+      </p:sp>
+      <p:sp>
+        <p:nvSpPr>
+          <p:cNvPr id="7" name="TextBox 6"/>
+          <p:cNvSpPr txBox="1"/>
+          <p:nvPr/>
+        </p:nvSpPr>
+        <p:spPr>
+          <a:xfrm>
+            <a:off x="10972800" y="6446520"/>
+            <a:ext cx="640080" cy="274320"/>
+          </a:xfrm>
+          <a:prstGeom prst="rect">
+            <a:avLst/>
+          </a:prstGeom>
+          <a:noFill/>
+        </p:spPr>
+        <p:txBody>
+          <a:bodyPr wrap="square">
+            <a:spAutoFit/>
+          </a:bodyPr>
+          <a:lstStyle/>
+          <a:p>
+            <a:pPr algn="r">
+              <a:spcAft>
+                <a:spcPts val="800"/>
+              </a:spcAft>
+            </a:pPr>
+            <a:r>
+              <a:rPr sz="1000" b="0">
+                <a:solidFill>
+                  <a:srgbClr val="6B7280"/>
+                </a:solidFill>
+              </a:rPr>
+              <a:t>7</a:t>
+            </a:r>
+          </a:p>
+        </p:txBody>
+      </p:sp>
+      <p:sp>
+        <p:nvSpPr>
+          <p:cNvPr id="8" name="TextBox 7"/>
+          <p:cNvSpPr txBox="1"/>
+          <p:nvPr/>
+        </p:nvSpPr>
+        <p:spPr>
+          <a:xfrm>
+            <a:off x="594360" y="1645920"/>
+            <a:ext cx="5486400" cy="365760"/>
+          </a:xfrm>
+          <a:prstGeom prst="rect">
+            <a:avLst/>
+          </a:prstGeom>
+          <a:noFill/>
+        </p:spPr>
+        <p:txBody>
+          <a:bodyPr wrap="square">
+            <a:spAutoFit/>
+          </a:bodyPr>
+          <a:lstStyle/>
+          <a:p>
+            <a:pPr>
+              <a:spcAft>
+                <a:spcPts val="800"/>
+              </a:spcAft>
+            </a:pPr>
+            <a:r>
+              <a:rPr sz="1800" b="1">
+                <a:solidFill>
+                  <a:srgbClr val="1F4E79"/>
+                </a:solidFill>
+              </a:rPr>
+              <a:t>Method</a:t>
+            </a:r>
+          </a:p>
+        </p:txBody>
+      </p:sp>
+      <p:sp>
+        <p:nvSpPr>
+          <p:cNvPr id="9" name="TextBox 8"/>
+          <p:cNvSpPr txBox="1"/>
+          <p:nvPr/>
+        </p:nvSpPr>
+        <p:spPr>
+          <a:xfrm>
+            <a:off x="594360" y="2103120"/>
+            <a:ext cx="5486400" cy="4206240"/>
+          </a:xfrm>
+          <a:prstGeom prst="rect">
+            <a:avLst/>
+          </a:prstGeom>
+          <a:noFill/>
+        </p:spPr>
+        <p:txBody>
+          <a:bodyPr wrap="square">
+            <a:spAutoFit/>
+          </a:bodyPr>
+          <a:lstStyle/>
+          <a:p>
+            <a:pPr>
+              <a:spcAft>
+                <a:spcPts val="800"/>
+              </a:spcAft>
+            </a:pPr>
+            <a:r>
+              <a:rPr sz="1500" b="0">
+                <a:solidFill>
+                  <a:srgbClr val="222222"/>
+                </a:solidFill>
+              </a:rPr>
+              <a:t>Promoter 5 stars, passive 4, detractor 1 to 3. 1,112,946 reviews over 21 months.</a:t>
+            </a:r>
+          </a:p>
+          <a:p>
+            <a:pPr>
+              <a:spcAft>
+                <a:spcPts val="800"/>
+              </a:spcAft>
+            </a:pPr>
+            <a:r>
+              <a:rPr sz="1500" b="0">
+                <a:solidFill>
+                  <a:srgbClr val="222222"/>
+                </a:solidFill>
+              </a:rPr>
+              <a:t>21,000 detractor reviews (1,000 per app per quarter, 4 or more words) tagged to 8 complaint drivers by Claude in an interactive session.</a:t>
+            </a:r>
+          </a:p>
+          <a:p>
+            <a:pPr>
+              <a:spcAft>
+                <a:spcPts val="800"/>
+              </a:spcAft>
+            </a:pPr>
+            <a:r>
+              <a:rPr sz="1500" b="0">
+                <a:solidFill>
+                  <a:srgbClr val="222222"/>
+                </a:solidFill>
+              </a:rPr>
+              <a:t>Two independent tagging passes agreed on 96% of 100 reviews (kappa 0.954).</a:t>
+            </a:r>
+          </a:p>
+          <a:p>
+            <a:pPr>
+              <a:spcAft>
+                <a:spcPts val="800"/>
+              </a:spcAft>
+            </a:pPr>
+            <a:r>
+              <a:rPr sz="1500" b="0">
+                <a:solidFill>
+                  <a:srgbClr val="222222"/>
+                </a:solidFill>
+              </a:rPr>
+              <a:t>A keyword list agrees with the model tags on 52% (kappa 0.46).</a:t>
+            </a:r>
+          </a:p>
+          <a:p>
+            <a:pPr>
+              <a:spcAft>
+                <a:spcPts val="800"/>
+              </a:spcAft>
+            </a:pPr>
+            <a:r>
+              <a:rPr sz="1500" b="0">
+                <a:solidFill>
+                  <a:srgbClr val="222222"/>
+                </a:solidFill>
+              </a:rPr>
+              <a:t>The waterfall splits the 34.5 point gap exactly.</a:t>
+            </a:r>
+          </a:p>
+        </p:txBody>
+      </p:sp>
+      <p:pic>
+        <p:nvPicPr>
+          <p:cNvPr id="10" name="Picture 9" descr="deck_validation.png"/>
+          <p:cNvPicPr>
+            <a:picLocks noChangeAspect="1"/>
+          </p:cNvPicPr>
+          <p:nvPr/>
+        </p:nvPicPr>
+        <p:blipFill>
+          <a:blip r:embed="rId2"/>
+          <a:stretch>
+            <a:fillRect/>
+          </a:stretch>
+        </p:blipFill>
+        <p:spPr>
+          <a:xfrm>
+            <a:off x="6309360" y="1645920"/>
+            <a:ext cx="5303520" cy="2272937"/>
+          </a:xfrm>
+          <a:prstGeom prst="rect">
+            <a:avLst/>
+          </a:prstGeom>
+        </p:spPr>
+      </p:pic>
+      <p:sp>
+        <p:nvSpPr>
+          <p:cNvPr id="11" name="TextBox 10"/>
+          <p:cNvSpPr txBox="1"/>
+          <p:nvPr/>
+        </p:nvSpPr>
+        <p:spPr>
+          <a:xfrm>
+            <a:off x="6309360" y="4069080"/>
+            <a:ext cx="5303520" cy="365760"/>
+          </a:xfrm>
+          <a:prstGeom prst="rect">
+            <a:avLst/>
+          </a:prstGeom>
+          <a:noFill/>
+        </p:spPr>
+        <p:txBody>
+          <a:bodyPr wrap="square">
+            <a:spAutoFit/>
+          </a:bodyPr>
+          <a:lstStyle/>
+          <a:p>
+            <a:pPr>
+              <a:spcAft>
+                <a:spcPts val="800"/>
+              </a:spcAft>
+            </a:pPr>
+            <a:r>
+              <a:rPr sz="1800" b="1">
+                <a:solidFill>
+                  <a:srgbClr val="1F4E79"/>
+                </a:solidFill>
+              </a:rPr>
+              <a:t>Limitations</a:t>
+            </a:r>
+          </a:p>
+        </p:txBody>
+      </p:sp>
+      <p:sp>
+        <p:nvSpPr>
+          <p:cNvPr id="12" name="TextBox 11"/>
+          <p:cNvSpPr txBox="1"/>
+          <p:nvPr/>
+        </p:nvSpPr>
+        <p:spPr>
+          <a:xfrm>
+            <a:off x="6309360" y="4480560"/>
+            <a:ext cx="5303520" cy="1920240"/>
+          </a:xfrm>
+          <a:prstGeom prst="rect">
+            <a:avLst/>
+          </a:prstGeom>
+          <a:noFill/>
+        </p:spPr>
+        <p:txBody>
+          <a:bodyPr wrap="square">
+            <a:spAutoFit/>
+          </a:bodyPr>
+          <a:lstStyle/>
+          <a:p>
+            <a:pPr>
+              <a:spcAft>
+                <a:spcPts val="800"/>
+              </a:spcAft>
+            </a:pPr>
+            <a:r>
+              <a:rPr sz="1300" b="0">
+                <a:solidFill>
+                  <a:srgbClr val="222222"/>
+                </a:solidFill>
+              </a:rPr>
+              <a:t>Review based proxy, not survey NPS. Reviewers skew negative.</a:t>
+            </a:r>
+          </a:p>
+          <a:p>
+            <a:pPr>
+              <a:spcAft>
+                <a:spcPts val="800"/>
+              </a:spcAft>
+            </a:pPr>
+            <a:r>
+              <a:rPr sz="1300" b="0">
+                <a:solidFill>
+                  <a:srgbClr val="222222"/>
+                </a:solidFill>
+              </a:rPr>
+              <a:t>Play Store and English only. Tags not yet checked against human labels.</a:t>
+            </a:r>
+          </a:p>
+          <a:p>
+            <a:pPr>
+              <a:spcAft>
+                <a:spcPts val="800"/>
+              </a:spcAft>
+            </a:pPr>
+            <a:r>
+              <a:rPr sz="1300" b="0">
+                <a:solidFill>
+                  <a:srgbClr val="222222"/>
+                </a:solidFill>
+              </a:rPr>
+              <a:t>Driver bars carry up to ±1.0 points of sampling error, and Blinkit's lead over second place is inside its margin.</a:t>
             </a:r>
           </a:p>
         </p:txBody>

</xml_diff>

<commit_message>
redesign the deck cover with logos and a red palette
</commit_message>
<xml_diff>
--- a/deck/qcom_nps.pptx
+++ b/deck/qcom_nps.pptx
@@ -3102,14 +3102,14 @@
         </p:nvSpPr>
         <p:spPr>
           <a:xfrm>
-            <a:off x="0" y="0"/>
-            <a:ext cx="12191695" cy="6858000"/>
+            <a:off x="8138160" y="0"/>
+            <a:ext cx="4053535" cy="6858000"/>
           </a:xfrm>
           <a:prstGeom prst="rect">
             <a:avLst/>
           </a:prstGeom>
           <a:solidFill>
-            <a:srgbClr val="0F2A43"/>
+            <a:srgbClr val="CC0000"/>
           </a:solidFill>
           <a:ln>
             <a:noFill/>
@@ -3140,20 +3140,134 @@
       </p:sp>
       <p:sp>
         <p:nvSpPr>
-          <p:cNvPr id="3" name="Rectangle 2"/>
+          <p:cNvPr id="3" name="TextBox 2"/>
+          <p:cNvSpPr txBox="1"/>
+          <p:nvPr/>
+        </p:nvSpPr>
+        <p:spPr>
+          <a:xfrm>
+            <a:off x="8595360" y="685800"/>
+            <a:ext cx="3291840" cy="365760"/>
+          </a:xfrm>
+          <a:prstGeom prst="rect">
+            <a:avLst/>
+          </a:prstGeom>
+          <a:noFill/>
+        </p:spPr>
+        <p:txBody>
+          <a:bodyPr wrap="square">
+            <a:spAutoFit/>
+          </a:bodyPr>
+          <a:lstStyle/>
+          <a:p>
+            <a:pPr>
+              <a:spcAft>
+                <a:spcPts val="800"/>
+              </a:spcAft>
+            </a:pPr>
+            <a:r>
+              <a:rPr sz="1300" b="1">
+                <a:solidFill>
+                  <a:srgbClr val="F7D6D6"/>
+                </a:solidFill>
+              </a:rPr>
+              <a:t>AT A GLANCE</a:t>
+            </a:r>
+          </a:p>
+        </p:txBody>
+      </p:sp>
+      <p:sp>
+        <p:nvSpPr>
+          <p:cNvPr id="4" name="TextBox 3"/>
+          <p:cNvSpPr txBox="1"/>
+          <p:nvPr/>
+        </p:nvSpPr>
+        <p:spPr>
+          <a:xfrm>
+            <a:off x="8595360" y="1280160"/>
+            <a:ext cx="3383280" cy="822960"/>
+          </a:xfrm>
+          <a:prstGeom prst="rect">
+            <a:avLst/>
+          </a:prstGeom>
+          <a:noFill/>
+        </p:spPr>
+        <p:txBody>
+          <a:bodyPr wrap="square">
+            <a:spAutoFit/>
+          </a:bodyPr>
+          <a:lstStyle/>
+          <a:p>
+            <a:pPr>
+              <a:spcAft>
+                <a:spcPts val="800"/>
+              </a:spcAft>
+            </a:pPr>
+            <a:r>
+              <a:rPr sz="4000" b="1">
+                <a:solidFill>
+                  <a:srgbClr val="FFFFFF"/>
+                </a:solidFill>
+              </a:rPr>
+              <a:t>1,112,946</a:t>
+            </a:r>
+          </a:p>
+        </p:txBody>
+      </p:sp>
+      <p:sp>
+        <p:nvSpPr>
+          <p:cNvPr id="5" name="TextBox 4"/>
+          <p:cNvSpPr txBox="1"/>
+          <p:nvPr/>
+        </p:nvSpPr>
+        <p:spPr>
+          <a:xfrm>
+            <a:off x="8595360" y="2148840"/>
+            <a:ext cx="3200400" cy="731520"/>
+          </a:xfrm>
+          <a:prstGeom prst="rect">
+            <a:avLst/>
+          </a:prstGeom>
+          <a:noFill/>
+        </p:spPr>
+        <p:txBody>
+          <a:bodyPr wrap="square">
+            <a:spAutoFit/>
+          </a:bodyPr>
+          <a:lstStyle/>
+          <a:p>
+            <a:pPr>
+              <a:spcAft>
+                <a:spcPts val="800"/>
+              </a:spcAft>
+            </a:pPr>
+            <a:r>
+              <a:rPr sz="1400" b="0">
+                <a:solidFill>
+                  <a:srgbClr val="F7D6D6"/>
+                </a:solidFill>
+              </a:rPr>
+              <a:t>public reviews, Jan 2025 to Sep 2026</a:t>
+            </a:r>
+          </a:p>
+        </p:txBody>
+      </p:sp>
+      <p:sp>
+        <p:nvSpPr>
+          <p:cNvPr id="6" name="Rectangle 5"/>
           <p:cNvSpPr/>
           <p:nvPr/>
         </p:nvSpPr>
         <p:spPr>
           <a:xfrm>
-            <a:off x="731520" y="1417320"/>
-            <a:ext cx="1005840" cy="73152"/>
+            <a:off x="8595360" y="3017520"/>
+            <a:ext cx="3108960" cy="13716"/>
           </a:xfrm>
           <a:prstGeom prst="rect">
             <a:avLst/>
           </a:prstGeom>
           <a:solidFill>
-            <a:srgbClr val="BBD3EA"/>
+            <a:srgbClr val="F7D6D6"/>
           </a:solidFill>
           <a:ln>
             <a:noFill/>
@@ -3184,14 +3298,14 @@
       </p:sp>
       <p:sp>
         <p:nvSpPr>
-          <p:cNvPr id="4" name="TextBox 3"/>
+          <p:cNvPr id="7" name="TextBox 6"/>
           <p:cNvSpPr txBox="1"/>
           <p:nvPr/>
         </p:nvSpPr>
         <p:spPr>
           <a:xfrm>
-            <a:off x="731520" y="1645920"/>
-            <a:ext cx="10515600" cy="1097280"/>
+            <a:off x="8595360" y="3063239"/>
+            <a:ext cx="3383280" cy="822960"/>
           </a:xfrm>
           <a:prstGeom prst="rect">
             <a:avLst/>
@@ -3210,26 +3324,26 @@
               </a:spcAft>
             </a:pPr>
             <a:r>
-              <a:rPr sz="5000" b="1">
+              <a:rPr sz="4000" b="1">
                 <a:solidFill>
                   <a:srgbClr val="FFFFFF"/>
                 </a:solidFill>
               </a:rPr>
-              <a:t>Quick-Commerce NPS Benchmark</a:t>
-            </a:r>
-          </a:p>
-        </p:txBody>
-      </p:sp>
-      <p:sp>
-        <p:nvSpPr>
-          <p:cNvPr id="5" name="TextBox 4"/>
+              <a:t>21,000</a:t>
+            </a:r>
+          </a:p>
+        </p:txBody>
+      </p:sp>
+      <p:sp>
+        <p:nvSpPr>
+          <p:cNvPr id="8" name="TextBox 7"/>
           <p:cNvSpPr txBox="1"/>
           <p:nvPr/>
         </p:nvSpPr>
         <p:spPr>
           <a:xfrm>
-            <a:off x="731520" y="2788920"/>
-            <a:ext cx="10058400" cy="1005840"/>
+            <a:off x="8595360" y="3931920"/>
+            <a:ext cx="3200400" cy="731520"/>
           </a:xfrm>
           <a:prstGeom prst="rect">
             <a:avLst/>
@@ -3248,26 +3362,70 @@
               </a:spcAft>
             </a:pPr>
             <a:r>
-              <a:rPr sz="2400" b="0">
-                <a:solidFill>
-                  <a:srgbClr val="BBD3EA"/>
+              <a:rPr sz="1400" b="0">
+                <a:solidFill>
+                  <a:srgbClr val="F7D6D6"/>
                 </a:solidFill>
               </a:rPr>
-              <a:t>What 1.1 million Google Play reviews say about Blinkit, Zepto and Swiggy Instamart</a:t>
-            </a:r>
-          </a:p>
-        </p:txBody>
-      </p:sp>
-      <p:sp>
-        <p:nvSpPr>
-          <p:cNvPr id="6" name="TextBox 5"/>
+              <a:t>detractor reviews tagged to 8 complaint drivers</a:t>
+            </a:r>
+          </a:p>
+        </p:txBody>
+      </p:sp>
+      <p:sp>
+        <p:nvSpPr>
+          <p:cNvPr id="9" name="Rectangle 8"/>
+          <p:cNvSpPr/>
+          <p:nvPr/>
+        </p:nvSpPr>
+        <p:spPr>
+          <a:xfrm>
+            <a:off x="8595360" y="4800600"/>
+            <a:ext cx="3108960" cy="13716"/>
+          </a:xfrm>
+          <a:prstGeom prst="rect">
+            <a:avLst/>
+          </a:prstGeom>
+          <a:solidFill>
+            <a:srgbClr val="F7D6D6"/>
+          </a:solidFill>
+          <a:ln>
+            <a:noFill/>
+          </a:ln>
+          <a:effectLst/>
+        </p:spPr>
+        <p:style>
+          <a:lnRef idx="1">
+            <a:schemeClr val="accent1"/>
+          </a:lnRef>
+          <a:fillRef idx="3">
+            <a:schemeClr val="accent1"/>
+          </a:fillRef>
+          <a:effectRef idx="2">
+            <a:schemeClr val="accent1"/>
+          </a:effectRef>
+          <a:fontRef idx="minor">
+            <a:schemeClr val="lt1"/>
+          </a:fontRef>
+        </p:style>
+        <p:txBody>
+          <a:bodyPr rtlCol="0" anchor="ctr"/>
+          <a:lstStyle/>
+          <a:p>
+            <a:pPr algn="ctr"/>
+          </a:p>
+        </p:txBody>
+      </p:sp>
+      <p:sp>
+        <p:nvSpPr>
+          <p:cNvPr id="10" name="TextBox 9"/>
           <p:cNvSpPr txBox="1"/>
           <p:nvPr/>
         </p:nvSpPr>
         <p:spPr>
           <a:xfrm>
-            <a:off x="731520" y="4526280"/>
-            <a:ext cx="3566160" cy="731520"/>
+            <a:off x="8595360" y="4846320"/>
+            <a:ext cx="3383280" cy="822960"/>
           </a:xfrm>
           <a:prstGeom prst="rect">
             <a:avLst/>
@@ -3286,26 +3444,26 @@
               </a:spcAft>
             </a:pPr>
             <a:r>
-              <a:rPr sz="3600" b="1">
+              <a:rPr sz="4000" b="1">
                 <a:solidFill>
                   <a:srgbClr val="FFFFFF"/>
                 </a:solidFill>
               </a:rPr>
-              <a:t>1,112,946</a:t>
-            </a:r>
-          </a:p>
-        </p:txBody>
-      </p:sp>
-      <p:sp>
-        <p:nvSpPr>
-          <p:cNvPr id="7" name="TextBox 6"/>
+              <a:t>34.5 points</a:t>
+            </a:r>
+          </a:p>
+        </p:txBody>
+      </p:sp>
+      <p:sp>
+        <p:nvSpPr>
+          <p:cNvPr id="11" name="TextBox 10"/>
           <p:cNvSpPr txBox="1"/>
           <p:nvPr/>
         </p:nvSpPr>
         <p:spPr>
           <a:xfrm>
-            <a:off x="731520" y="5257800"/>
-            <a:ext cx="3383280" cy="731520"/>
+            <a:off x="8595360" y="5715000"/>
+            <a:ext cx="3200400" cy="731520"/>
           </a:xfrm>
           <a:prstGeom prst="rect">
             <a:avLst/>
@@ -3326,24 +3484,68 @@
             <a:r>
               <a:rPr sz="1400" b="0">
                 <a:solidFill>
-                  <a:srgbClr val="BBD3EA"/>
+                  <a:srgbClr val="F7D6D6"/>
                 </a:solidFill>
               </a:rPr>
-              <a:t>public reviews, Jan 2025 to Sep 2026</a:t>
-            </a:r>
-          </a:p>
-        </p:txBody>
-      </p:sp>
-      <p:sp>
-        <p:nvSpPr>
-          <p:cNvPr id="8" name="TextBox 7"/>
+              <a:t>NPS gap, Blinkit vs Zepto, Jul to Sep 2026</a:t>
+            </a:r>
+          </a:p>
+        </p:txBody>
+      </p:sp>
+      <p:sp>
+        <p:nvSpPr>
+          <p:cNvPr id="12" name="Rectangle 11"/>
+          <p:cNvSpPr/>
+          <p:nvPr/>
+        </p:nvSpPr>
+        <p:spPr>
+          <a:xfrm>
+            <a:off x="731520" y="914400"/>
+            <a:ext cx="822960" cy="82296"/>
+          </a:xfrm>
+          <a:prstGeom prst="rect">
+            <a:avLst/>
+          </a:prstGeom>
+          <a:solidFill>
+            <a:srgbClr val="CC0000"/>
+          </a:solidFill>
+          <a:ln>
+            <a:noFill/>
+          </a:ln>
+          <a:effectLst/>
+        </p:spPr>
+        <p:style>
+          <a:lnRef idx="1">
+            <a:schemeClr val="accent1"/>
+          </a:lnRef>
+          <a:fillRef idx="3">
+            <a:schemeClr val="accent1"/>
+          </a:fillRef>
+          <a:effectRef idx="2">
+            <a:schemeClr val="accent1"/>
+          </a:effectRef>
+          <a:fontRef idx="minor">
+            <a:schemeClr val="lt1"/>
+          </a:fontRef>
+        </p:style>
+        <p:txBody>
+          <a:bodyPr rtlCol="0" anchor="ctr"/>
+          <a:lstStyle/>
+          <a:p>
+            <a:pPr algn="ctr"/>
+          </a:p>
+        </p:txBody>
+      </p:sp>
+      <p:sp>
+        <p:nvSpPr>
+          <p:cNvPr id="13" name="TextBox 12"/>
           <p:cNvSpPr txBox="1"/>
           <p:nvPr/>
         </p:nvSpPr>
         <p:spPr>
           <a:xfrm>
-            <a:off x="4480559" y="4526280"/>
-            <a:ext cx="3566160" cy="731520"/>
+            <a:off x="731520" y="1097280"/>
+            <a:ext cx="6858000" cy="365760"/>
           </a:xfrm>
           <a:prstGeom prst="rect">
             <a:avLst/>
@@ -3362,26 +3564,26 @@
               </a:spcAft>
             </a:pPr>
             <a:r>
-              <a:rPr sz="3600" b="1">
-                <a:solidFill>
-                  <a:srgbClr val="FFFFFF"/>
+              <a:rPr sz="1300" b="1">
+                <a:solidFill>
+                  <a:srgbClr val="CC0000"/>
                 </a:solidFill>
               </a:rPr>
-              <a:t>21,000</a:t>
-            </a:r>
-          </a:p>
-        </p:txBody>
-      </p:sp>
-      <p:sp>
-        <p:nvSpPr>
-          <p:cNvPr id="9" name="TextBox 8"/>
+              <a:t>CASE STUDY  |  QUICK COMMERCE</a:t>
+            </a:r>
+          </a:p>
+        </p:txBody>
+      </p:sp>
+      <p:sp>
+        <p:nvSpPr>
+          <p:cNvPr id="14" name="TextBox 13"/>
           <p:cNvSpPr txBox="1"/>
           <p:nvPr/>
         </p:nvSpPr>
         <p:spPr>
           <a:xfrm>
-            <a:off x="4480559" y="5257800"/>
-            <a:ext cx="3383280" cy="731520"/>
+            <a:off x="731520" y="1508760"/>
+            <a:ext cx="7223760" cy="2011680"/>
           </a:xfrm>
           <a:prstGeom prst="rect">
             <a:avLst/>
@@ -3400,37 +3602,14 @@
               </a:spcAft>
             </a:pPr>
             <a:r>
-              <a:rPr sz="1400" b="0">
-                <a:solidFill>
-                  <a:srgbClr val="BBD3EA"/>
+              <a:rPr sz="4600" b="1">
+                <a:solidFill>
+                  <a:srgbClr val="1A1A1A"/>
                 </a:solidFill>
               </a:rPr>
-              <a:t>detractor reviews tagged to 8 complaint drivers</a:t>
-            </a:r>
-          </a:p>
-        </p:txBody>
-      </p:sp>
-      <p:sp>
-        <p:nvSpPr>
-          <p:cNvPr id="10" name="TextBox 9"/>
-          <p:cNvSpPr txBox="1"/>
-          <p:nvPr/>
-        </p:nvSpPr>
-        <p:spPr>
-          <a:xfrm>
-            <a:off x="8229600" y="4526280"/>
-            <a:ext cx="3566160" cy="731520"/>
-          </a:xfrm>
-          <a:prstGeom prst="rect">
-            <a:avLst/>
-          </a:prstGeom>
-          <a:noFill/>
-        </p:spPr>
-        <p:txBody>
-          <a:bodyPr wrap="square">
-            <a:spAutoFit/>
-          </a:bodyPr>
-          <a:lstStyle/>
+              <a:t>Quick-Commerce</a:t>
+            </a:r>
+          </a:p>
           <a:p>
             <a:pPr>
               <a:spcAft>
@@ -3438,26 +3617,26 @@
               </a:spcAft>
             </a:pPr>
             <a:r>
-              <a:rPr sz="3600" b="1">
-                <a:solidFill>
-                  <a:srgbClr val="FFFFFF"/>
+              <a:rPr sz="4600" b="1">
+                <a:solidFill>
+                  <a:srgbClr val="1A1A1A"/>
                 </a:solidFill>
               </a:rPr>
-              <a:t>34.5 points</a:t>
-            </a:r>
-          </a:p>
-        </p:txBody>
-      </p:sp>
-      <p:sp>
-        <p:nvSpPr>
-          <p:cNvPr id="11" name="TextBox 10"/>
+              <a:t>NPS Benchmark</a:t>
+            </a:r>
+          </a:p>
+        </p:txBody>
+      </p:sp>
+      <p:sp>
+        <p:nvSpPr>
+          <p:cNvPr id="15" name="TextBox 14"/>
           <p:cNvSpPr txBox="1"/>
           <p:nvPr/>
         </p:nvSpPr>
         <p:spPr>
           <a:xfrm>
-            <a:off x="8229600" y="5257800"/>
-            <a:ext cx="3383280" cy="731520"/>
+            <a:off x="731520" y="3383280"/>
+            <a:ext cx="6858000" cy="1097280"/>
           </a:xfrm>
           <a:prstGeom prst="rect">
             <a:avLst/>
@@ -3476,26 +3655,26 @@
               </a:spcAft>
             </a:pPr>
             <a:r>
-              <a:rPr sz="1400" b="0">
-                <a:solidFill>
-                  <a:srgbClr val="BBD3EA"/>
+              <a:rPr sz="2000" b="0">
+                <a:solidFill>
+                  <a:srgbClr val="6B6B6B"/>
                 </a:solidFill>
               </a:rPr>
-              <a:t>NPS gap, Blinkit vs Zepto, Jul to Sep 2026</a:t>
-            </a:r>
-          </a:p>
-        </p:txBody>
-      </p:sp>
-      <p:sp>
-        <p:nvSpPr>
-          <p:cNvPr id="12" name="TextBox 11"/>
+              <a:t>What 1.1 million Google Play reviews say about Blinkit, Zepto and Swiggy Instamart</a:t>
+            </a:r>
+          </a:p>
+        </p:txBody>
+      </p:sp>
+      <p:sp>
+        <p:nvSpPr>
+          <p:cNvPr id="16" name="TextBox 15"/>
           <p:cNvSpPr txBox="1"/>
           <p:nvPr/>
         </p:nvSpPr>
         <p:spPr>
           <a:xfrm>
-            <a:off x="731520" y="6263640"/>
-            <a:ext cx="10058400" cy="365760"/>
+            <a:off x="731520" y="4434840"/>
+            <a:ext cx="3657600" cy="274320"/>
           </a:xfrm>
           <a:prstGeom prst="rect">
             <a:avLst/>
@@ -3514,9 +3693,377 @@
               </a:spcAft>
             </a:pPr>
             <a:r>
-              <a:rPr sz="1300" b="0">
-                <a:solidFill>
-                  <a:srgbClr val="BBD3EA"/>
+              <a:rPr sz="1100" b="1">
+                <a:solidFill>
+                  <a:srgbClr val="6B6B6B"/>
+                </a:solidFill>
+              </a:rPr>
+              <a:t>APPS COMPARED</a:t>
+            </a:r>
+          </a:p>
+        </p:txBody>
+      </p:sp>
+      <p:sp>
+        <p:nvSpPr>
+          <p:cNvPr id="17" name="TextBox 16"/>
+          <p:cNvSpPr txBox="1"/>
+          <p:nvPr/>
+        </p:nvSpPr>
+        <p:spPr>
+          <a:xfrm>
+            <a:off x="5120640" y="4434840"/>
+            <a:ext cx="2743200" cy="274320"/>
+          </a:xfrm>
+          <a:prstGeom prst="rect">
+            <a:avLst/>
+          </a:prstGeom>
+          <a:noFill/>
+        </p:spPr>
+        <p:txBody>
+          <a:bodyPr wrap="square">
+            <a:spAutoFit/>
+          </a:bodyPr>
+          <a:lstStyle/>
+          <a:p>
+            <a:pPr>
+              <a:spcAft>
+                <a:spcPts val="800"/>
+              </a:spcAft>
+            </a:pPr>
+            <a:r>
+              <a:rPr sz="1100" b="1">
+                <a:solidFill>
+                  <a:srgbClr val="6B6B6B"/>
+                </a:solidFill>
+              </a:rPr>
+              <a:t>DATA SOURCE</a:t>
+            </a:r>
+          </a:p>
+        </p:txBody>
+      </p:sp>
+      <p:sp>
+        <p:nvSpPr>
+          <p:cNvPr id="18" name="Rectangle 17"/>
+          <p:cNvSpPr/>
+          <p:nvPr/>
+        </p:nvSpPr>
+        <p:spPr>
+          <a:xfrm>
+            <a:off x="4754880" y="4754880"/>
+            <a:ext cx="13716" cy="1280160"/>
+          </a:xfrm>
+          <a:prstGeom prst="rect">
+            <a:avLst/>
+          </a:prstGeom>
+          <a:solidFill>
+            <a:srgbClr val="D9D9D9"/>
+          </a:solidFill>
+          <a:ln>
+            <a:noFill/>
+          </a:ln>
+          <a:effectLst/>
+        </p:spPr>
+        <p:style>
+          <a:lnRef idx="1">
+            <a:schemeClr val="accent1"/>
+          </a:lnRef>
+          <a:fillRef idx="3">
+            <a:schemeClr val="accent1"/>
+          </a:fillRef>
+          <a:effectRef idx="2">
+            <a:schemeClr val="accent1"/>
+          </a:effectRef>
+          <a:fontRef idx="minor">
+            <a:schemeClr val="lt1"/>
+          </a:fontRef>
+        </p:style>
+        <p:txBody>
+          <a:bodyPr rtlCol="0" anchor="ctr"/>
+          <a:lstStyle/>
+          <a:p>
+            <a:pPr algn="ctr"/>
+          </a:p>
+        </p:txBody>
+      </p:sp>
+      <p:pic>
+        <p:nvPicPr>
+          <p:cNvPr id="19" name="Picture 18" descr="blinkit.png"/>
+          <p:cNvPicPr>
+            <a:picLocks noChangeAspect="1"/>
+          </p:cNvPicPr>
+          <p:nvPr/>
+        </p:nvPicPr>
+        <p:blipFill>
+          <a:blip r:embed="rId2"/>
+          <a:stretch>
+            <a:fillRect/>
+          </a:stretch>
+        </p:blipFill>
+        <p:spPr>
+          <a:xfrm>
+            <a:off x="731520" y="4754880"/>
+            <a:ext cx="960120" cy="960120"/>
+          </a:xfrm>
+          <a:prstGeom prst="rect">
+            <a:avLst/>
+          </a:prstGeom>
+        </p:spPr>
+      </p:pic>
+      <p:sp>
+        <p:nvSpPr>
+          <p:cNvPr id="20" name="TextBox 19"/>
+          <p:cNvSpPr txBox="1"/>
+          <p:nvPr/>
+        </p:nvSpPr>
+        <p:spPr>
+          <a:xfrm>
+            <a:off x="640080" y="5760720"/>
+            <a:ext cx="1143000" cy="274320"/>
+          </a:xfrm>
+          <a:prstGeom prst="rect">
+            <a:avLst/>
+          </a:prstGeom>
+          <a:noFill/>
+        </p:spPr>
+        <p:txBody>
+          <a:bodyPr wrap="square">
+            <a:spAutoFit/>
+          </a:bodyPr>
+          <a:lstStyle/>
+          <a:p>
+            <a:pPr algn="ctr">
+              <a:spcAft>
+                <a:spcPts val="800"/>
+              </a:spcAft>
+            </a:pPr>
+            <a:r>
+              <a:rPr sz="1100" b="0">
+                <a:solidFill>
+                  <a:srgbClr val="6B6B6B"/>
+                </a:solidFill>
+              </a:rPr>
+              <a:t>Blinkit</a:t>
+            </a:r>
+          </a:p>
+        </p:txBody>
+      </p:sp>
+      <p:pic>
+        <p:nvPicPr>
+          <p:cNvPr id="21" name="Picture 20" descr="zepto.png"/>
+          <p:cNvPicPr>
+            <a:picLocks noChangeAspect="1"/>
+          </p:cNvPicPr>
+          <p:nvPr/>
+        </p:nvPicPr>
+        <p:blipFill>
+          <a:blip r:embed="rId3"/>
+          <a:stretch>
+            <a:fillRect/>
+          </a:stretch>
+        </p:blipFill>
+        <p:spPr>
+          <a:xfrm>
+            <a:off x="1965960" y="4754880"/>
+            <a:ext cx="960120" cy="960120"/>
+          </a:xfrm>
+          <a:prstGeom prst="rect">
+            <a:avLst/>
+          </a:prstGeom>
+        </p:spPr>
+      </p:pic>
+      <p:sp>
+        <p:nvSpPr>
+          <p:cNvPr id="22" name="TextBox 21"/>
+          <p:cNvSpPr txBox="1"/>
+          <p:nvPr/>
+        </p:nvSpPr>
+        <p:spPr>
+          <a:xfrm>
+            <a:off x="1874519" y="5760720"/>
+            <a:ext cx="1143000" cy="274320"/>
+          </a:xfrm>
+          <a:prstGeom prst="rect">
+            <a:avLst/>
+          </a:prstGeom>
+          <a:noFill/>
+        </p:spPr>
+        <p:txBody>
+          <a:bodyPr wrap="square">
+            <a:spAutoFit/>
+          </a:bodyPr>
+          <a:lstStyle/>
+          <a:p>
+            <a:pPr algn="ctr">
+              <a:spcAft>
+                <a:spcPts val="800"/>
+              </a:spcAft>
+            </a:pPr>
+            <a:r>
+              <a:rPr sz="1100" b="0">
+                <a:solidFill>
+                  <a:srgbClr val="6B6B6B"/>
+                </a:solidFill>
+              </a:rPr>
+              <a:t>Zepto</a:t>
+            </a:r>
+          </a:p>
+        </p:txBody>
+      </p:sp>
+      <p:pic>
+        <p:nvPicPr>
+          <p:cNvPr id="23" name="Picture 22" descr="instamart.png"/>
+          <p:cNvPicPr>
+            <a:picLocks noChangeAspect="1"/>
+          </p:cNvPicPr>
+          <p:nvPr/>
+        </p:nvPicPr>
+        <p:blipFill>
+          <a:blip r:embed="rId4"/>
+          <a:stretch>
+            <a:fillRect/>
+          </a:stretch>
+        </p:blipFill>
+        <p:spPr>
+          <a:xfrm>
+            <a:off x="3200400" y="4754880"/>
+            <a:ext cx="960120" cy="960120"/>
+          </a:xfrm>
+          <a:prstGeom prst="rect">
+            <a:avLst/>
+          </a:prstGeom>
+        </p:spPr>
+      </p:pic>
+      <p:sp>
+        <p:nvSpPr>
+          <p:cNvPr id="24" name="TextBox 23"/>
+          <p:cNvSpPr txBox="1"/>
+          <p:nvPr/>
+        </p:nvSpPr>
+        <p:spPr>
+          <a:xfrm>
+            <a:off x="3108960" y="5760720"/>
+            <a:ext cx="1143000" cy="274320"/>
+          </a:xfrm>
+          <a:prstGeom prst="rect">
+            <a:avLst/>
+          </a:prstGeom>
+          <a:noFill/>
+        </p:spPr>
+        <p:txBody>
+          <a:bodyPr wrap="square">
+            <a:spAutoFit/>
+          </a:bodyPr>
+          <a:lstStyle/>
+          <a:p>
+            <a:pPr algn="ctr">
+              <a:spcAft>
+                <a:spcPts val="800"/>
+              </a:spcAft>
+            </a:pPr>
+            <a:r>
+              <a:rPr sz="1100" b="0">
+                <a:solidFill>
+                  <a:srgbClr val="6B6B6B"/>
+                </a:solidFill>
+              </a:rPr>
+              <a:t>Instamart</a:t>
+            </a:r>
+          </a:p>
+        </p:txBody>
+      </p:sp>
+      <p:pic>
+        <p:nvPicPr>
+          <p:cNvPr id="25" name="Picture 24" descr="googleplay.png"/>
+          <p:cNvPicPr>
+            <a:picLocks noChangeAspect="1"/>
+          </p:cNvPicPr>
+          <p:nvPr/>
+        </p:nvPicPr>
+        <p:blipFill>
+          <a:blip r:embed="rId5"/>
+          <a:stretch>
+            <a:fillRect/>
+          </a:stretch>
+        </p:blipFill>
+        <p:spPr>
+          <a:xfrm>
+            <a:off x="5257800" y="4754880"/>
+            <a:ext cx="869543" cy="960120"/>
+          </a:xfrm>
+          <a:prstGeom prst="rect">
+            <a:avLst/>
+          </a:prstGeom>
+        </p:spPr>
+      </p:pic>
+      <p:sp>
+        <p:nvSpPr>
+          <p:cNvPr id="26" name="TextBox 25"/>
+          <p:cNvSpPr txBox="1"/>
+          <p:nvPr/>
+        </p:nvSpPr>
+        <p:spPr>
+          <a:xfrm>
+            <a:off x="5120640" y="5760720"/>
+            <a:ext cx="1143000" cy="274320"/>
+          </a:xfrm>
+          <a:prstGeom prst="rect">
+            <a:avLst/>
+          </a:prstGeom>
+          <a:noFill/>
+        </p:spPr>
+        <p:txBody>
+          <a:bodyPr wrap="square">
+            <a:spAutoFit/>
+          </a:bodyPr>
+          <a:lstStyle/>
+          <a:p>
+            <a:pPr algn="ctr">
+              <a:spcAft>
+                <a:spcPts val="800"/>
+              </a:spcAft>
+            </a:pPr>
+            <a:r>
+              <a:rPr sz="1100" b="0">
+                <a:solidFill>
+                  <a:srgbClr val="6B6B6B"/>
+                </a:solidFill>
+              </a:rPr>
+              <a:t>Google Play</a:t>
+            </a:r>
+          </a:p>
+        </p:txBody>
+      </p:sp>
+      <p:sp>
+        <p:nvSpPr>
+          <p:cNvPr id="27" name="TextBox 26"/>
+          <p:cNvSpPr txBox="1"/>
+          <p:nvPr/>
+        </p:nvSpPr>
+        <p:spPr>
+          <a:xfrm>
+            <a:off x="731520" y="6263640"/>
+            <a:ext cx="7132320" cy="365760"/>
+          </a:xfrm>
+          <a:prstGeom prst="rect">
+            <a:avLst/>
+          </a:prstGeom>
+          <a:noFill/>
+        </p:spPr>
+        <p:txBody>
+          <a:bodyPr wrap="square">
+            <a:spAutoFit/>
+          </a:bodyPr>
+          <a:lstStyle/>
+          <a:p>
+            <a:pPr>
+              <a:spcAft>
+                <a:spcPts val="800"/>
+              </a:spcAft>
+            </a:pPr>
+            <a:r>
+              <a:rPr sz="1200" b="0">
+                <a:solidFill>
+                  <a:srgbClr val="6B6B6B"/>
                 </a:solidFill>
               </a:rPr>
               <a:t>Sri Kaasyap Vepa  |  A review based NPS proxy with a 95% margin of error</a:t>
@@ -3557,7 +4104,7 @@
             <a:avLst/>
           </a:prstGeom>
           <a:solidFill>
-            <a:srgbClr val="1F4E79"/>
+            <a:srgbClr val="CC0000"/>
           </a:solidFill>
           <a:ln>
             <a:noFill/>
@@ -3616,7 +4163,7 @@
             <a:r>
               <a:rPr sz="1200" b="1">
                 <a:solidFill>
-                  <a:srgbClr val="1F4E79"/>
+                  <a:srgbClr val="CC0000"/>
                 </a:solidFill>
               </a:rPr>
               <a:t>EXECUTIVE SUMMARY</a:t>
@@ -3654,7 +4201,7 @@
             <a:r>
               <a:rPr sz="2400" b="1">
                 <a:solidFill>
-                  <a:srgbClr val="0F2A43"/>
+                  <a:srgbClr val="1A1A1A"/>
                 </a:solidFill>
               </a:rPr>
               <a:t>Blinkit leads Zepto by 34.5 NPS points in Jul to Sep 2026, and quality and freshness and missing or wrong items explain 10.3 of them</a:t>
@@ -3677,7 +4224,7 @@
             <a:avLst/>
           </a:prstGeom>
           <a:solidFill>
-            <a:srgbClr val="BBD3EA"/>
+            <a:srgbClr val="D9D9D9"/>
           </a:solidFill>
           <a:ln>
             <a:noFill/>
@@ -3736,7 +4283,7 @@
             <a:r>
               <a:rPr sz="1000" b="0">
                 <a:solidFill>
-                  <a:srgbClr val="6B7280"/>
+                  <a:srgbClr val="6B6B6B"/>
                 </a:solidFill>
               </a:rPr>
               <a:t>Source: Google Play reviews, India, English, 1,112,946 reviews, Jan 2025 to Sep 2026. Figures from outputs/ in the repo.</a:t>
@@ -3774,7 +4321,7 @@
             <a:r>
               <a:rPr sz="1000" b="0">
                 <a:solidFill>
-                  <a:srgbClr val="6B7280"/>
+                  <a:srgbClr val="6B6B6B"/>
                 </a:solidFill>
               </a:rPr>
               <a:t>2</a:t>
@@ -3799,7 +4346,7 @@
             </a:avLst>
           </a:prstGeom>
           <a:solidFill>
-            <a:srgbClr val="F1F5F9"/>
+            <a:srgbClr val="F2F2F2"/>
           </a:solidFill>
           <a:ln>
             <a:noFill/>
@@ -3828,16 +4375,40 @@
           </a:p>
         </p:txBody>
       </p:sp>
-      <p:sp>
-        <p:nvSpPr>
-          <p:cNvPr id="9" name="TextBox 8"/>
+      <p:pic>
+        <p:nvPicPr>
+          <p:cNvPr id="9" name="Picture 8" descr="blinkit.png"/>
+          <p:cNvPicPr>
+            <a:picLocks noChangeAspect="1"/>
+          </p:cNvPicPr>
+          <p:nvPr/>
+        </p:nvPicPr>
+        <p:blipFill>
+          <a:blip r:embed="rId2"/>
+          <a:stretch>
+            <a:fillRect/>
+          </a:stretch>
+        </p:blipFill>
+        <p:spPr>
+          <a:xfrm>
+            <a:off x="777240" y="1874519"/>
+            <a:ext cx="868680" cy="868680"/>
+          </a:xfrm>
+          <a:prstGeom prst="rect">
+            <a:avLst/>
+          </a:prstGeom>
+        </p:spPr>
+      </p:pic>
+      <p:sp>
+        <p:nvSpPr>
+          <p:cNvPr id="10" name="TextBox 9"/>
           <p:cNvSpPr txBox="1"/>
           <p:nvPr/>
         </p:nvSpPr>
         <p:spPr>
           <a:xfrm>
-            <a:off x="777240" y="1755648"/>
-            <a:ext cx="3200400" cy="365760"/>
+            <a:off x="1783080" y="1755648"/>
+            <a:ext cx="2286000" cy="365760"/>
           </a:xfrm>
           <a:prstGeom prst="rect">
             <a:avLst/>
@@ -3858,7 +4429,7 @@
             <a:r>
               <a:rPr sz="1300" b="0">
                 <a:solidFill>
-                  <a:srgbClr val="6B7280"/>
+                  <a:srgbClr val="6B6B6B"/>
                 </a:solidFill>
               </a:rPr>
               <a:t>Blinkit, Jul to Sep 2026</a:t>
@@ -3868,14 +4439,14 @@
       </p:sp>
       <p:sp>
         <p:nvSpPr>
-          <p:cNvPr id="10" name="TextBox 9"/>
+          <p:cNvPr id="11" name="TextBox 10"/>
           <p:cNvSpPr txBox="1"/>
           <p:nvPr/>
         </p:nvSpPr>
         <p:spPr>
           <a:xfrm>
-            <a:off x="777240" y="2057400"/>
-            <a:ext cx="3200400" cy="731520"/>
+            <a:off x="1783080" y="2103120"/>
+            <a:ext cx="2377440" cy="731520"/>
           </a:xfrm>
           <a:prstGeom prst="rect">
             <a:avLst/>
@@ -3894,19 +4465,19 @@
               </a:spcAft>
             </a:pPr>
             <a:r>
-              <a:rPr sz="3200" b="1">
-                <a:solidFill>
-                  <a:srgbClr val="1F4E79"/>
+              <a:rPr sz="2800" b="1">
+                <a:solidFill>
+                  <a:srgbClr val="CC0000"/>
                 </a:solidFill>
               </a:rPr>
-              <a:t>44.4  (±0.5)</a:t>
-            </a:r>
-          </a:p>
-        </p:txBody>
-      </p:sp>
-      <p:sp>
-        <p:nvSpPr>
-          <p:cNvPr id="11" name="Rounded Rectangle 10"/>
+              <a:t>44.4 (±0.5)</a:t>
+            </a:r>
+          </a:p>
+        </p:txBody>
+      </p:sp>
+      <p:sp>
+        <p:nvSpPr>
+          <p:cNvPr id="12" name="Rounded Rectangle 11"/>
           <p:cNvSpPr/>
           <p:nvPr/>
         </p:nvSpPr>
@@ -3921,7 +4492,7 @@
             </a:avLst>
           </a:prstGeom>
           <a:solidFill>
-            <a:srgbClr val="F1F5F9"/>
+            <a:srgbClr val="F2F2F2"/>
           </a:solidFill>
           <a:ln>
             <a:noFill/>
@@ -3950,16 +4521,40 @@
           </a:p>
         </p:txBody>
       </p:sp>
-      <p:sp>
-        <p:nvSpPr>
-          <p:cNvPr id="12" name="TextBox 11"/>
+      <p:pic>
+        <p:nvPicPr>
+          <p:cNvPr id="13" name="Picture 12" descr="instamart.png"/>
+          <p:cNvPicPr>
+            <a:picLocks noChangeAspect="1"/>
+          </p:cNvPicPr>
+          <p:nvPr/>
+        </p:nvPicPr>
+        <p:blipFill>
+          <a:blip r:embed="rId3"/>
+          <a:stretch>
+            <a:fillRect/>
+          </a:stretch>
+        </p:blipFill>
+        <p:spPr>
+          <a:xfrm>
+            <a:off x="4526280" y="1874519"/>
+            <a:ext cx="868680" cy="868680"/>
+          </a:xfrm>
+          <a:prstGeom prst="rect">
+            <a:avLst/>
+          </a:prstGeom>
+        </p:spPr>
+      </p:pic>
+      <p:sp>
+        <p:nvSpPr>
+          <p:cNvPr id="14" name="TextBox 13"/>
           <p:cNvSpPr txBox="1"/>
           <p:nvPr/>
         </p:nvSpPr>
         <p:spPr>
           <a:xfrm>
-            <a:off x="4526279" y="1755648"/>
-            <a:ext cx="3200400" cy="365760"/>
+            <a:off x="5532120" y="1755648"/>
+            <a:ext cx="2286000" cy="365760"/>
           </a:xfrm>
           <a:prstGeom prst="rect">
             <a:avLst/>
@@ -3980,7 +4575,7 @@
             <a:r>
               <a:rPr sz="1300" b="0">
                 <a:solidFill>
-                  <a:srgbClr val="6B7280"/>
+                  <a:srgbClr val="6B6B6B"/>
                 </a:solidFill>
               </a:rPr>
               <a:t>Instamart, Jul to Sep 2026</a:t>
@@ -3990,14 +4585,14 @@
       </p:sp>
       <p:sp>
         <p:nvSpPr>
-          <p:cNvPr id="13" name="TextBox 12"/>
+          <p:cNvPr id="15" name="TextBox 14"/>
           <p:cNvSpPr txBox="1"/>
           <p:nvPr/>
         </p:nvSpPr>
         <p:spPr>
           <a:xfrm>
-            <a:off x="4526279" y="2057400"/>
-            <a:ext cx="3200400" cy="731520"/>
+            <a:off x="5532120" y="2103120"/>
+            <a:ext cx="2377440" cy="731520"/>
           </a:xfrm>
           <a:prstGeom prst="rect">
             <a:avLst/>
@@ -4016,19 +4611,19 @@
               </a:spcAft>
             </a:pPr>
             <a:r>
-              <a:rPr sz="3200" b="1">
-                <a:solidFill>
-                  <a:srgbClr val="1F4E79"/>
+              <a:rPr sz="2800" b="1">
+                <a:solidFill>
+                  <a:srgbClr val="CC0000"/>
                 </a:solidFill>
               </a:rPr>
-              <a:t>43.8  (±1.1)</a:t>
-            </a:r>
-          </a:p>
-        </p:txBody>
-      </p:sp>
-      <p:sp>
-        <p:nvSpPr>
-          <p:cNvPr id="14" name="Rounded Rectangle 13"/>
+              <a:t>43.8 (±1.1)</a:t>
+            </a:r>
+          </a:p>
+        </p:txBody>
+      </p:sp>
+      <p:sp>
+        <p:nvSpPr>
+          <p:cNvPr id="16" name="Rounded Rectangle 15"/>
           <p:cNvSpPr/>
           <p:nvPr/>
         </p:nvSpPr>
@@ -4043,7 +4638,7 @@
             </a:avLst>
           </a:prstGeom>
           <a:solidFill>
-            <a:srgbClr val="F1F5F9"/>
+            <a:srgbClr val="F2F2F2"/>
           </a:solidFill>
           <a:ln>
             <a:noFill/>
@@ -4072,16 +4667,40 @@
           </a:p>
         </p:txBody>
       </p:sp>
-      <p:sp>
-        <p:nvSpPr>
-          <p:cNvPr id="15" name="TextBox 14"/>
+      <p:pic>
+        <p:nvPicPr>
+          <p:cNvPr id="17" name="Picture 16" descr="zepto.png"/>
+          <p:cNvPicPr>
+            <a:picLocks noChangeAspect="1"/>
+          </p:cNvPicPr>
+          <p:nvPr/>
+        </p:nvPicPr>
+        <p:blipFill>
+          <a:blip r:embed="rId4"/>
+          <a:stretch>
+            <a:fillRect/>
+          </a:stretch>
+        </p:blipFill>
+        <p:spPr>
+          <a:xfrm>
+            <a:off x="8275319" y="1874519"/>
+            <a:ext cx="868680" cy="868680"/>
+          </a:xfrm>
+          <a:prstGeom prst="rect">
+            <a:avLst/>
+          </a:prstGeom>
+        </p:spPr>
+      </p:pic>
+      <p:sp>
+        <p:nvSpPr>
+          <p:cNvPr id="18" name="TextBox 17"/>
           <p:cNvSpPr txBox="1"/>
           <p:nvPr/>
         </p:nvSpPr>
         <p:spPr>
           <a:xfrm>
-            <a:off x="8275319" y="1755648"/>
-            <a:ext cx="3200400" cy="365760"/>
+            <a:off x="9281160" y="1755648"/>
+            <a:ext cx="2286000" cy="365760"/>
           </a:xfrm>
           <a:prstGeom prst="rect">
             <a:avLst/>
@@ -4102,7 +4721,7 @@
             <a:r>
               <a:rPr sz="1300" b="0">
                 <a:solidFill>
-                  <a:srgbClr val="6B7280"/>
+                  <a:srgbClr val="6B6B6B"/>
                 </a:solidFill>
               </a:rPr>
               <a:t>Zepto, Jul to Sep 2026</a:t>
@@ -4112,14 +4731,14 @@
       </p:sp>
       <p:sp>
         <p:nvSpPr>
-          <p:cNvPr id="16" name="TextBox 15"/>
+          <p:cNvPr id="19" name="TextBox 18"/>
           <p:cNvSpPr txBox="1"/>
           <p:nvPr/>
         </p:nvSpPr>
         <p:spPr>
           <a:xfrm>
-            <a:off x="8275319" y="2057400"/>
-            <a:ext cx="3200400" cy="731520"/>
+            <a:off x="9281160" y="2103120"/>
+            <a:ext cx="2377440" cy="731520"/>
           </a:xfrm>
           <a:prstGeom prst="rect">
             <a:avLst/>
@@ -4138,26 +4757,26 @@
               </a:spcAft>
             </a:pPr>
             <a:r>
-              <a:rPr sz="3200" b="1">
-                <a:solidFill>
-                  <a:srgbClr val="1F4E79"/>
+              <a:rPr sz="2800" b="1">
+                <a:solidFill>
+                  <a:srgbClr val="CC0000"/>
                 </a:solidFill>
               </a:rPr>
-              <a:t>10.0  (±1.3)</a:t>
+              <a:t>10.0 (±1.3)</a:t>
             </a:r>
           </a:p>
         </p:txBody>
       </p:sp>
       <p:pic>
         <p:nvPicPr>
-          <p:cNvPr id="17" name="Picture 16" descr="deck_latest.png"/>
+          <p:cNvPr id="20" name="Picture 19" descr="deck_latest.png"/>
           <p:cNvPicPr>
             <a:picLocks noChangeAspect="1"/>
           </p:cNvPicPr>
           <p:nvPr/>
         </p:nvPicPr>
         <p:blipFill>
-          <a:blip r:embed="rId2"/>
+          <a:blip r:embed="rId5"/>
           <a:stretch>
             <a:fillRect/>
           </a:stretch>
@@ -4174,7 +4793,7 @@
       </p:pic>
       <p:sp>
         <p:nvSpPr>
-          <p:cNvPr id="18" name="TextBox 17"/>
+          <p:cNvPr id="21" name="TextBox 20"/>
           <p:cNvSpPr txBox="1"/>
           <p:nvPr/>
         </p:nvSpPr>
@@ -4202,7 +4821,7 @@
             <a:r>
               <a:rPr sz="1600" b="0">
                 <a:solidFill>
-                  <a:srgbClr val="222222"/>
+                  <a:srgbClr val="333333"/>
                 </a:solidFill>
               </a:rPr>
               <a:t>The 34.5 point gap: 14.2 from more 5 star reviews at Blinkit, 20.3 from heavier complaints at Zepto.</a:t>
@@ -4217,7 +4836,7 @@
             <a:r>
               <a:rPr sz="1600" b="0">
                 <a:solidFill>
-                  <a:srgbClr val="222222"/>
+                  <a:srgbClr val="333333"/>
                 </a:solidFill>
               </a:rPr>
               <a:t>Biggest complaint gaps: quality and freshness 6.0, missing or wrong items 4.4, support and rider behaviour 3.5 points.</a:t>
@@ -4232,7 +4851,7 @@
             <a:r>
               <a:rPr sz="1600" b="0">
                 <a:solidFill>
-                  <a:srgbClr val="222222"/>
+                  <a:srgbClr val="333333"/>
                 </a:solidFill>
               </a:rPr>
               <a:t>The ranking holds in 7 of 7 quarters when 3 stars count as passive. First place leads by 0.7 points against ±1.2, so treat it as a tie.</a:t>
@@ -4273,7 +4892,7 @@
             <a:avLst/>
           </a:prstGeom>
           <a:solidFill>
-            <a:srgbClr val="1F4E79"/>
+            <a:srgbClr val="CC0000"/>
           </a:solidFill>
           <a:ln>
             <a:noFill/>
@@ -4332,7 +4951,7 @@
             <a:r>
               <a:rPr sz="1200" b="1">
                 <a:solidFill>
-                  <a:srgbClr val="1F4E79"/>
+                  <a:srgbClr val="CC0000"/>
                 </a:solidFill>
               </a:rPr>
               <a:t>NPS TREND</a:t>
@@ -4370,7 +4989,7 @@
             <a:r>
               <a:rPr sz="2400" b="1">
                 <a:solidFill>
-                  <a:srgbClr val="0F2A43"/>
+                  <a:srgbClr val="1A1A1A"/>
                 </a:solidFill>
               </a:rPr>
               <a:t>Blinkit and Instamart stayed between 34 and 56 NPS points for 21 months while Zepto swung from -25 to 42 and ended at 7</a:t>
@@ -4393,7 +5012,7 @@
             <a:avLst/>
           </a:prstGeom>
           <a:solidFill>
-            <a:srgbClr val="BBD3EA"/>
+            <a:srgbClr val="D9D9D9"/>
           </a:solidFill>
           <a:ln>
             <a:noFill/>
@@ -4452,7 +5071,7 @@
             <a:r>
               <a:rPr sz="1000" b="0">
                 <a:solidFill>
-                  <a:srgbClr val="6B7280"/>
+                  <a:srgbClr val="6B6B6B"/>
                 </a:solidFill>
               </a:rPr>
               <a:t>Source: Google Play reviews, India, English, 1,112,946 reviews, Jan 2025 to Sep 2026. Figures from outputs/ in the repo.</a:t>
@@ -4490,7 +5109,7 @@
             <a:r>
               <a:rPr sz="1000" b="0">
                 <a:solidFill>
-                  <a:srgbClr val="6B7280"/>
+                  <a:srgbClr val="6B6B6B"/>
                 </a:solidFill>
               </a:rPr>
               <a:t>3</a:t>
@@ -4576,7 +5195,7 @@
             <a:r>
               <a:rPr sz="1300" b="0">
                 <a:solidFill>
-                  <a:srgbClr val="6B7280"/>
+                  <a:srgbClr val="6B6B6B"/>
                 </a:solidFill>
               </a:rPr>
               <a:t>Best minus worst NPS in each quarter. The gap has not closed.</a:t>
@@ -4617,7 +5236,7 @@
             <a:avLst/>
           </a:prstGeom>
           <a:solidFill>
-            <a:srgbClr val="1F4E79"/>
+            <a:srgbClr val="CC0000"/>
           </a:solidFill>
           <a:ln>
             <a:noFill/>
@@ -4676,7 +5295,7 @@
             <a:r>
               <a:rPr sz="1200" b="1">
                 <a:solidFill>
-                  <a:srgbClr val="1F4E79"/>
+                  <a:srgbClr val="CC0000"/>
                 </a:solidFill>
               </a:rPr>
               <a:t>DRIVER MIX</a:t>
@@ -4714,7 +5333,7 @@
             <a:r>
               <a:rPr sz="2400" b="1">
                 <a:solidFill>
-                  <a:srgbClr val="0F2A43"/>
+                  <a:srgbClr val="1A1A1A"/>
                 </a:solidFill>
               </a:rPr>
               <a:t>Fees and prices lead the complaints at Blinkit (21%) and Instamart (26%), but quality and freshness lead at Zepto (21%)</a:t>
@@ -4737,7 +5356,7 @@
             <a:avLst/>
           </a:prstGeom>
           <a:solidFill>
-            <a:srgbClr val="BBD3EA"/>
+            <a:srgbClr val="D9D9D9"/>
           </a:solidFill>
           <a:ln>
             <a:noFill/>
@@ -4796,7 +5415,7 @@
             <a:r>
               <a:rPr sz="1000" b="0">
                 <a:solidFill>
-                  <a:srgbClr val="6B7280"/>
+                  <a:srgbClr val="6B6B6B"/>
                 </a:solidFill>
               </a:rPr>
               <a:t>Source: Google Play reviews, India, English, 1,112,946 reviews, Jan 2025 to Sep 2026. Figures from outputs/ in the repo.</a:t>
@@ -4834,7 +5453,7 @@
             <a:r>
               <a:rPr sz="1000" b="0">
                 <a:solidFill>
-                  <a:srgbClr val="6B7280"/>
+                  <a:srgbClr val="6B6B6B"/>
                 </a:solidFill>
               </a:rPr>
               <a:t>4</a:t>
@@ -4920,7 +5539,7 @@
             <a:r>
               <a:rPr sz="1200" b="0">
                 <a:solidFill>
-                  <a:srgbClr val="6B7280"/>
+                  <a:srgbClr val="6B6B6B"/>
                 </a:solidFill>
               </a:rPr>
               <a:t>Share of tagged detractor reviews, Jul to Sep 2026.</a:t>
@@ -4958,7 +5577,7 @@
             <a:r>
               <a:rPr sz="1200" b="0">
                 <a:solidFill>
-                  <a:srgbClr val="6B7280"/>
+                  <a:srgbClr val="6B6B6B"/>
                 </a:solidFill>
               </a:rPr>
               <a:t>NPS points lost to each driver, per app (all reviews).</a:t>
@@ -4999,7 +5618,7 @@
             <a:avLst/>
           </a:prstGeom>
           <a:solidFill>
-            <a:srgbClr val="1F4E79"/>
+            <a:srgbClr val="CC0000"/>
           </a:solidFill>
           <a:ln>
             <a:noFill/>
@@ -5058,7 +5677,7 @@
             <a:r>
               <a:rPr sz="1200" b="1">
                 <a:solidFill>
-                  <a:srgbClr val="1F4E79"/>
+                  <a:srgbClr val="CC0000"/>
                 </a:solidFill>
               </a:rPr>
               <a:t>WHERE THE GAP COMES FROM</a:t>
@@ -5096,7 +5715,7 @@
             <a:r>
               <a:rPr sz="2400" b="1">
                 <a:solidFill>
-                  <a:srgbClr val="0F2A43"/>
+                  <a:srgbClr val="1A1A1A"/>
                 </a:solidFill>
               </a:rPr>
               <a:t>Blinkit's 34.5 point lead over Zepto is 14.2 points of 5 star reviews, then 6.0 from quality and freshness and 4.4 from missing or wrong items</a:t>
@@ -5119,7 +5738,7 @@
             <a:avLst/>
           </a:prstGeom>
           <a:solidFill>
-            <a:srgbClr val="BBD3EA"/>
+            <a:srgbClr val="D9D9D9"/>
           </a:solidFill>
           <a:ln>
             <a:noFill/>
@@ -5178,7 +5797,7 @@
             <a:r>
               <a:rPr sz="1000" b="0">
                 <a:solidFill>
-                  <a:srgbClr val="6B7280"/>
+                  <a:srgbClr val="6B6B6B"/>
                 </a:solidFill>
               </a:rPr>
               <a:t>Source: Google Play reviews, India, English, 1,112,946 reviews. Bars sum to the gap; driver bars carry up to ±1.0 points of sampling error.</a:t>
@@ -5216,7 +5835,7 @@
             <a:r>
               <a:rPr sz="1000" b="0">
                 <a:solidFill>
-                  <a:srgbClr val="6B7280"/>
+                  <a:srgbClr val="6B6B6B"/>
                 </a:solidFill>
               </a:rPr>
               <a:t>5</a:t>
@@ -5281,7 +5900,7 @@
             <a:avLst/>
           </a:prstGeom>
           <a:solidFill>
-            <a:srgbClr val="1F4E79"/>
+            <a:srgbClr val="CC0000"/>
           </a:solidFill>
           <a:ln>
             <a:noFill/>
@@ -5340,7 +5959,7 @@
             <a:r>
               <a:rPr sz="1200" b="1">
                 <a:solidFill>
-                  <a:srgbClr val="1F4E79"/>
+                  <a:srgbClr val="CC0000"/>
                 </a:solidFill>
               </a:rPr>
               <a:t>RECOMMENDATIONS</a:t>
@@ -5378,7 +5997,7 @@
             <a:r>
               <a:rPr sz="2400" b="1">
                 <a:solidFill>
-                  <a:srgbClr val="0F2A43"/>
+                  <a:srgbClr val="1A1A1A"/>
                 </a:solidFill>
               </a:rPr>
               <a:t>Fixing quality and freshness, missing or wrong items and support and rider behaviour at Zepto is worth up to 13.8 of the 34.5 NPS points to Blinkit</a:t>
@@ -5401,7 +6020,7 @@
             <a:avLst/>
           </a:prstGeom>
           <a:solidFill>
-            <a:srgbClr val="BBD3EA"/>
+            <a:srgbClr val="D9D9D9"/>
           </a:solidFill>
           <a:ln>
             <a:noFill/>
@@ -5460,7 +6079,7 @@
             <a:r>
               <a:rPr sz="1000" b="0">
                 <a:solidFill>
-                  <a:srgbClr val="6B7280"/>
+                  <a:srgbClr val="6B6B6B"/>
                 </a:solidFill>
               </a:rPr>
               <a:t>Source: Google Play reviews, India, English, 1,112,946 reviews, Jan 2025 to Sep 2026. Figures from outputs/ in the repo.</a:t>
@@ -5498,7 +6117,7 @@
             <a:r>
               <a:rPr sz="1000" b="0">
                 <a:solidFill>
-                  <a:srgbClr val="6B7280"/>
+                  <a:srgbClr val="6B6B6B"/>
                 </a:solidFill>
               </a:rPr>
               <a:t>6</a:t>
@@ -5523,7 +6142,7 @@
             </a:avLst>
           </a:prstGeom>
           <a:solidFill>
-            <a:srgbClr val="F1F5F9"/>
+            <a:srgbClr val="F2F2F2"/>
           </a:solidFill>
           <a:ln>
             <a:noFill/>
@@ -5582,7 +6201,7 @@
             <a:r>
               <a:rPr sz="3800" b="1">
                 <a:solidFill>
-                  <a:srgbClr val="1F4E79"/>
+                  <a:srgbClr val="CC0000"/>
                 </a:solidFill>
               </a:rPr>
               <a:t>6.0</a:t>
@@ -5620,7 +6239,7 @@
             <a:r>
               <a:rPr sz="1600" b="1">
                 <a:solidFill>
-                  <a:srgbClr val="222222"/>
+                  <a:srgbClr val="333333"/>
                 </a:solidFill>
               </a:rPr>
               <a:t>1. Quality and freshness (±1.0)</a:t>
@@ -5658,7 +6277,7 @@
             <a:r>
               <a:rPr sz="1250" b="0">
                 <a:solidFill>
-                  <a:srgbClr val="222222"/>
+                  <a:srgbClr val="333333"/>
                 </a:solidFill>
               </a:rPr>
               <a:t>Check expiry and condition of perishables at packing, and pull items that get repeat complaints.</a:t>
@@ -5683,7 +6302,7 @@
             </a:avLst>
           </a:prstGeom>
           <a:solidFill>
-            <a:srgbClr val="F1F5F9"/>
+            <a:srgbClr val="F2F2F2"/>
           </a:solidFill>
           <a:ln>
             <a:noFill/>
@@ -5742,7 +6361,7 @@
             <a:r>
               <a:rPr sz="3800" b="1">
                 <a:solidFill>
-                  <a:srgbClr val="1F4E79"/>
+                  <a:srgbClr val="CC0000"/>
                 </a:solidFill>
               </a:rPr>
               <a:t>4.4</a:t>
@@ -5780,7 +6399,7 @@
             <a:r>
               <a:rPr sz="1600" b="1">
                 <a:solidFill>
-                  <a:srgbClr val="222222"/>
+                  <a:srgbClr val="333333"/>
                 </a:solidFill>
               </a:rPr>
               <a:t>2. Missing or wrong items (±0.9)</a:t>
@@ -5818,7 +6437,7 @@
             <a:r>
               <a:rPr sz="1250" b="0">
                 <a:solidFill>
-                  <a:srgbClr val="222222"/>
+                  <a:srgbClr val="333333"/>
                 </a:solidFill>
               </a:rPr>
               <a:t>Add a pick and pack check, and require proof of drop before an order can be marked delivered.</a:t>
@@ -5843,7 +6462,7 @@
             </a:avLst>
           </a:prstGeom>
           <a:solidFill>
-            <a:srgbClr val="F1F5F9"/>
+            <a:srgbClr val="F2F2F2"/>
           </a:solidFill>
           <a:ln>
             <a:noFill/>
@@ -5902,7 +6521,7 @@
             <a:r>
               <a:rPr sz="3800" b="1">
                 <a:solidFill>
-                  <a:srgbClr val="1F4E79"/>
+                  <a:srgbClr val="CC0000"/>
                 </a:solidFill>
               </a:rPr>
               <a:t>3.5</a:t>
@@ -5940,7 +6559,7 @@
             <a:r>
               <a:rPr sz="1600" b="1">
                 <a:solidFill>
-                  <a:srgbClr val="222222"/>
+                  <a:srgbClr val="333333"/>
                 </a:solidFill>
               </a:rPr>
               <a:t>3. Support and rider behaviour (±0.9)</a:t>
@@ -5978,7 +6597,7 @@
             <a:r>
               <a:rPr sz="1250" b="0">
                 <a:solidFill>
-                  <a:srgbClr val="222222"/>
+                  <a:srgbClr val="333333"/>
                 </a:solidFill>
               </a:rPr>
               <a:t>Give a human agent path after the bot, shorten the first human reply, and coach riders on conduct.</a:t>
@@ -6040,7 +6659,7 @@
             <a:r>
               <a:rPr sz="1200" b="0">
                 <a:solidFill>
-                  <a:srgbClr val="6B7280"/>
+                  <a:srgbClr val="6B6B6B"/>
                 </a:solidFill>
               </a:rPr>
               <a:t>Points at stake are the extra NPS points Zepto loses to each driver compared with Blinkit in Jul to Sep 2026. Matching the leader's rate would recover them. The ± is sampling error from the tagged sample.</a:t>
@@ -6081,7 +6700,7 @@
             <a:avLst/>
           </a:prstGeom>
           <a:solidFill>
-            <a:srgbClr val="1F4E79"/>
+            <a:srgbClr val="CC0000"/>
           </a:solidFill>
           <a:ln>
             <a:noFill/>
@@ -6140,7 +6759,7 @@
             <a:r>
               <a:rPr sz="1200" b="1">
                 <a:solidFill>
-                  <a:srgbClr val="1F4E79"/>
+                  <a:srgbClr val="CC0000"/>
                 </a:solidFill>
               </a:rPr>
               <a:t>METHOD AND LIMITATIONS</a:t>
@@ -6178,7 +6797,7 @@
             <a:r>
               <a:rPr sz="2400" b="1">
                 <a:solidFill>
-                  <a:srgbClr val="0F2A43"/>
+                  <a:srgbClr val="1A1A1A"/>
                 </a:solidFill>
               </a:rPr>
               <a:t>The numbers are a review based proxy for NPS, tagged by a model and checked for consistency, not yet against human labels</a:t>
@@ -6201,7 +6820,7 @@
             <a:avLst/>
           </a:prstGeom>
           <a:solidFill>
-            <a:srgbClr val="BBD3EA"/>
+            <a:srgbClr val="D9D9D9"/>
           </a:solidFill>
           <a:ln>
             <a:noFill/>
@@ -6260,7 +6879,7 @@
             <a:r>
               <a:rPr sz="1000" b="0">
                 <a:solidFill>
-                  <a:srgbClr val="6B7280"/>
+                  <a:srgbClr val="6B6B6B"/>
                 </a:solidFill>
               </a:rPr>
               <a:t>Source: Google Play reviews, India, English, 1,112,946 reviews, Jan 2025 to Sep 2026. Figures from outputs/ in the repo.</a:t>
@@ -6298,7 +6917,7 @@
             <a:r>
               <a:rPr sz="1000" b="0">
                 <a:solidFill>
-                  <a:srgbClr val="6B7280"/>
+                  <a:srgbClr val="6B6B6B"/>
                 </a:solidFill>
               </a:rPr>
               <a:t>7</a:t>
@@ -6336,7 +6955,7 @@
             <a:r>
               <a:rPr sz="1800" b="1">
                 <a:solidFill>
-                  <a:srgbClr val="1F4E79"/>
+                  <a:srgbClr val="CC0000"/>
                 </a:solidFill>
               </a:rPr>
               <a:t>Method</a:t>
@@ -6374,7 +6993,7 @@
             <a:r>
               <a:rPr sz="1500" b="0">
                 <a:solidFill>
-                  <a:srgbClr val="222222"/>
+                  <a:srgbClr val="333333"/>
                 </a:solidFill>
               </a:rPr>
               <a:t>Promoter 5 stars, passive 4, detractor 1 to 3. 1,112,946 reviews over 21 months.</a:t>
@@ -6389,7 +7008,7 @@
             <a:r>
               <a:rPr sz="1500" b="0">
                 <a:solidFill>
-                  <a:srgbClr val="222222"/>
+                  <a:srgbClr val="333333"/>
                 </a:solidFill>
               </a:rPr>
               <a:t>21,000 detractor reviews (1,000 per app per quarter, 4 or more words) tagged to 8 complaint drivers by Claude in an interactive session.</a:t>
@@ -6404,7 +7023,7 @@
             <a:r>
               <a:rPr sz="1500" b="0">
                 <a:solidFill>
-                  <a:srgbClr val="222222"/>
+                  <a:srgbClr val="333333"/>
                 </a:solidFill>
               </a:rPr>
               <a:t>Two independent tagging passes agreed on 96% of 100 reviews (kappa 0.954).</a:t>
@@ -6419,7 +7038,7 @@
             <a:r>
               <a:rPr sz="1500" b="0">
                 <a:solidFill>
-                  <a:srgbClr val="222222"/>
+                  <a:srgbClr val="333333"/>
                 </a:solidFill>
               </a:rPr>
               <a:t>A keyword list agrees with the model tags on 52% (kappa 0.46).</a:t>
@@ -6434,7 +7053,7 @@
             <a:r>
               <a:rPr sz="1500" b="0">
                 <a:solidFill>
-                  <a:srgbClr val="222222"/>
+                  <a:srgbClr val="333333"/>
                 </a:solidFill>
               </a:rPr>
               <a:t>The waterfall splits the 34.5 point gap exactly.</a:t>
@@ -6496,7 +7115,7 @@
             <a:r>
               <a:rPr sz="1800" b="1">
                 <a:solidFill>
-                  <a:srgbClr val="1F4E79"/>
+                  <a:srgbClr val="CC0000"/>
                 </a:solidFill>
               </a:rPr>
               <a:t>Limitations</a:t>
@@ -6534,7 +7153,7 @@
             <a:r>
               <a:rPr sz="1300" b="0">
                 <a:solidFill>
-                  <a:srgbClr val="222222"/>
+                  <a:srgbClr val="333333"/>
                 </a:solidFill>
               </a:rPr>
               <a:t>Review based proxy, not survey NPS. Reviewers skew negative.</a:t>
@@ -6549,7 +7168,7 @@
             <a:r>
               <a:rPr sz="1300" b="0">
                 <a:solidFill>
-                  <a:srgbClr val="222222"/>
+                  <a:srgbClr val="333333"/>
                 </a:solidFill>
               </a:rPr>
               <a:t>Play Store and English only. Tags not yet checked against human labels.</a:t>
@@ -6564,7 +7183,7 @@
             <a:r>
               <a:rPr sz="1300" b="0">
                 <a:solidFill>
-                  <a:srgbClr val="222222"/>
+                  <a:srgbClr val="333333"/>
                 </a:solidFill>
               </a:rPr>
               <a:t>Driver bars carry up to ±1.0 points of sampling error, and Blinkit's lead over second place is inside its margin.</a:t>

</xml_diff>

<commit_message>
remove the red bar above the cover title
</commit_message>
<xml_diff>
--- a/deck/qcom_nps.pptx
+++ b/deck/qcom_nps.pptx
@@ -3494,20 +3494,225 @@
       </p:sp>
       <p:sp>
         <p:nvSpPr>
-          <p:cNvPr id="12" name="Rectangle 11"/>
+          <p:cNvPr id="12" name="TextBox 11"/>
+          <p:cNvSpPr txBox="1"/>
+          <p:nvPr/>
+        </p:nvSpPr>
+        <p:spPr>
+          <a:xfrm>
+            <a:off x="731520" y="1097280"/>
+            <a:ext cx="6858000" cy="365760"/>
+          </a:xfrm>
+          <a:prstGeom prst="rect">
+            <a:avLst/>
+          </a:prstGeom>
+          <a:noFill/>
+        </p:spPr>
+        <p:txBody>
+          <a:bodyPr wrap="square">
+            <a:spAutoFit/>
+          </a:bodyPr>
+          <a:lstStyle/>
+          <a:p>
+            <a:pPr>
+              <a:spcAft>
+                <a:spcPts val="800"/>
+              </a:spcAft>
+            </a:pPr>
+            <a:r>
+              <a:rPr sz="1300" b="1">
+                <a:solidFill>
+                  <a:srgbClr val="CC0000"/>
+                </a:solidFill>
+              </a:rPr>
+              <a:t>CASE STUDY  |  QUICK COMMERCE</a:t>
+            </a:r>
+          </a:p>
+        </p:txBody>
+      </p:sp>
+      <p:sp>
+        <p:nvSpPr>
+          <p:cNvPr id="13" name="TextBox 12"/>
+          <p:cNvSpPr txBox="1"/>
+          <p:nvPr/>
+        </p:nvSpPr>
+        <p:spPr>
+          <a:xfrm>
+            <a:off x="731520" y="1508760"/>
+            <a:ext cx="7223760" cy="2011680"/>
+          </a:xfrm>
+          <a:prstGeom prst="rect">
+            <a:avLst/>
+          </a:prstGeom>
+          <a:noFill/>
+        </p:spPr>
+        <p:txBody>
+          <a:bodyPr wrap="square">
+            <a:spAutoFit/>
+          </a:bodyPr>
+          <a:lstStyle/>
+          <a:p>
+            <a:pPr>
+              <a:spcAft>
+                <a:spcPts val="800"/>
+              </a:spcAft>
+            </a:pPr>
+            <a:r>
+              <a:rPr sz="4600" b="1">
+                <a:solidFill>
+                  <a:srgbClr val="1A1A1A"/>
+                </a:solidFill>
+              </a:rPr>
+              <a:t>Quick-Commerce</a:t>
+            </a:r>
+          </a:p>
+          <a:p>
+            <a:pPr>
+              <a:spcAft>
+                <a:spcPts val="800"/>
+              </a:spcAft>
+            </a:pPr>
+            <a:r>
+              <a:rPr sz="4600" b="1">
+                <a:solidFill>
+                  <a:srgbClr val="1A1A1A"/>
+                </a:solidFill>
+              </a:rPr>
+              <a:t>NPS Benchmark</a:t>
+            </a:r>
+          </a:p>
+        </p:txBody>
+      </p:sp>
+      <p:sp>
+        <p:nvSpPr>
+          <p:cNvPr id="14" name="TextBox 13"/>
+          <p:cNvSpPr txBox="1"/>
+          <p:nvPr/>
+        </p:nvSpPr>
+        <p:spPr>
+          <a:xfrm>
+            <a:off x="731520" y="3383280"/>
+            <a:ext cx="6858000" cy="1097280"/>
+          </a:xfrm>
+          <a:prstGeom prst="rect">
+            <a:avLst/>
+          </a:prstGeom>
+          <a:noFill/>
+        </p:spPr>
+        <p:txBody>
+          <a:bodyPr wrap="square">
+            <a:spAutoFit/>
+          </a:bodyPr>
+          <a:lstStyle/>
+          <a:p>
+            <a:pPr>
+              <a:spcAft>
+                <a:spcPts val="800"/>
+              </a:spcAft>
+            </a:pPr>
+            <a:r>
+              <a:rPr sz="2000" b="0">
+                <a:solidFill>
+                  <a:srgbClr val="6B6B6B"/>
+                </a:solidFill>
+              </a:rPr>
+              <a:t>What 1.1 million Google Play reviews say about Blinkit, Zepto and Swiggy Instamart</a:t>
+            </a:r>
+          </a:p>
+        </p:txBody>
+      </p:sp>
+      <p:sp>
+        <p:nvSpPr>
+          <p:cNvPr id="15" name="TextBox 14"/>
+          <p:cNvSpPr txBox="1"/>
+          <p:nvPr/>
+        </p:nvSpPr>
+        <p:spPr>
+          <a:xfrm>
+            <a:off x="731520" y="4434840"/>
+            <a:ext cx="3657600" cy="274320"/>
+          </a:xfrm>
+          <a:prstGeom prst="rect">
+            <a:avLst/>
+          </a:prstGeom>
+          <a:noFill/>
+        </p:spPr>
+        <p:txBody>
+          <a:bodyPr wrap="square">
+            <a:spAutoFit/>
+          </a:bodyPr>
+          <a:lstStyle/>
+          <a:p>
+            <a:pPr>
+              <a:spcAft>
+                <a:spcPts val="800"/>
+              </a:spcAft>
+            </a:pPr>
+            <a:r>
+              <a:rPr sz="1100" b="1">
+                <a:solidFill>
+                  <a:srgbClr val="6B6B6B"/>
+                </a:solidFill>
+              </a:rPr>
+              <a:t>APPS COMPARED</a:t>
+            </a:r>
+          </a:p>
+        </p:txBody>
+      </p:sp>
+      <p:sp>
+        <p:nvSpPr>
+          <p:cNvPr id="16" name="TextBox 15"/>
+          <p:cNvSpPr txBox="1"/>
+          <p:nvPr/>
+        </p:nvSpPr>
+        <p:spPr>
+          <a:xfrm>
+            <a:off x="5120640" y="4434840"/>
+            <a:ext cx="2743200" cy="274320"/>
+          </a:xfrm>
+          <a:prstGeom prst="rect">
+            <a:avLst/>
+          </a:prstGeom>
+          <a:noFill/>
+        </p:spPr>
+        <p:txBody>
+          <a:bodyPr wrap="square">
+            <a:spAutoFit/>
+          </a:bodyPr>
+          <a:lstStyle/>
+          <a:p>
+            <a:pPr>
+              <a:spcAft>
+                <a:spcPts val="800"/>
+              </a:spcAft>
+            </a:pPr>
+            <a:r>
+              <a:rPr sz="1100" b="1">
+                <a:solidFill>
+                  <a:srgbClr val="6B6B6B"/>
+                </a:solidFill>
+              </a:rPr>
+              <a:t>DATA SOURCE</a:t>
+            </a:r>
+          </a:p>
+        </p:txBody>
+      </p:sp>
+      <p:sp>
+        <p:nvSpPr>
+          <p:cNvPr id="17" name="Rectangle 16"/>
           <p:cNvSpPr/>
           <p:nvPr/>
         </p:nvSpPr>
         <p:spPr>
           <a:xfrm>
-            <a:off x="731520" y="914400"/>
-            <a:ext cx="822960" cy="82296"/>
+            <a:off x="4754880" y="4754880"/>
+            <a:ext cx="13716" cy="1280160"/>
           </a:xfrm>
           <a:prstGeom prst="rect">
             <a:avLst/>
           </a:prstGeom>
           <a:solidFill>
-            <a:srgbClr val="CC0000"/>
+            <a:srgbClr val="D9D9D9"/>
           </a:solidFill>
           <a:ln>
             <a:noFill/>
@@ -3536,258 +3741,9 @@
           </a:p>
         </p:txBody>
       </p:sp>
-      <p:sp>
-        <p:nvSpPr>
-          <p:cNvPr id="13" name="TextBox 12"/>
-          <p:cNvSpPr txBox="1"/>
-          <p:nvPr/>
-        </p:nvSpPr>
-        <p:spPr>
-          <a:xfrm>
-            <a:off x="731520" y="1097280"/>
-            <a:ext cx="6858000" cy="365760"/>
-          </a:xfrm>
-          <a:prstGeom prst="rect">
-            <a:avLst/>
-          </a:prstGeom>
-          <a:noFill/>
-        </p:spPr>
-        <p:txBody>
-          <a:bodyPr wrap="square">
-            <a:spAutoFit/>
-          </a:bodyPr>
-          <a:lstStyle/>
-          <a:p>
-            <a:pPr>
-              <a:spcAft>
-                <a:spcPts val="800"/>
-              </a:spcAft>
-            </a:pPr>
-            <a:r>
-              <a:rPr sz="1300" b="1">
-                <a:solidFill>
-                  <a:srgbClr val="CC0000"/>
-                </a:solidFill>
-              </a:rPr>
-              <a:t>CASE STUDY  |  QUICK COMMERCE</a:t>
-            </a:r>
-          </a:p>
-        </p:txBody>
-      </p:sp>
-      <p:sp>
-        <p:nvSpPr>
-          <p:cNvPr id="14" name="TextBox 13"/>
-          <p:cNvSpPr txBox="1"/>
-          <p:nvPr/>
-        </p:nvSpPr>
-        <p:spPr>
-          <a:xfrm>
-            <a:off x="731520" y="1508760"/>
-            <a:ext cx="7223760" cy="2011680"/>
-          </a:xfrm>
-          <a:prstGeom prst="rect">
-            <a:avLst/>
-          </a:prstGeom>
-          <a:noFill/>
-        </p:spPr>
-        <p:txBody>
-          <a:bodyPr wrap="square">
-            <a:spAutoFit/>
-          </a:bodyPr>
-          <a:lstStyle/>
-          <a:p>
-            <a:pPr>
-              <a:spcAft>
-                <a:spcPts val="800"/>
-              </a:spcAft>
-            </a:pPr>
-            <a:r>
-              <a:rPr sz="4600" b="1">
-                <a:solidFill>
-                  <a:srgbClr val="1A1A1A"/>
-                </a:solidFill>
-              </a:rPr>
-              <a:t>Quick-Commerce</a:t>
-            </a:r>
-          </a:p>
-          <a:p>
-            <a:pPr>
-              <a:spcAft>
-                <a:spcPts val="800"/>
-              </a:spcAft>
-            </a:pPr>
-            <a:r>
-              <a:rPr sz="4600" b="1">
-                <a:solidFill>
-                  <a:srgbClr val="1A1A1A"/>
-                </a:solidFill>
-              </a:rPr>
-              <a:t>NPS Benchmark</a:t>
-            </a:r>
-          </a:p>
-        </p:txBody>
-      </p:sp>
-      <p:sp>
-        <p:nvSpPr>
-          <p:cNvPr id="15" name="TextBox 14"/>
-          <p:cNvSpPr txBox="1"/>
-          <p:nvPr/>
-        </p:nvSpPr>
-        <p:spPr>
-          <a:xfrm>
-            <a:off x="731520" y="3383280"/>
-            <a:ext cx="6858000" cy="1097280"/>
-          </a:xfrm>
-          <a:prstGeom prst="rect">
-            <a:avLst/>
-          </a:prstGeom>
-          <a:noFill/>
-        </p:spPr>
-        <p:txBody>
-          <a:bodyPr wrap="square">
-            <a:spAutoFit/>
-          </a:bodyPr>
-          <a:lstStyle/>
-          <a:p>
-            <a:pPr>
-              <a:spcAft>
-                <a:spcPts val="800"/>
-              </a:spcAft>
-            </a:pPr>
-            <a:r>
-              <a:rPr sz="2000" b="0">
-                <a:solidFill>
-                  <a:srgbClr val="6B6B6B"/>
-                </a:solidFill>
-              </a:rPr>
-              <a:t>What 1.1 million Google Play reviews say about Blinkit, Zepto and Swiggy Instamart</a:t>
-            </a:r>
-          </a:p>
-        </p:txBody>
-      </p:sp>
-      <p:sp>
-        <p:nvSpPr>
-          <p:cNvPr id="16" name="TextBox 15"/>
-          <p:cNvSpPr txBox="1"/>
-          <p:nvPr/>
-        </p:nvSpPr>
-        <p:spPr>
-          <a:xfrm>
-            <a:off x="731520" y="4434840"/>
-            <a:ext cx="3657600" cy="274320"/>
-          </a:xfrm>
-          <a:prstGeom prst="rect">
-            <a:avLst/>
-          </a:prstGeom>
-          <a:noFill/>
-        </p:spPr>
-        <p:txBody>
-          <a:bodyPr wrap="square">
-            <a:spAutoFit/>
-          </a:bodyPr>
-          <a:lstStyle/>
-          <a:p>
-            <a:pPr>
-              <a:spcAft>
-                <a:spcPts val="800"/>
-              </a:spcAft>
-            </a:pPr>
-            <a:r>
-              <a:rPr sz="1100" b="1">
-                <a:solidFill>
-                  <a:srgbClr val="6B6B6B"/>
-                </a:solidFill>
-              </a:rPr>
-              <a:t>APPS COMPARED</a:t>
-            </a:r>
-          </a:p>
-        </p:txBody>
-      </p:sp>
-      <p:sp>
-        <p:nvSpPr>
-          <p:cNvPr id="17" name="TextBox 16"/>
-          <p:cNvSpPr txBox="1"/>
-          <p:nvPr/>
-        </p:nvSpPr>
-        <p:spPr>
-          <a:xfrm>
-            <a:off x="5120640" y="4434840"/>
-            <a:ext cx="2743200" cy="274320"/>
-          </a:xfrm>
-          <a:prstGeom prst="rect">
-            <a:avLst/>
-          </a:prstGeom>
-          <a:noFill/>
-        </p:spPr>
-        <p:txBody>
-          <a:bodyPr wrap="square">
-            <a:spAutoFit/>
-          </a:bodyPr>
-          <a:lstStyle/>
-          <a:p>
-            <a:pPr>
-              <a:spcAft>
-                <a:spcPts val="800"/>
-              </a:spcAft>
-            </a:pPr>
-            <a:r>
-              <a:rPr sz="1100" b="1">
-                <a:solidFill>
-                  <a:srgbClr val="6B6B6B"/>
-                </a:solidFill>
-              </a:rPr>
-              <a:t>DATA SOURCE</a:t>
-            </a:r>
-          </a:p>
-        </p:txBody>
-      </p:sp>
-      <p:sp>
-        <p:nvSpPr>
-          <p:cNvPr id="18" name="Rectangle 17"/>
-          <p:cNvSpPr/>
-          <p:nvPr/>
-        </p:nvSpPr>
-        <p:spPr>
-          <a:xfrm>
-            <a:off x="4754880" y="4754880"/>
-            <a:ext cx="13716" cy="1280160"/>
-          </a:xfrm>
-          <a:prstGeom prst="rect">
-            <a:avLst/>
-          </a:prstGeom>
-          <a:solidFill>
-            <a:srgbClr val="D9D9D9"/>
-          </a:solidFill>
-          <a:ln>
-            <a:noFill/>
-          </a:ln>
-          <a:effectLst/>
-        </p:spPr>
-        <p:style>
-          <a:lnRef idx="1">
-            <a:schemeClr val="accent1"/>
-          </a:lnRef>
-          <a:fillRef idx="3">
-            <a:schemeClr val="accent1"/>
-          </a:fillRef>
-          <a:effectRef idx="2">
-            <a:schemeClr val="accent1"/>
-          </a:effectRef>
-          <a:fontRef idx="minor">
-            <a:schemeClr val="lt1"/>
-          </a:fontRef>
-        </p:style>
-        <p:txBody>
-          <a:bodyPr rtlCol="0" anchor="ctr"/>
-          <a:lstStyle/>
-          <a:p>
-            <a:pPr algn="ctr"/>
-          </a:p>
-        </p:txBody>
-      </p:sp>
       <p:pic>
         <p:nvPicPr>
-          <p:cNvPr id="19" name="Picture 18" descr="blinkit.png"/>
+          <p:cNvPr id="18" name="Picture 17" descr="blinkit.png"/>
           <p:cNvPicPr>
             <a:picLocks noChangeAspect="1"/>
           </p:cNvPicPr>
@@ -3811,7 +3767,7 @@
       </p:pic>
       <p:sp>
         <p:nvSpPr>
-          <p:cNvPr id="20" name="TextBox 19"/>
+          <p:cNvPr id="19" name="TextBox 18"/>
           <p:cNvSpPr txBox="1"/>
           <p:nvPr/>
         </p:nvSpPr>
@@ -3849,7 +3805,7 @@
       </p:sp>
       <p:pic>
         <p:nvPicPr>
-          <p:cNvPr id="21" name="Picture 20" descr="zepto.png"/>
+          <p:cNvPr id="20" name="Picture 19" descr="zepto.png"/>
           <p:cNvPicPr>
             <a:picLocks noChangeAspect="1"/>
           </p:cNvPicPr>
@@ -3873,7 +3829,7 @@
       </p:pic>
       <p:sp>
         <p:nvSpPr>
-          <p:cNvPr id="22" name="TextBox 21"/>
+          <p:cNvPr id="21" name="TextBox 20"/>
           <p:cNvSpPr txBox="1"/>
           <p:nvPr/>
         </p:nvSpPr>
@@ -3911,7 +3867,7 @@
       </p:sp>
       <p:pic>
         <p:nvPicPr>
-          <p:cNvPr id="23" name="Picture 22" descr="instamart.png"/>
+          <p:cNvPr id="22" name="Picture 21" descr="instamart.png"/>
           <p:cNvPicPr>
             <a:picLocks noChangeAspect="1"/>
           </p:cNvPicPr>
@@ -3935,7 +3891,7 @@
       </p:pic>
       <p:sp>
         <p:nvSpPr>
-          <p:cNvPr id="24" name="TextBox 23"/>
+          <p:cNvPr id="23" name="TextBox 22"/>
           <p:cNvSpPr txBox="1"/>
           <p:nvPr/>
         </p:nvSpPr>
@@ -3973,7 +3929,7 @@
       </p:sp>
       <p:pic>
         <p:nvPicPr>
-          <p:cNvPr id="25" name="Picture 24" descr="googleplay.png"/>
+          <p:cNvPr id="24" name="Picture 23" descr="googleplay.png"/>
           <p:cNvPicPr>
             <a:picLocks noChangeAspect="1"/>
           </p:cNvPicPr>
@@ -3997,7 +3953,7 @@
       </p:pic>
       <p:sp>
         <p:nvSpPr>
-          <p:cNvPr id="26" name="TextBox 25"/>
+          <p:cNvPr id="25" name="TextBox 24"/>
           <p:cNvSpPr txBox="1"/>
           <p:nvPr/>
         </p:nvSpPr>
@@ -4035,7 +3991,7 @@
       </p:sp>
       <p:sp>
         <p:nvSpPr>
-          <p:cNvPr id="27" name="TextBox 26"/>
+          <p:cNvPr id="26" name="TextBox 25"/>
           <p:cNvSpPr txBox="1"/>
           <p:nvPr/>
         </p:nvSpPr>

</xml_diff>